<commit_message>
docs(release): publish Slides-verified pitch and final live evidence
</commit_message>
<xml_diff>
--- a/apps/web/public/downloads/arkiv-graph-pitch.pptx
+++ b/apps/web/public/downloads/arkiv-graph-pitch.pptx
@@ -2,20 +2,20 @@
 <file path=ppt/presentation.xml><?xml version="1.0" encoding="utf-8"?>
 <p:presentation xmlns:p="http://schemas.openxmlformats.org/presentationml/2006/main">
   <p:sldMasterIdLst>
-    <p:sldMasterId xmlns:r="http://schemas.openxmlformats.org/officeDocument/2006/relationships" id="2147483648" r:id="Rdad184e87a2d4607"/>
+    <p:sldMasterId xmlns:r="http://schemas.openxmlformats.org/officeDocument/2006/relationships" id="2147483648" r:id="R4e83e70411ca4640"/>
   </p:sldMasterIdLst>
   <p:notesMasterIdLst>
-    <p:notesMasterId xmlns:r="http://schemas.openxmlformats.org/officeDocument/2006/relationships" r:id="Rc75d353659194430"/>
+    <p:notesMasterId xmlns:r="http://schemas.openxmlformats.org/officeDocument/2006/relationships" r:id="R342e4f5ac09541c2"/>
   </p:notesMasterIdLst>
   <p:sldIdLst>
-    <p:sldId xmlns:r="http://schemas.openxmlformats.org/officeDocument/2006/relationships" id="256" r:id="Rbdc334da814b4d58"/>
-    <p:sldId xmlns:r="http://schemas.openxmlformats.org/officeDocument/2006/relationships" id="257" r:id="R217cfba400234a8d"/>
-    <p:sldId xmlns:r="http://schemas.openxmlformats.org/officeDocument/2006/relationships" id="258" r:id="R0a5e49f6fb864946"/>
-    <p:sldId xmlns:r="http://schemas.openxmlformats.org/officeDocument/2006/relationships" id="259" r:id="R0f7b81a90d5e4f0c"/>
-    <p:sldId xmlns:r="http://schemas.openxmlformats.org/officeDocument/2006/relationships" id="260" r:id="Rb643b499b4e14592"/>
-    <p:sldId xmlns:r="http://schemas.openxmlformats.org/officeDocument/2006/relationships" id="261" r:id="Rb1e36b3981d14c7d"/>
-    <p:sldId xmlns:r="http://schemas.openxmlformats.org/officeDocument/2006/relationships" id="262" r:id="R010840df0a494860"/>
-    <p:sldId xmlns:r="http://schemas.openxmlformats.org/officeDocument/2006/relationships" id="263" r:id="R8d8ec7a296244ed6"/>
+    <p:sldId xmlns:r="http://schemas.openxmlformats.org/officeDocument/2006/relationships" id="256" r:id="R3467675ed2ed4d6c"/>
+    <p:sldId xmlns:r="http://schemas.openxmlformats.org/officeDocument/2006/relationships" id="257" r:id="Rf1f736b88e624c38"/>
+    <p:sldId xmlns:r="http://schemas.openxmlformats.org/officeDocument/2006/relationships" id="258" r:id="R784981ff6a9a49c4"/>
+    <p:sldId xmlns:r="http://schemas.openxmlformats.org/officeDocument/2006/relationships" id="259" r:id="Rcf9049d498814e9e"/>
+    <p:sldId xmlns:r="http://schemas.openxmlformats.org/officeDocument/2006/relationships" id="260" r:id="R1ce55aa065484062"/>
+    <p:sldId xmlns:r="http://schemas.openxmlformats.org/officeDocument/2006/relationships" id="261" r:id="Rc11ac4fed5dc40d2"/>
+    <p:sldId xmlns:r="http://schemas.openxmlformats.org/officeDocument/2006/relationships" id="262" r:id="R0d6af6566c8c4ce6"/>
+    <p:sldId xmlns:r="http://schemas.openxmlformats.org/officeDocument/2006/relationships" id="263" r:id="R06da28804a8c4c7e"/>
   </p:sldIdLst>
   <p:sldSz cx="18288000" cy="10287000"/>
   <p:notesSz cx="6858000" cy="9144000"/>
@@ -986,7 +986,7 @@
           <p:cNvPr id="3" name="Title">
             <a:extLst xmlns:a="http://schemas.openxmlformats.org/drawingml/2006/main">
               <a:ext uri="{FF2B5EF4-FFF2-40B4-BE49-F238E27FC236}">
-                <a16:creationId xmlns:a16="http://schemas.microsoft.com/office/drawing/2014/main" id="{58B9C14F-58CD-4A54-8448-D8CD72987A6D}"/>
+                <a16:creationId xmlns:a16="http://schemas.microsoft.com/office/drawing/2014/main" id="{3451585E-8539-40EC-8565-61EB0CCDE886}"/>
               </a:ext>
             </a:extLst>
           </p:cNvPr>
@@ -1143,7 +1143,7 @@
           <p:cNvPr id="2" name="Subtitle">
             <a:extLst xmlns:a="http://schemas.openxmlformats.org/drawingml/2006/main">
               <a:ext uri="{FF2B5EF4-FFF2-40B4-BE49-F238E27FC236}">
-                <a16:creationId xmlns:a16="http://schemas.microsoft.com/office/drawing/2014/main" id="{85B4E568-4DAE-4141-A13E-36E3FAE4C1F0}"/>
+                <a16:creationId xmlns:a16="http://schemas.microsoft.com/office/drawing/2014/main" id="{C917930E-5F40-4F35-945E-E6C1795F2382}"/>
               </a:ext>
             </a:extLst>
           </p:cNvPr>
@@ -1317,7 +1317,7 @@
           <p:cNvPr id="2" name="Section title">
             <a:extLst xmlns:a="http://schemas.openxmlformats.org/drawingml/2006/main">
               <a:ext uri="{FF2B5EF4-FFF2-40B4-BE49-F238E27FC236}">
-                <a16:creationId xmlns:a16="http://schemas.microsoft.com/office/drawing/2014/main" id="{0804B447-1E67-444B-8002-3F8008D1F27B}"/>
+                <a16:creationId xmlns:a16="http://schemas.microsoft.com/office/drawing/2014/main" id="{8C9AAE0A-FB0A-413E-9E10-794DF41C5A09}"/>
               </a:ext>
             </a:extLst>
           </p:cNvPr>
@@ -1491,7 +1491,7 @@
           <p:cNvPr id="3" name="Title">
             <a:extLst xmlns:a="http://schemas.openxmlformats.org/drawingml/2006/main">
               <a:ext uri="{FF2B5EF4-FFF2-40B4-BE49-F238E27FC236}">
-                <a16:creationId xmlns:a16="http://schemas.microsoft.com/office/drawing/2014/main" id="{8074AC62-63E0-445C-9748-55B0CDF86053}"/>
+                <a16:creationId xmlns:a16="http://schemas.microsoft.com/office/drawing/2014/main" id="{4FCFBE10-96F7-4CF4-8C29-18572B1D5360}"/>
               </a:ext>
             </a:extLst>
           </p:cNvPr>
@@ -1648,7 +1648,7 @@
           <p:cNvPr id="2" name="Body">
             <a:extLst xmlns:a="http://schemas.openxmlformats.org/drawingml/2006/main">
               <a:ext uri="{FF2B5EF4-FFF2-40B4-BE49-F238E27FC236}">
-                <a16:creationId xmlns:a16="http://schemas.microsoft.com/office/drawing/2014/main" id="{C80CC0EF-BD53-40DE-9AC8-18DA17751D8C}"/>
+                <a16:creationId xmlns:a16="http://schemas.microsoft.com/office/drawing/2014/main" id="{46E60E40-8B15-4070-A73F-6AD9F93246D4}"/>
               </a:ext>
             </a:extLst>
           </p:cNvPr>
@@ -1822,7 +1822,7 @@
           <p:cNvPr id="4" name="Title">
             <a:extLst xmlns:a="http://schemas.openxmlformats.org/drawingml/2006/main">
               <a:ext uri="{FF2B5EF4-FFF2-40B4-BE49-F238E27FC236}">
-                <a16:creationId xmlns:a16="http://schemas.microsoft.com/office/drawing/2014/main" id="{9C97C781-2D0E-4185-ACB5-180E25623247}"/>
+                <a16:creationId xmlns:a16="http://schemas.microsoft.com/office/drawing/2014/main" id="{CBE5E132-E22E-4CD8-8878-4E465A9158EF}"/>
               </a:ext>
             </a:extLst>
           </p:cNvPr>
@@ -1979,7 +1979,7 @@
           <p:cNvPr id="2" name="Left column">
             <a:extLst xmlns:a="http://schemas.openxmlformats.org/drawingml/2006/main">
               <a:ext uri="{FF2B5EF4-FFF2-40B4-BE49-F238E27FC236}">
-                <a16:creationId xmlns:a16="http://schemas.microsoft.com/office/drawing/2014/main" id="{64BBDB1D-14BB-4B8C-B4F1-F1F0C7BE9F45}"/>
+                <a16:creationId xmlns:a16="http://schemas.microsoft.com/office/drawing/2014/main" id="{D3CEF924-1CED-49F1-90C1-C7753662483D}"/>
               </a:ext>
             </a:extLst>
           </p:cNvPr>
@@ -2136,7 +2136,7 @@
           <p:cNvPr id="3" name="Right column">
             <a:extLst xmlns:a="http://schemas.openxmlformats.org/drawingml/2006/main">
               <a:ext uri="{FF2B5EF4-FFF2-40B4-BE49-F238E27FC236}">
-                <a16:creationId xmlns:a16="http://schemas.microsoft.com/office/drawing/2014/main" id="{E31AEE75-F4EE-4763-B770-B21DA6342C9B}"/>
+                <a16:creationId xmlns:a16="http://schemas.microsoft.com/office/drawing/2014/main" id="{F1C15449-7685-4E12-A0A5-B675327E7AA4}"/>
               </a:ext>
             </a:extLst>
           </p:cNvPr>
@@ -2310,7 +2310,7 @@
           <p:cNvPr id="3" name="Title">
             <a:extLst xmlns:a="http://schemas.openxmlformats.org/drawingml/2006/main">
               <a:ext uri="{FF2B5EF4-FFF2-40B4-BE49-F238E27FC236}">
-                <a16:creationId xmlns:a16="http://schemas.microsoft.com/office/drawing/2014/main" id="{15501568-0160-4B0C-BAD5-0C7628097C29}"/>
+                <a16:creationId xmlns:a16="http://schemas.microsoft.com/office/drawing/2014/main" id="{D368F10B-1590-4989-ABB9-3C50C8239509}"/>
               </a:ext>
             </a:extLst>
           </p:cNvPr>
@@ -2467,7 +2467,7 @@
           <p:cNvPr id="2" name="Left column">
             <a:extLst xmlns:a="http://schemas.openxmlformats.org/drawingml/2006/main">
               <a:ext uri="{FF2B5EF4-FFF2-40B4-BE49-F238E27FC236}">
-                <a16:creationId xmlns:a16="http://schemas.microsoft.com/office/drawing/2014/main" id="{3E613EBF-21A8-4A31-B072-A4B63597B193}"/>
+                <a16:creationId xmlns:a16="http://schemas.microsoft.com/office/drawing/2014/main" id="{20C638FB-2BCF-44C7-8913-FA9CF1340442}"/>
               </a:ext>
             </a:extLst>
           </p:cNvPr>
@@ -2662,12 +2662,12 @@
   </p:cSld>
   <p:clrMap bg1="lt1" tx1="dk1" bg2="lt2" tx2="dk2" accent1="accent1" accent2="accent2" accent3="accent3" accent4="accent4" accent5="accent5" accent6="accent6" hlink="hlink" folHlink="folHlink"/>
   <p:sldLayoutIdLst>
-    <p:sldLayoutId xmlns:r="http://schemas.openxmlformats.org/officeDocument/2006/relationships" id="2147483649" r:id="R128fe4b39c00442a"/>
-    <p:sldLayoutId xmlns:r="http://schemas.openxmlformats.org/officeDocument/2006/relationships" id="2147483650" r:id="R42908f903fc447b3"/>
-    <p:sldLayoutId xmlns:r="http://schemas.openxmlformats.org/officeDocument/2006/relationships" id="2147483651" r:id="R4c1baeda0ef34bbc"/>
-    <p:sldLayoutId xmlns:r="http://schemas.openxmlformats.org/officeDocument/2006/relationships" id="2147483652" r:id="R77e8f265df5746c7"/>
-    <p:sldLayoutId xmlns:r="http://schemas.openxmlformats.org/officeDocument/2006/relationships" id="2147483653" r:id="R9dda1e0fe52b4703"/>
-    <p:sldLayoutId xmlns:r="http://schemas.openxmlformats.org/officeDocument/2006/relationships" id="2147483654" r:id="R385aaaa9a1eb49aa"/>
+    <p:sldLayoutId xmlns:r="http://schemas.openxmlformats.org/officeDocument/2006/relationships" id="2147483649" r:id="Rbd658da0326643c8"/>
+    <p:sldLayoutId xmlns:r="http://schemas.openxmlformats.org/officeDocument/2006/relationships" id="2147483650" r:id="R90b759bb5dcb4d4b"/>
+    <p:sldLayoutId xmlns:r="http://schemas.openxmlformats.org/officeDocument/2006/relationships" id="2147483651" r:id="R9788bb0678234863"/>
+    <p:sldLayoutId xmlns:r="http://schemas.openxmlformats.org/officeDocument/2006/relationships" id="2147483652" r:id="R64f1d04dec01455e"/>
+    <p:sldLayoutId xmlns:r="http://schemas.openxmlformats.org/officeDocument/2006/relationships" id="2147483653" r:id="Re5ccb1eb630442b0"/>
+    <p:sldLayoutId xmlns:r="http://schemas.openxmlformats.org/officeDocument/2006/relationships" id="2147483654" r:id="R53bf817631d9483c"/>
   </p:sldLayoutIdLst>
   <p:txStyles>
     <p:titleStyle>
@@ -3370,7 +3370,7 @@
         <c:axId val="48672768"/>
         <c:scaling>
           <c:orientation val="minMax"/>
-          <c:max val="100"/>
+          <c:max val="110"/>
           <c:min val="0"/>
         </c:scaling>
         <c:delete val="0"/>
@@ -3480,7 +3480,7 @@
           <p:cNvPr id="12" name="">
             <a:extLst xmlns:a="http://schemas.openxmlformats.org/drawingml/2006/main">
               <a:ext uri="{FF2B5EF4-FFF2-40B4-BE49-F238E27FC236}">
-                <a16:creationId xmlns:a16="http://schemas.microsoft.com/office/drawing/2014/main" id="{6B69D136-A8F2-441C-9B80-C6091157ABD3}"/>
+                <a16:creationId xmlns:a16="http://schemas.microsoft.com/office/drawing/2014/main" id="{206A2F7D-68B5-44FD-9FE0-8693BBB4FD1B}"/>
               </a:ext>
             </a:extLst>
           </p:cNvPr>
@@ -3546,7 +3546,7 @@
           <p:cNvPr id="2" name="">
             <a:extLst xmlns:a="http://schemas.openxmlformats.org/drawingml/2006/main">
               <a:ext uri="{FF2B5EF4-FFF2-40B4-BE49-F238E27FC236}">
-                <a16:creationId xmlns:a16="http://schemas.microsoft.com/office/drawing/2014/main" id="{ACF5B6BC-5850-410E-AD6A-76FDFDA27FB6}"/>
+                <a16:creationId xmlns:a16="http://schemas.microsoft.com/office/drawing/2014/main" id="{2F605279-2872-4142-9BEF-635088336FBE}"/>
               </a:ext>
             </a:extLst>
           </p:cNvPr>
@@ -3612,7 +3612,7 @@
           <p:cNvPr id="3" name="">
             <a:extLst xmlns:a="http://schemas.openxmlformats.org/drawingml/2006/main">
               <a:ext uri="{FF2B5EF4-FFF2-40B4-BE49-F238E27FC236}">
-                <a16:creationId xmlns:a16="http://schemas.microsoft.com/office/drawing/2014/main" id="{FDBC5584-4841-4181-B1B6-A86B322C0E8F}"/>
+                <a16:creationId xmlns:a16="http://schemas.microsoft.com/office/drawing/2014/main" id="{51827CFC-E304-4E0C-83D9-35B70AE5F229}"/>
               </a:ext>
             </a:extLst>
           </p:cNvPr>
@@ -3642,7 +3642,7 @@
           <p:cNvPr id="4" name="">
             <a:extLst xmlns:a="http://schemas.openxmlformats.org/drawingml/2006/main">
               <a:ext uri="{FF2B5EF4-FFF2-40B4-BE49-F238E27FC236}">
-                <a16:creationId xmlns:a16="http://schemas.microsoft.com/office/drawing/2014/main" id="{5A550E91-E0AF-4F92-9430-9DA344879516}"/>
+                <a16:creationId xmlns:a16="http://schemas.microsoft.com/office/drawing/2014/main" id="{0C64E689-7671-4340-88AE-24DDCFDDDE70}"/>
               </a:ext>
             </a:extLst>
           </p:cNvPr>
@@ -3708,7 +3708,7 @@
           <p:cNvPr id="5" name="">
             <a:extLst xmlns:a="http://schemas.openxmlformats.org/drawingml/2006/main">
               <a:ext uri="{FF2B5EF4-FFF2-40B4-BE49-F238E27FC236}">
-                <a16:creationId xmlns:a16="http://schemas.microsoft.com/office/drawing/2014/main" id="{23F34AEF-9539-48F9-835B-F09FE7A88588}"/>
+                <a16:creationId xmlns:a16="http://schemas.microsoft.com/office/drawing/2014/main" id="{7AF4FF5A-9D17-4A54-96A4-C798E053714B}"/>
               </a:ext>
             </a:extLst>
           </p:cNvPr>
@@ -3774,7 +3774,7 @@
           <p:cNvPr id="6" name="">
             <a:extLst xmlns:a="http://schemas.openxmlformats.org/drawingml/2006/main">
               <a:ext uri="{FF2B5EF4-FFF2-40B4-BE49-F238E27FC236}">
-                <a16:creationId xmlns:a16="http://schemas.microsoft.com/office/drawing/2014/main" id="{E21CE31B-D609-4B30-9912-B7E292A2D642}"/>
+                <a16:creationId xmlns:a16="http://schemas.microsoft.com/office/drawing/2014/main" id="{181028E4-B5AD-4BC1-8C30-9E9546431741}"/>
               </a:ext>
             </a:extLst>
           </p:cNvPr>
@@ -3840,7 +3840,7 @@
           <p:cNvPr id="7" name="">
             <a:extLst xmlns:a="http://schemas.openxmlformats.org/drawingml/2006/main">
               <a:ext uri="{FF2B5EF4-FFF2-40B4-BE49-F238E27FC236}">
-                <a16:creationId xmlns:a16="http://schemas.microsoft.com/office/drawing/2014/main" id="{2FC1205C-BB63-4082-BC0E-9751A1C28D16}"/>
+                <a16:creationId xmlns:a16="http://schemas.microsoft.com/office/drawing/2014/main" id="{F606A571-2467-4105-82FD-FCF9DB0E9D9C}"/>
               </a:ext>
             </a:extLst>
           </p:cNvPr>
@@ -3929,7 +3929,7 @@
           <p:cNvPr id="8" name="">
             <a:extLst xmlns:a="http://schemas.openxmlformats.org/drawingml/2006/main">
               <a:ext uri="{FF2B5EF4-FFF2-40B4-BE49-F238E27FC236}">
-                <a16:creationId xmlns:a16="http://schemas.microsoft.com/office/drawing/2014/main" id="{FEBB879F-EEEC-41DA-AA72-12CEAF74466D}"/>
+                <a16:creationId xmlns:a16="http://schemas.microsoft.com/office/drawing/2014/main" id="{8660A22B-0C60-4C59-A03E-A00CAD336925}"/>
               </a:ext>
             </a:extLst>
           </p:cNvPr>
@@ -4018,7 +4018,7 @@
           <p:cNvPr id="9" name="">
             <a:extLst xmlns:a="http://schemas.openxmlformats.org/drawingml/2006/main">
               <a:ext uri="{FF2B5EF4-FFF2-40B4-BE49-F238E27FC236}">
-                <a16:creationId xmlns:a16="http://schemas.microsoft.com/office/drawing/2014/main" id="{E5EB2D30-AE93-48B5-9FE3-8CAE254628FD}"/>
+                <a16:creationId xmlns:a16="http://schemas.microsoft.com/office/drawing/2014/main" id="{36CDE356-1E0F-4AD9-AB77-42F03C3D5D0C}"/>
               </a:ext>
             </a:extLst>
           </p:cNvPr>
@@ -4107,7 +4107,7 @@
           <p:cNvPr id="10" name="">
             <a:extLst xmlns:a="http://schemas.openxmlformats.org/drawingml/2006/main">
               <a:ext uri="{FF2B5EF4-FFF2-40B4-BE49-F238E27FC236}">
-                <a16:creationId xmlns:a16="http://schemas.microsoft.com/office/drawing/2014/main" id="{6D6B9543-A253-4B68-B5DD-950D02279745}"/>
+                <a16:creationId xmlns:a16="http://schemas.microsoft.com/office/drawing/2014/main" id="{95313F3C-CA4F-4AFC-9B8B-6B1B2F97152A}"/>
               </a:ext>
             </a:extLst>
           </p:cNvPr>
@@ -4117,7 +4117,7 @@
           <p:nvPr/>
         </p:nvPicPr>
         <p:blipFill>
-          <a:blip xmlns:r="http://schemas.openxmlformats.org/officeDocument/2006/relationships" xmlns:a="http://schemas.openxmlformats.org/drawingml/2006/main" r:embed="Rbfc24f9967494a27"/>
+          <a:blip xmlns:r="http://schemas.openxmlformats.org/officeDocument/2006/relationships" xmlns:a="http://schemas.openxmlformats.org/drawingml/2006/main" r:embed="R23865e238f004bdd"/>
           <a:stretch xmlns:a="http://schemas.openxmlformats.org/drawingml/2006/main"/>
         </p:blipFill>
         <p:spPr>
@@ -4135,7 +4135,7 @@
           <p:cNvPr id="11" name="">
             <a:extLst xmlns:a="http://schemas.openxmlformats.org/drawingml/2006/main">
               <a:ext uri="{FF2B5EF4-FFF2-40B4-BE49-F238E27FC236}">
-                <a16:creationId xmlns:a16="http://schemas.microsoft.com/office/drawing/2014/main" id="{9680486D-D688-4FD4-9AE8-C52DEB67F94C}"/>
+                <a16:creationId xmlns:a16="http://schemas.microsoft.com/office/drawing/2014/main" id="{F69D500E-C9B3-4012-8AC2-4C9F878EB816}"/>
               </a:ext>
             </a:extLst>
           </p:cNvPr>
@@ -4199,7 +4199,7 @@
     </p:spTree>
     <p:extLst>
       <p:ext uri="{BB962C8B-B14F-4D97-AF65-F5344CB8AC3E}">
-        <p14:creationId xmlns:p14="http://schemas.microsoft.com/office/powerpoint/2010/main" val="1428606706"/>
+        <p14:creationId xmlns:p14="http://schemas.microsoft.com/office/powerpoint/2010/main" val="956176809"/>
       </p:ext>
     </p:extLst>
   </p:cSld>
@@ -4230,7 +4230,7 @@
           <p:cNvPr id="17" name="">
             <a:extLst xmlns:a="http://schemas.openxmlformats.org/drawingml/2006/main">
               <a:ext uri="{FF2B5EF4-FFF2-40B4-BE49-F238E27FC236}">
-                <a16:creationId xmlns:a16="http://schemas.microsoft.com/office/drawing/2014/main" id="{4952C65C-A171-4684-8516-81E6030896FC}"/>
+                <a16:creationId xmlns:a16="http://schemas.microsoft.com/office/drawing/2014/main" id="{BE6827E8-40F0-4457-9F42-C9B28D926C25}"/>
               </a:ext>
             </a:extLst>
           </p:cNvPr>
@@ -4296,7 +4296,7 @@
           <p:cNvPr id="2" name="">
             <a:extLst xmlns:a="http://schemas.openxmlformats.org/drawingml/2006/main">
               <a:ext uri="{FF2B5EF4-FFF2-40B4-BE49-F238E27FC236}">
-                <a16:creationId xmlns:a16="http://schemas.microsoft.com/office/drawing/2014/main" id="{561E94E7-1402-4852-B364-089BEA3E9ECD}"/>
+                <a16:creationId xmlns:a16="http://schemas.microsoft.com/office/drawing/2014/main" id="{4EA1A273-ED8A-4B5E-AAE8-92716B996902}"/>
               </a:ext>
             </a:extLst>
           </p:cNvPr>
@@ -4362,7 +4362,7 @@
           <p:cNvPr id="3" name="">
             <a:extLst xmlns:a="http://schemas.openxmlformats.org/drawingml/2006/main">
               <a:ext uri="{FF2B5EF4-FFF2-40B4-BE49-F238E27FC236}">
-                <a16:creationId xmlns:a16="http://schemas.microsoft.com/office/drawing/2014/main" id="{C08F0F56-DDA9-4EE7-961A-F4C13BB63FC8}"/>
+                <a16:creationId xmlns:a16="http://schemas.microsoft.com/office/drawing/2014/main" id="{224F233C-C104-44F3-9FDE-E62D0BEE3100}"/>
               </a:ext>
             </a:extLst>
           </p:cNvPr>
@@ -4392,7 +4392,7 @@
           <p:cNvPr id="4" name="">
             <a:extLst xmlns:a="http://schemas.openxmlformats.org/drawingml/2006/main">
               <a:ext uri="{FF2B5EF4-FFF2-40B4-BE49-F238E27FC236}">
-                <a16:creationId xmlns:a16="http://schemas.microsoft.com/office/drawing/2014/main" id="{F31AD28C-A7EF-4A0F-B3BC-CA8A1412A7BC}"/>
+                <a16:creationId xmlns:a16="http://schemas.microsoft.com/office/drawing/2014/main" id="{81C3DF52-B458-45FA-9C9B-FC872D4CC6C3}"/>
               </a:ext>
             </a:extLst>
           </p:cNvPr>
@@ -4458,7 +4458,7 @@
           <p:cNvPr id="5" name="">
             <a:extLst xmlns:a="http://schemas.openxmlformats.org/drawingml/2006/main">
               <a:ext uri="{FF2B5EF4-FFF2-40B4-BE49-F238E27FC236}">
-                <a16:creationId xmlns:a16="http://schemas.microsoft.com/office/drawing/2014/main" id="{B44B0A07-9315-4FF8-BBB0-68A38AEE7A36}"/>
+                <a16:creationId xmlns:a16="http://schemas.microsoft.com/office/drawing/2014/main" id="{7CAE9902-AA49-4C83-A8E2-65D14A2B6108}"/>
               </a:ext>
             </a:extLst>
           </p:cNvPr>
@@ -4524,7 +4524,7 @@
           <p:cNvPr id="6" name="">
             <a:extLst xmlns:a="http://schemas.openxmlformats.org/drawingml/2006/main">
               <a:ext uri="{FF2B5EF4-FFF2-40B4-BE49-F238E27FC236}">
-                <a16:creationId xmlns:a16="http://schemas.microsoft.com/office/drawing/2014/main" id="{211A0D4D-3547-447F-AC40-F7D06455CCCF}"/>
+                <a16:creationId xmlns:a16="http://schemas.microsoft.com/office/drawing/2014/main" id="{75AA0970-AFED-40AA-A2A1-5447898AB9D7}"/>
               </a:ext>
             </a:extLst>
           </p:cNvPr>
@@ -4613,7 +4613,7 @@
           <p:cNvPr id="7" name="">
             <a:extLst xmlns:a="http://schemas.openxmlformats.org/drawingml/2006/main">
               <a:ext uri="{FF2B5EF4-FFF2-40B4-BE49-F238E27FC236}">
-                <a16:creationId xmlns:a16="http://schemas.microsoft.com/office/drawing/2014/main" id="{435162AC-B374-48E1-A9F0-2CB34346DE75}"/>
+                <a16:creationId xmlns:a16="http://schemas.microsoft.com/office/drawing/2014/main" id="{DF55ACA3-9C38-4BDF-8878-4F35E971F9DE}"/>
               </a:ext>
             </a:extLst>
           </p:cNvPr>
@@ -4679,7 +4679,7 @@
           <p:cNvPr id="8" name="">
             <a:extLst xmlns:a="http://schemas.openxmlformats.org/drawingml/2006/main">
               <a:ext uri="{FF2B5EF4-FFF2-40B4-BE49-F238E27FC236}">
-                <a16:creationId xmlns:a16="http://schemas.microsoft.com/office/drawing/2014/main" id="{D1713ACB-D0F4-437C-B5B3-9DC1C933A30C}"/>
+                <a16:creationId xmlns:a16="http://schemas.microsoft.com/office/drawing/2014/main" id="{9DF562D0-0791-4878-A203-7729267D29A1}"/>
               </a:ext>
             </a:extLst>
           </p:cNvPr>
@@ -4745,7 +4745,7 @@
           <p:cNvPr id="9" name="">
             <a:extLst xmlns:a="http://schemas.openxmlformats.org/drawingml/2006/main">
               <a:ext uri="{FF2B5EF4-FFF2-40B4-BE49-F238E27FC236}">
-                <a16:creationId xmlns:a16="http://schemas.microsoft.com/office/drawing/2014/main" id="{532DD9B7-3B5B-4668-BF68-B796A4784E57}"/>
+                <a16:creationId xmlns:a16="http://schemas.microsoft.com/office/drawing/2014/main" id="{E0CCC5B4-E2CF-418C-A2E3-37CB3BA7129C}"/>
               </a:ext>
             </a:extLst>
           </p:cNvPr>
@@ -4811,7 +4811,7 @@
           <p:cNvPr id="10" name="">
             <a:extLst xmlns:a="http://schemas.openxmlformats.org/drawingml/2006/main">
               <a:ext uri="{FF2B5EF4-FFF2-40B4-BE49-F238E27FC236}">
-                <a16:creationId xmlns:a16="http://schemas.microsoft.com/office/drawing/2014/main" id="{F5C22DEB-872D-4AD8-B653-AE78D132759C}"/>
+                <a16:creationId xmlns:a16="http://schemas.microsoft.com/office/drawing/2014/main" id="{0285B78C-758C-40AD-B5E1-ED663693D40F}"/>
               </a:ext>
             </a:extLst>
           </p:cNvPr>
@@ -4841,7 +4841,7 @@
           <p:cNvPr id="11" name="">
             <a:extLst xmlns:a="http://schemas.openxmlformats.org/drawingml/2006/main">
               <a:ext uri="{FF2B5EF4-FFF2-40B4-BE49-F238E27FC236}">
-                <a16:creationId xmlns:a16="http://schemas.microsoft.com/office/drawing/2014/main" id="{EAA104C3-8F3C-4DC6-91E1-472998AA8CA7}"/>
+                <a16:creationId xmlns:a16="http://schemas.microsoft.com/office/drawing/2014/main" id="{406D58FB-F412-419D-906B-E7BCCF8CE13A}"/>
               </a:ext>
             </a:extLst>
           </p:cNvPr>
@@ -4907,7 +4907,7 @@
           <p:cNvPr id="12" name="">
             <a:extLst xmlns:a="http://schemas.openxmlformats.org/drawingml/2006/main">
               <a:ext uri="{FF2B5EF4-FFF2-40B4-BE49-F238E27FC236}">
-                <a16:creationId xmlns:a16="http://schemas.microsoft.com/office/drawing/2014/main" id="{BD031346-FEDD-4CF1-927D-62A06333D66B}"/>
+                <a16:creationId xmlns:a16="http://schemas.microsoft.com/office/drawing/2014/main" id="{653E8090-5DE6-4EAD-B1DC-9A3B2A013D70}"/>
               </a:ext>
             </a:extLst>
           </p:cNvPr>
@@ -4996,7 +4996,7 @@
           <p:cNvPr id="13" name="">
             <a:extLst xmlns:a="http://schemas.openxmlformats.org/drawingml/2006/main">
               <a:ext uri="{FF2B5EF4-FFF2-40B4-BE49-F238E27FC236}">
-                <a16:creationId xmlns:a16="http://schemas.microsoft.com/office/drawing/2014/main" id="{844B72C7-51BC-46E4-B325-815A739171D3}"/>
+                <a16:creationId xmlns:a16="http://schemas.microsoft.com/office/drawing/2014/main" id="{42D11487-B68D-483C-8F34-3EEFEDC34BC4}"/>
               </a:ext>
             </a:extLst>
           </p:cNvPr>
@@ -5062,7 +5062,7 @@
           <p:cNvPr id="14" name="">
             <a:extLst xmlns:a="http://schemas.openxmlformats.org/drawingml/2006/main">
               <a:ext uri="{FF2B5EF4-FFF2-40B4-BE49-F238E27FC236}">
-                <a16:creationId xmlns:a16="http://schemas.microsoft.com/office/drawing/2014/main" id="{786C9D1C-CF2C-4151-8FE1-4686B412D81C}"/>
+                <a16:creationId xmlns:a16="http://schemas.microsoft.com/office/drawing/2014/main" id="{075F639B-E7F0-4EB6-B484-4998A242EF75}"/>
               </a:ext>
             </a:extLst>
           </p:cNvPr>
@@ -5151,7 +5151,7 @@
           <p:cNvPr id="15" name="">
             <a:extLst xmlns:a="http://schemas.openxmlformats.org/drawingml/2006/main">
               <a:ext uri="{FF2B5EF4-FFF2-40B4-BE49-F238E27FC236}">
-                <a16:creationId xmlns:a16="http://schemas.microsoft.com/office/drawing/2014/main" id="{2D60B0CF-D198-46EC-8AF5-F49A28E07673}"/>
+                <a16:creationId xmlns:a16="http://schemas.microsoft.com/office/drawing/2014/main" id="{0564567A-C39F-4B26-A529-D44DA276F923}"/>
               </a:ext>
             </a:extLst>
           </p:cNvPr>
@@ -5217,7 +5217,7 @@
           <p:cNvPr id="16" name="">
             <a:extLst xmlns:a="http://schemas.openxmlformats.org/drawingml/2006/main">
               <a:ext uri="{FF2B5EF4-FFF2-40B4-BE49-F238E27FC236}">
-                <a16:creationId xmlns:a16="http://schemas.microsoft.com/office/drawing/2014/main" id="{E33AA638-EB26-48B9-9A5E-29C0E9EE422A}"/>
+                <a16:creationId xmlns:a16="http://schemas.microsoft.com/office/drawing/2014/main" id="{FF55A032-8793-4782-BD2F-1F199A1EE6CD}"/>
               </a:ext>
             </a:extLst>
           </p:cNvPr>
@@ -5304,7 +5304,7 @@
     </p:spTree>
     <p:extLst>
       <p:ext uri="{BB962C8B-B14F-4D97-AF65-F5344CB8AC3E}">
-        <p14:creationId xmlns:p14="http://schemas.microsoft.com/office/powerpoint/2010/main" val="279399011"/>
+        <p14:creationId xmlns:p14="http://schemas.microsoft.com/office/powerpoint/2010/main" val="708456314"/>
       </p:ext>
     </p:extLst>
   </p:cSld>
@@ -5335,7 +5335,7 @@
           <p:cNvPr id="23" name="">
             <a:extLst xmlns:a="http://schemas.openxmlformats.org/drawingml/2006/main">
               <a:ext uri="{FF2B5EF4-FFF2-40B4-BE49-F238E27FC236}">
-                <a16:creationId xmlns:a16="http://schemas.microsoft.com/office/drawing/2014/main" id="{25300D80-FFC2-4263-A7E4-1DCB955A69ED}"/>
+                <a16:creationId xmlns:a16="http://schemas.microsoft.com/office/drawing/2014/main" id="{382A296E-3611-48CF-978A-89C9D76562AF}"/>
               </a:ext>
             </a:extLst>
           </p:cNvPr>
@@ -5401,7 +5401,7 @@
           <p:cNvPr id="2" name="">
             <a:extLst xmlns:a="http://schemas.openxmlformats.org/drawingml/2006/main">
               <a:ext uri="{FF2B5EF4-FFF2-40B4-BE49-F238E27FC236}">
-                <a16:creationId xmlns:a16="http://schemas.microsoft.com/office/drawing/2014/main" id="{8F80AEE5-810E-4451-9D61-04EECB415197}"/>
+                <a16:creationId xmlns:a16="http://schemas.microsoft.com/office/drawing/2014/main" id="{3DFC1B93-CB0A-481C-AADB-DDC375A6C2F3}"/>
               </a:ext>
             </a:extLst>
           </p:cNvPr>
@@ -5467,7 +5467,7 @@
           <p:cNvPr id="3" name="">
             <a:extLst xmlns:a="http://schemas.openxmlformats.org/drawingml/2006/main">
               <a:ext uri="{FF2B5EF4-FFF2-40B4-BE49-F238E27FC236}">
-                <a16:creationId xmlns:a16="http://schemas.microsoft.com/office/drawing/2014/main" id="{428CF678-25A4-4ED2-A523-4A38EAD0E303}"/>
+                <a16:creationId xmlns:a16="http://schemas.microsoft.com/office/drawing/2014/main" id="{7F5F6A2E-2D47-4F85-9A2D-B3C90E0C0FEF}"/>
               </a:ext>
             </a:extLst>
           </p:cNvPr>
@@ -5497,7 +5497,7 @@
           <p:cNvPr id="4" name="">
             <a:extLst xmlns:a="http://schemas.openxmlformats.org/drawingml/2006/main">
               <a:ext uri="{FF2B5EF4-FFF2-40B4-BE49-F238E27FC236}">
-                <a16:creationId xmlns:a16="http://schemas.microsoft.com/office/drawing/2014/main" id="{8230A92A-5C60-49FC-9CCC-8170E495B448}"/>
+                <a16:creationId xmlns:a16="http://schemas.microsoft.com/office/drawing/2014/main" id="{57A42C68-DA39-4557-BCAB-9E7A9C3DF2EF}"/>
               </a:ext>
             </a:extLst>
           </p:cNvPr>
@@ -5563,7 +5563,7 @@
           <p:cNvPr id="5" name="">
             <a:extLst xmlns:a="http://schemas.openxmlformats.org/drawingml/2006/main">
               <a:ext uri="{FF2B5EF4-FFF2-40B4-BE49-F238E27FC236}">
-                <a16:creationId xmlns:a16="http://schemas.microsoft.com/office/drawing/2014/main" id="{E0DE190E-0539-4C92-922F-4AB3C7DA73D7}"/>
+                <a16:creationId xmlns:a16="http://schemas.microsoft.com/office/drawing/2014/main" id="{66E14704-5ADF-4E95-B7B0-0897F89950A5}"/>
               </a:ext>
             </a:extLst>
           </p:cNvPr>
@@ -5629,7 +5629,7 @@
           <p:cNvPr id="6" name="">
             <a:extLst xmlns:a="http://schemas.openxmlformats.org/drawingml/2006/main">
               <a:ext uri="{FF2B5EF4-FFF2-40B4-BE49-F238E27FC236}">
-                <a16:creationId xmlns:a16="http://schemas.microsoft.com/office/drawing/2014/main" id="{B22D14CE-F615-46DD-8AC2-DC9D9376A9B9}"/>
+                <a16:creationId xmlns:a16="http://schemas.microsoft.com/office/drawing/2014/main" id="{A06FEDC2-A425-4CAC-91A8-D06A6AB562CE}"/>
               </a:ext>
             </a:extLst>
           </p:cNvPr>
@@ -5695,7 +5695,7 @@
           <p:cNvPr id="7" name="">
             <a:extLst xmlns:a="http://schemas.openxmlformats.org/drawingml/2006/main">
               <a:ext uri="{FF2B5EF4-FFF2-40B4-BE49-F238E27FC236}">
-                <a16:creationId xmlns:a16="http://schemas.microsoft.com/office/drawing/2014/main" id="{1CB22EA3-BC86-4D98-815A-A0CF4DC71D55}"/>
+                <a16:creationId xmlns:a16="http://schemas.microsoft.com/office/drawing/2014/main" id="{A66E7544-3DAB-4824-83C2-246B33797E43}"/>
               </a:ext>
             </a:extLst>
           </p:cNvPr>
@@ -5761,7 +5761,7 @@
           <p:cNvPr id="8" name="">
             <a:extLst xmlns:a="http://schemas.openxmlformats.org/drawingml/2006/main">
               <a:ext uri="{FF2B5EF4-FFF2-40B4-BE49-F238E27FC236}">
-                <a16:creationId xmlns:a16="http://schemas.microsoft.com/office/drawing/2014/main" id="{9D88C02F-5C35-41F5-AAD3-93848A410DB1}"/>
+                <a16:creationId xmlns:a16="http://schemas.microsoft.com/office/drawing/2014/main" id="{F3600617-BB63-41DB-A6E2-4EAC03A4984D}"/>
               </a:ext>
             </a:extLst>
           </p:cNvPr>
@@ -5827,7 +5827,7 @@
           <p:cNvPr id="9" name="">
             <a:extLst xmlns:a="http://schemas.openxmlformats.org/drawingml/2006/main">
               <a:ext uri="{FF2B5EF4-FFF2-40B4-BE49-F238E27FC236}">
-                <a16:creationId xmlns:a16="http://schemas.microsoft.com/office/drawing/2014/main" id="{2DC9AA12-4DD7-4014-AFA9-327BA5317D8E}"/>
+                <a16:creationId xmlns:a16="http://schemas.microsoft.com/office/drawing/2014/main" id="{07D6062A-C9C3-4143-9E68-93A618908432}"/>
               </a:ext>
             </a:extLst>
           </p:cNvPr>
@@ -5893,7 +5893,7 @@
           <p:cNvPr id="10" name="">
             <a:extLst xmlns:a="http://schemas.openxmlformats.org/drawingml/2006/main">
               <a:ext uri="{FF2B5EF4-FFF2-40B4-BE49-F238E27FC236}">
-                <a16:creationId xmlns:a16="http://schemas.microsoft.com/office/drawing/2014/main" id="{1F648CEC-7201-4CC7-A5F8-A7875FBED077}"/>
+                <a16:creationId xmlns:a16="http://schemas.microsoft.com/office/drawing/2014/main" id="{9B26DA0C-D27D-486E-B05F-5B630CD80127}"/>
               </a:ext>
             </a:extLst>
           </p:cNvPr>
@@ -5925,7 +5925,7 @@
           <p:cNvPr id="11" name="">
             <a:extLst xmlns:a="http://schemas.openxmlformats.org/drawingml/2006/main">
               <a:ext uri="{FF2B5EF4-FFF2-40B4-BE49-F238E27FC236}">
-                <a16:creationId xmlns:a16="http://schemas.microsoft.com/office/drawing/2014/main" id="{5E1386E2-C6A9-4803-996B-F80ABA12B525}"/>
+                <a16:creationId xmlns:a16="http://schemas.microsoft.com/office/drawing/2014/main" id="{EB0190F5-3BD3-45E7-BA37-5B79AD5FCAB0}"/>
               </a:ext>
             </a:extLst>
           </p:cNvPr>
@@ -6037,7 +6037,7 @@
           <p:cNvPr id="12" name="">
             <a:extLst xmlns:a="http://schemas.openxmlformats.org/drawingml/2006/main">
               <a:ext uri="{FF2B5EF4-FFF2-40B4-BE49-F238E27FC236}">
-                <a16:creationId xmlns:a16="http://schemas.microsoft.com/office/drawing/2014/main" id="{EB23BBF9-9E61-4048-834C-6055AAE4BD9F}"/>
+                <a16:creationId xmlns:a16="http://schemas.microsoft.com/office/drawing/2014/main" id="{7B6AB031-74BE-4D6D-88C6-661459AF9CF9}"/>
               </a:ext>
             </a:extLst>
           </p:cNvPr>
@@ -6126,7 +6126,7 @@
           <p:cNvPr id="13" name="">
             <a:extLst xmlns:a="http://schemas.openxmlformats.org/drawingml/2006/main">
               <a:ext uri="{FF2B5EF4-FFF2-40B4-BE49-F238E27FC236}">
-                <a16:creationId xmlns:a16="http://schemas.microsoft.com/office/drawing/2014/main" id="{09AF57A2-EA72-4023-9638-14A356B16E31}"/>
+                <a16:creationId xmlns:a16="http://schemas.microsoft.com/office/drawing/2014/main" id="{47DAC6E0-8513-4559-8D43-B9D60FC4E9BD}"/>
               </a:ext>
             </a:extLst>
           </p:cNvPr>
@@ -6192,7 +6192,7 @@
           <p:cNvPr id="14" name="">
             <a:extLst xmlns:a="http://schemas.openxmlformats.org/drawingml/2006/main">
               <a:ext uri="{FF2B5EF4-FFF2-40B4-BE49-F238E27FC236}">
-                <a16:creationId xmlns:a16="http://schemas.microsoft.com/office/drawing/2014/main" id="{DEB9FE1F-1BDF-4DB3-BB62-1F0D458DE1D2}"/>
+                <a16:creationId xmlns:a16="http://schemas.microsoft.com/office/drawing/2014/main" id="{6D05FB6C-1747-4501-8D47-9FFDD409DA7F}"/>
               </a:ext>
             </a:extLst>
           </p:cNvPr>
@@ -6222,7 +6222,7 @@
           <p:cNvPr id="15" name="">
             <a:extLst xmlns:a="http://schemas.openxmlformats.org/drawingml/2006/main">
               <a:ext uri="{FF2B5EF4-FFF2-40B4-BE49-F238E27FC236}">
-                <a16:creationId xmlns:a16="http://schemas.microsoft.com/office/drawing/2014/main" id="{86C1E039-8900-4591-B071-A2ECEC86A799}"/>
+                <a16:creationId xmlns:a16="http://schemas.microsoft.com/office/drawing/2014/main" id="{2E85B963-6AB4-4C8C-BCFE-BD116CBE3ED5}"/>
               </a:ext>
             </a:extLst>
           </p:cNvPr>
@@ -6334,7 +6334,7 @@
           <p:cNvPr id="16" name="">
             <a:extLst xmlns:a="http://schemas.openxmlformats.org/drawingml/2006/main">
               <a:ext uri="{FF2B5EF4-FFF2-40B4-BE49-F238E27FC236}">
-                <a16:creationId xmlns:a16="http://schemas.microsoft.com/office/drawing/2014/main" id="{2C104F76-0E8D-417D-A075-986F16849127}"/>
+                <a16:creationId xmlns:a16="http://schemas.microsoft.com/office/drawing/2014/main" id="{D3FD17A9-F205-4FE6-992C-6AA064AA2E9F}"/>
               </a:ext>
             </a:extLst>
           </p:cNvPr>
@@ -6423,7 +6423,7 @@
           <p:cNvPr id="17" name="">
             <a:extLst xmlns:a="http://schemas.openxmlformats.org/drawingml/2006/main">
               <a:ext uri="{FF2B5EF4-FFF2-40B4-BE49-F238E27FC236}">
-                <a16:creationId xmlns:a16="http://schemas.microsoft.com/office/drawing/2014/main" id="{DD785296-D0A4-4C2E-853E-B115DFA10602}"/>
+                <a16:creationId xmlns:a16="http://schemas.microsoft.com/office/drawing/2014/main" id="{755C8EF8-AE64-4B9F-92F9-24BB68A07AD1}"/>
               </a:ext>
             </a:extLst>
           </p:cNvPr>
@@ -6489,7 +6489,7 @@
           <p:cNvPr id="18" name="">
             <a:extLst xmlns:a="http://schemas.openxmlformats.org/drawingml/2006/main">
               <a:ext uri="{FF2B5EF4-FFF2-40B4-BE49-F238E27FC236}">
-                <a16:creationId xmlns:a16="http://schemas.microsoft.com/office/drawing/2014/main" id="{A8C3E020-C482-48EA-ADC0-CE0D71DCC59D}"/>
+                <a16:creationId xmlns:a16="http://schemas.microsoft.com/office/drawing/2014/main" id="{EB028AEA-C498-47E7-8B42-34F1C7973D1C}"/>
               </a:ext>
             </a:extLst>
           </p:cNvPr>
@@ -6521,7 +6521,7 @@
           <p:cNvPr id="19" name="">
             <a:extLst xmlns:a="http://schemas.openxmlformats.org/drawingml/2006/main">
               <a:ext uri="{FF2B5EF4-FFF2-40B4-BE49-F238E27FC236}">
-                <a16:creationId xmlns:a16="http://schemas.microsoft.com/office/drawing/2014/main" id="{3FC94342-CEE3-4076-B9C4-3AE5265B43E8}"/>
+                <a16:creationId xmlns:a16="http://schemas.microsoft.com/office/drawing/2014/main" id="{95AAF7D3-6E38-464B-B25D-D1F6B0090AFB}"/>
               </a:ext>
             </a:extLst>
           </p:cNvPr>
@@ -6633,7 +6633,7 @@
           <p:cNvPr id="20" name="">
             <a:extLst xmlns:a="http://schemas.openxmlformats.org/drawingml/2006/main">
               <a:ext uri="{FF2B5EF4-FFF2-40B4-BE49-F238E27FC236}">
-                <a16:creationId xmlns:a16="http://schemas.microsoft.com/office/drawing/2014/main" id="{B70089F0-38F6-48CC-BC79-5DE605976274}"/>
+                <a16:creationId xmlns:a16="http://schemas.microsoft.com/office/drawing/2014/main" id="{BD633FCD-E865-4EAB-A0CC-A556D4071465}"/>
               </a:ext>
             </a:extLst>
           </p:cNvPr>
@@ -6722,7 +6722,7 @@
           <p:cNvPr id="21" name="">
             <a:extLst xmlns:a="http://schemas.openxmlformats.org/drawingml/2006/main">
               <a:ext uri="{FF2B5EF4-FFF2-40B4-BE49-F238E27FC236}">
-                <a16:creationId xmlns:a16="http://schemas.microsoft.com/office/drawing/2014/main" id="{F15D96F0-D520-417B-916B-402D37AB1323}"/>
+                <a16:creationId xmlns:a16="http://schemas.microsoft.com/office/drawing/2014/main" id="{6550E9D6-C20D-4F48-AD3A-1F0A2C33B1A1}"/>
               </a:ext>
             </a:extLst>
           </p:cNvPr>
@@ -6752,7 +6752,7 @@
           <p:cNvPr id="22" name="">
             <a:extLst xmlns:a="http://schemas.openxmlformats.org/drawingml/2006/main">
               <a:ext uri="{FF2B5EF4-FFF2-40B4-BE49-F238E27FC236}">
-                <a16:creationId xmlns:a16="http://schemas.microsoft.com/office/drawing/2014/main" id="{F6064D0A-6211-407A-AD28-59ADDC54036F}"/>
+                <a16:creationId xmlns:a16="http://schemas.microsoft.com/office/drawing/2014/main" id="{B11E99BF-82EF-4165-AD35-9BDBA621BC9D}"/>
               </a:ext>
             </a:extLst>
           </p:cNvPr>
@@ -6816,7 +6816,7 @@
     </p:spTree>
     <p:extLst>
       <p:ext uri="{BB962C8B-B14F-4D97-AF65-F5344CB8AC3E}">
-        <p14:creationId xmlns:p14="http://schemas.microsoft.com/office/powerpoint/2010/main" val="1364730409"/>
+        <p14:creationId xmlns:p14="http://schemas.microsoft.com/office/powerpoint/2010/main" val="1799325939"/>
       </p:ext>
     </p:extLst>
   </p:cSld>
@@ -6847,7 +6847,7 @@
           <p:cNvPr id="16" name="">
             <a:extLst xmlns:a="http://schemas.openxmlformats.org/drawingml/2006/main">
               <a:ext uri="{FF2B5EF4-FFF2-40B4-BE49-F238E27FC236}">
-                <a16:creationId xmlns:a16="http://schemas.microsoft.com/office/drawing/2014/main" id="{71C12617-1492-4459-BF75-08113EA3C186}"/>
+                <a16:creationId xmlns:a16="http://schemas.microsoft.com/office/drawing/2014/main" id="{0741E363-99A2-4936-BD5E-B2B432A4EF96}"/>
               </a:ext>
             </a:extLst>
           </p:cNvPr>
@@ -6913,7 +6913,7 @@
           <p:cNvPr id="2" name="">
             <a:extLst xmlns:a="http://schemas.openxmlformats.org/drawingml/2006/main">
               <a:ext uri="{FF2B5EF4-FFF2-40B4-BE49-F238E27FC236}">
-                <a16:creationId xmlns:a16="http://schemas.microsoft.com/office/drawing/2014/main" id="{BAE89000-6125-4C20-B8DF-CC3DB01DBF0A}"/>
+                <a16:creationId xmlns:a16="http://schemas.microsoft.com/office/drawing/2014/main" id="{4A25AC3C-1D77-42F8-B00B-CFF5760EF928}"/>
               </a:ext>
             </a:extLst>
           </p:cNvPr>
@@ -6979,7 +6979,7 @@
           <p:cNvPr id="3" name="">
             <a:extLst xmlns:a="http://schemas.openxmlformats.org/drawingml/2006/main">
               <a:ext uri="{FF2B5EF4-FFF2-40B4-BE49-F238E27FC236}">
-                <a16:creationId xmlns:a16="http://schemas.microsoft.com/office/drawing/2014/main" id="{9A9C7A80-FA88-48E3-B95D-7BC3EEF2A813}"/>
+                <a16:creationId xmlns:a16="http://schemas.microsoft.com/office/drawing/2014/main" id="{10B06ADA-D21A-4130-AF86-C69CA425C47F}"/>
               </a:ext>
             </a:extLst>
           </p:cNvPr>
@@ -7009,7 +7009,7 @@
           <p:cNvPr id="4" name="">
             <a:extLst xmlns:a="http://schemas.openxmlformats.org/drawingml/2006/main">
               <a:ext uri="{FF2B5EF4-FFF2-40B4-BE49-F238E27FC236}">
-                <a16:creationId xmlns:a16="http://schemas.microsoft.com/office/drawing/2014/main" id="{C15E37A3-3F9B-43B4-997A-5C1CE56EF550}"/>
+                <a16:creationId xmlns:a16="http://schemas.microsoft.com/office/drawing/2014/main" id="{BEE76D49-F4A8-41A9-B366-DADAB8B40CB3}"/>
               </a:ext>
             </a:extLst>
           </p:cNvPr>
@@ -7075,7 +7075,7 @@
           <p:cNvPr id="5" name="">
             <a:extLst xmlns:a="http://schemas.openxmlformats.org/drawingml/2006/main">
               <a:ext uri="{FF2B5EF4-FFF2-40B4-BE49-F238E27FC236}">
-                <a16:creationId xmlns:a16="http://schemas.microsoft.com/office/drawing/2014/main" id="{FE23072D-F033-43B9-8B12-650EC143E32E}"/>
+                <a16:creationId xmlns:a16="http://schemas.microsoft.com/office/drawing/2014/main" id="{A3EE8ECF-6534-4802-A3B1-F35E87444BBB}"/>
               </a:ext>
             </a:extLst>
           </p:cNvPr>
@@ -7141,7 +7141,7 @@
           <p:cNvPr id="6" name="">
             <a:extLst xmlns:a="http://schemas.openxmlformats.org/drawingml/2006/main">
               <a:ext uri="{FF2B5EF4-FFF2-40B4-BE49-F238E27FC236}">
-                <a16:creationId xmlns:a16="http://schemas.microsoft.com/office/drawing/2014/main" id="{EAE21BB4-888F-4523-9534-282B94B3EFE9}"/>
+                <a16:creationId xmlns:a16="http://schemas.microsoft.com/office/drawing/2014/main" id="{B09825FB-94F9-4D78-BE87-7A902867468F}"/>
               </a:ext>
             </a:extLst>
           </p:cNvPr>
@@ -7207,7 +7207,7 @@
           <p:cNvPr id="7" name="">
             <a:extLst xmlns:a="http://schemas.openxmlformats.org/drawingml/2006/main">
               <a:ext uri="{FF2B5EF4-FFF2-40B4-BE49-F238E27FC236}">
-                <a16:creationId xmlns:a16="http://schemas.microsoft.com/office/drawing/2014/main" id="{E0998C88-A66F-4A85-8890-3294846DAFF4}"/>
+                <a16:creationId xmlns:a16="http://schemas.microsoft.com/office/drawing/2014/main" id="{6C6E8D69-C0EE-4B3F-998D-078869DF9DE3}"/>
               </a:ext>
             </a:extLst>
           </p:cNvPr>
@@ -7273,7 +7273,7 @@
           <p:cNvPr id="8" name="">
             <a:extLst xmlns:a="http://schemas.openxmlformats.org/drawingml/2006/main">
               <a:ext uri="{FF2B5EF4-FFF2-40B4-BE49-F238E27FC236}">
-                <a16:creationId xmlns:a16="http://schemas.microsoft.com/office/drawing/2014/main" id="{569B0594-6BE6-4C27-8D75-DAFE0DD7A49C}"/>
+                <a16:creationId xmlns:a16="http://schemas.microsoft.com/office/drawing/2014/main" id="{02186970-5069-4EEA-88EE-6E80EA309178}"/>
               </a:ext>
             </a:extLst>
           </p:cNvPr>
@@ -7362,7 +7362,7 @@
           <p:cNvPr id="9" name="">
             <a:extLst xmlns:a="http://schemas.openxmlformats.org/drawingml/2006/main">
               <a:ext uri="{FF2B5EF4-FFF2-40B4-BE49-F238E27FC236}">
-                <a16:creationId xmlns:a16="http://schemas.microsoft.com/office/drawing/2014/main" id="{AC243D2D-7B85-4587-9F15-2E6E7377CE44}"/>
+                <a16:creationId xmlns:a16="http://schemas.microsoft.com/office/drawing/2014/main" id="{F71B7CDF-383D-4652-858C-EF79404B996F}"/>
               </a:ext>
             </a:extLst>
           </p:cNvPr>
@@ -7451,7 +7451,7 @@
           <p:cNvPr id="10" name="">
             <a:extLst xmlns:a="http://schemas.openxmlformats.org/drawingml/2006/main">
               <a:ext uri="{FF2B5EF4-FFF2-40B4-BE49-F238E27FC236}">
-                <a16:creationId xmlns:a16="http://schemas.microsoft.com/office/drawing/2014/main" id="{C977A8F1-8388-4D7E-A422-4045CF265192}"/>
+                <a16:creationId xmlns:a16="http://schemas.microsoft.com/office/drawing/2014/main" id="{D8BF35E7-A5B9-44FE-B97A-6767C94C8B70}"/>
               </a:ext>
             </a:extLst>
           </p:cNvPr>
@@ -7540,7 +7540,7 @@
           <p:cNvPr id="11" name="">
             <a:extLst xmlns:a="http://schemas.openxmlformats.org/drawingml/2006/main">
               <a:ext uri="{FF2B5EF4-FFF2-40B4-BE49-F238E27FC236}">
-                <a16:creationId xmlns:a16="http://schemas.microsoft.com/office/drawing/2014/main" id="{D4CEA5B2-812F-42ED-A5D6-6281784FC247}"/>
+                <a16:creationId xmlns:a16="http://schemas.microsoft.com/office/drawing/2014/main" id="{49FED891-AA0B-400D-8C65-0456E249B0DF}"/>
               </a:ext>
             </a:extLst>
           </p:cNvPr>
@@ -7570,7 +7570,7 @@
           <p:cNvPr id="12" name="">
             <a:extLst xmlns:a="http://schemas.openxmlformats.org/drawingml/2006/main">
               <a:ext uri="{FF2B5EF4-FFF2-40B4-BE49-F238E27FC236}">
-                <a16:creationId xmlns:a16="http://schemas.microsoft.com/office/drawing/2014/main" id="{A378F94B-B214-436F-B77C-1FCBF3F54CA2}"/>
+                <a16:creationId xmlns:a16="http://schemas.microsoft.com/office/drawing/2014/main" id="{08ADDCAB-4D8F-476A-AF4A-DB3DE8B6E7AD}"/>
               </a:ext>
             </a:extLst>
           </p:cNvPr>
@@ -7580,7 +7580,7 @@
           <p:nvPr/>
         </p:nvPicPr>
         <p:blipFill>
-          <a:blip xmlns:r="http://schemas.openxmlformats.org/officeDocument/2006/relationships" xmlns:a="http://schemas.openxmlformats.org/drawingml/2006/main" r:embed="R421b5a991ec64fd6"/>
+          <a:blip xmlns:r="http://schemas.openxmlformats.org/officeDocument/2006/relationships" xmlns:a="http://schemas.openxmlformats.org/drawingml/2006/main" r:embed="Rc4d629c68b32492e"/>
           <a:stretch xmlns:a="http://schemas.openxmlformats.org/drawingml/2006/main"/>
         </p:blipFill>
         <p:spPr>
@@ -7598,7 +7598,7 @@
           <p:cNvPr id="13" name="">
             <a:extLst xmlns:a="http://schemas.openxmlformats.org/drawingml/2006/main">
               <a:ext uri="{FF2B5EF4-FFF2-40B4-BE49-F238E27FC236}">
-                <a16:creationId xmlns:a16="http://schemas.microsoft.com/office/drawing/2014/main" id="{3A318D45-7B8D-496E-8B35-907C7016A1F5}"/>
+                <a16:creationId xmlns:a16="http://schemas.microsoft.com/office/drawing/2014/main" id="{C0A9EE09-D774-4C8F-8E7C-DAC6F3AE03E2}"/>
               </a:ext>
             </a:extLst>
           </p:cNvPr>
@@ -7608,7 +7608,7 @@
           <p:nvPr/>
         </p:nvPicPr>
         <p:blipFill>
-          <a:blip xmlns:r="http://schemas.openxmlformats.org/officeDocument/2006/relationships" xmlns:a="http://schemas.openxmlformats.org/drawingml/2006/main" r:embed="R7fb67042367949f8"/>
+          <a:blip xmlns:r="http://schemas.openxmlformats.org/officeDocument/2006/relationships" xmlns:a="http://schemas.openxmlformats.org/drawingml/2006/main" r:embed="R74eb9b65b90e4c5f"/>
           <a:stretch xmlns:a="http://schemas.openxmlformats.org/drawingml/2006/main"/>
         </p:blipFill>
         <p:spPr>
@@ -7626,7 +7626,7 @@
           <p:cNvPr id="14" name="">
             <a:extLst xmlns:a="http://schemas.openxmlformats.org/drawingml/2006/main">
               <a:ext uri="{FF2B5EF4-FFF2-40B4-BE49-F238E27FC236}">
-                <a16:creationId xmlns:a16="http://schemas.microsoft.com/office/drawing/2014/main" id="{07BBF9B9-0F28-4057-968A-655E1ECC1FD5}"/>
+                <a16:creationId xmlns:a16="http://schemas.microsoft.com/office/drawing/2014/main" id="{049C774A-8E16-44B6-BB56-E0030990B59B}"/>
               </a:ext>
             </a:extLst>
           </p:cNvPr>
@@ -7692,7 +7692,7 @@
           <p:cNvPr id="15" name="">
             <a:extLst xmlns:a="http://schemas.openxmlformats.org/drawingml/2006/main">
               <a:ext uri="{FF2B5EF4-FFF2-40B4-BE49-F238E27FC236}">
-                <a16:creationId xmlns:a16="http://schemas.microsoft.com/office/drawing/2014/main" id="{720A5552-46AC-4344-A8B8-5A6F97C9B94B}"/>
+                <a16:creationId xmlns:a16="http://schemas.microsoft.com/office/drawing/2014/main" id="{B1EB8BB0-F109-475B-823D-C470ADFAC4F1}"/>
               </a:ext>
             </a:extLst>
           </p:cNvPr>
@@ -7756,7 +7756,7 @@
     </p:spTree>
     <p:extLst>
       <p:ext uri="{BB962C8B-B14F-4D97-AF65-F5344CB8AC3E}">
-        <p14:creationId xmlns:p14="http://schemas.microsoft.com/office/powerpoint/2010/main" val="185337237"/>
+        <p14:creationId xmlns:p14="http://schemas.microsoft.com/office/powerpoint/2010/main" val="118096012"/>
       </p:ext>
     </p:extLst>
   </p:cSld>
@@ -7787,7 +7787,7 @@
           <p:cNvPr id="13" name="">
             <a:extLst xmlns:a="http://schemas.openxmlformats.org/drawingml/2006/main">
               <a:ext uri="{FF2B5EF4-FFF2-40B4-BE49-F238E27FC236}">
-                <a16:creationId xmlns:a16="http://schemas.microsoft.com/office/drawing/2014/main" id="{106A9DB0-D96B-4D3E-946A-28D31BD8DCCD}"/>
+                <a16:creationId xmlns:a16="http://schemas.microsoft.com/office/drawing/2014/main" id="{6DC53978-267A-4E97-A54A-2DCBE243F86E}"/>
               </a:ext>
             </a:extLst>
           </p:cNvPr>
@@ -7853,7 +7853,7 @@
           <p:cNvPr id="2" name="">
             <a:extLst xmlns:a="http://schemas.openxmlformats.org/drawingml/2006/main">
               <a:ext uri="{FF2B5EF4-FFF2-40B4-BE49-F238E27FC236}">
-                <a16:creationId xmlns:a16="http://schemas.microsoft.com/office/drawing/2014/main" id="{718E429E-1069-4257-B073-3AB3C88D54FC}"/>
+                <a16:creationId xmlns:a16="http://schemas.microsoft.com/office/drawing/2014/main" id="{338125E5-DC41-466B-A9A6-19164C02BE5E}"/>
               </a:ext>
             </a:extLst>
           </p:cNvPr>
@@ -7919,7 +7919,7 @@
           <p:cNvPr id="3" name="">
             <a:extLst xmlns:a="http://schemas.openxmlformats.org/drawingml/2006/main">
               <a:ext uri="{FF2B5EF4-FFF2-40B4-BE49-F238E27FC236}">
-                <a16:creationId xmlns:a16="http://schemas.microsoft.com/office/drawing/2014/main" id="{48554AC3-728F-4FE1-BAC7-D10A879D0792}"/>
+                <a16:creationId xmlns:a16="http://schemas.microsoft.com/office/drawing/2014/main" id="{80B5CEE9-031B-4E2C-9B45-0272510971AC}"/>
               </a:ext>
             </a:extLst>
           </p:cNvPr>
@@ -7949,7 +7949,7 @@
           <p:cNvPr id="4" name="">
             <a:extLst xmlns:a="http://schemas.openxmlformats.org/drawingml/2006/main">
               <a:ext uri="{FF2B5EF4-FFF2-40B4-BE49-F238E27FC236}">
-                <a16:creationId xmlns:a16="http://schemas.microsoft.com/office/drawing/2014/main" id="{EE4FE98F-948A-41E6-A076-D128AF4D408A}"/>
+                <a16:creationId xmlns:a16="http://schemas.microsoft.com/office/drawing/2014/main" id="{CFBB7E9C-1423-478C-90FA-D164341CD706}"/>
               </a:ext>
             </a:extLst>
           </p:cNvPr>
@@ -8015,7 +8015,7 @@
           <p:cNvPr id="5" name="">
             <a:extLst xmlns:a="http://schemas.openxmlformats.org/drawingml/2006/main">
               <a:ext uri="{FF2B5EF4-FFF2-40B4-BE49-F238E27FC236}">
-                <a16:creationId xmlns:a16="http://schemas.microsoft.com/office/drawing/2014/main" id="{01F2E466-B4F7-4A9E-B1C0-802F153B7072}"/>
+                <a16:creationId xmlns:a16="http://schemas.microsoft.com/office/drawing/2014/main" id="{D7120637-34E2-438C-B66E-403ECC8E3AAC}"/>
               </a:ext>
             </a:extLst>
           </p:cNvPr>
@@ -8081,7 +8081,7 @@
           <p:cNvPr id="6" name="">
             <a:extLst xmlns:a="http://schemas.openxmlformats.org/drawingml/2006/main">
               <a:ext uri="{FF2B5EF4-FFF2-40B4-BE49-F238E27FC236}">
-                <a16:creationId xmlns:a16="http://schemas.microsoft.com/office/drawing/2014/main" id="{151837B3-8DBF-4B36-93BA-B3E2DF9898DA}"/>
+                <a16:creationId xmlns:a16="http://schemas.microsoft.com/office/drawing/2014/main" id="{F7E8C14E-7F7F-4CA7-AE8D-D4478153E8A4}"/>
               </a:ext>
             </a:extLst>
           </p:cNvPr>
@@ -8147,7 +8147,7 @@
           <p:cNvPr id="7" name="">
             <a:extLst xmlns:a="http://schemas.openxmlformats.org/drawingml/2006/main">
               <a:ext uri="{FF2B5EF4-FFF2-40B4-BE49-F238E27FC236}">
-                <a16:creationId xmlns:a16="http://schemas.microsoft.com/office/drawing/2014/main" id="{EF33E1EF-9CDE-493F-BAF4-6CE50EB62482}"/>
+                <a16:creationId xmlns:a16="http://schemas.microsoft.com/office/drawing/2014/main" id="{4DFDF57B-FF23-4E46-A0B8-2C73FE6C1708}"/>
               </a:ext>
             </a:extLst>
           </p:cNvPr>
@@ -8213,7 +8213,7 @@
           <p:cNvPr id="8" name="">
             <a:extLst xmlns:a="http://schemas.openxmlformats.org/drawingml/2006/main">
               <a:ext uri="{FF2B5EF4-FFF2-40B4-BE49-F238E27FC236}">
-                <a16:creationId xmlns:a16="http://schemas.microsoft.com/office/drawing/2014/main" id="{922D23E1-914F-4BD0-A4DA-966B5DC6FD63}"/>
+                <a16:creationId xmlns:a16="http://schemas.microsoft.com/office/drawing/2014/main" id="{CA0321FE-7ACD-4342-9877-3DEC9549F20A}"/>
               </a:ext>
             </a:extLst>
           </p:cNvPr>
@@ -8325,7 +8325,7 @@
           <p:cNvPr id="9" name="">
             <a:extLst xmlns:a="http://schemas.openxmlformats.org/drawingml/2006/main">
               <a:ext uri="{FF2B5EF4-FFF2-40B4-BE49-F238E27FC236}">
-                <a16:creationId xmlns:a16="http://schemas.microsoft.com/office/drawing/2014/main" id="{AFB990E8-7DF1-4AC2-8741-523903396DE2}"/>
+                <a16:creationId xmlns:a16="http://schemas.microsoft.com/office/drawing/2014/main" id="{3631B2C8-4D0F-4506-A7CD-B65FF8C93758}"/>
               </a:ext>
             </a:extLst>
           </p:cNvPr>
@@ -8391,7 +8391,7 @@
           <p:cNvPr id="10" name="">
             <a:extLst xmlns:a="http://schemas.openxmlformats.org/drawingml/2006/main">
               <a:ext uri="{FF2B5EF4-FFF2-40B4-BE49-F238E27FC236}">
-                <a16:creationId xmlns:a16="http://schemas.microsoft.com/office/drawing/2014/main" id="{7AB7A3A7-099A-411C-9D31-458C49CB9072}"/>
+                <a16:creationId xmlns:a16="http://schemas.microsoft.com/office/drawing/2014/main" id="{58D3FB44-43FF-44B7-B54C-3534203B3C91}"/>
               </a:ext>
             </a:extLst>
           </p:cNvPr>
@@ -8503,7 +8503,7 @@
           <p:cNvPr id="11" name="">
             <a:extLst xmlns:a="http://schemas.openxmlformats.org/drawingml/2006/main">
               <a:ext uri="{FF2B5EF4-FFF2-40B4-BE49-F238E27FC236}">
-                <a16:creationId xmlns:a16="http://schemas.microsoft.com/office/drawing/2014/main" id="{307E26DA-B36B-4E89-ACD9-75363DBFC69F}"/>
+                <a16:creationId xmlns:a16="http://schemas.microsoft.com/office/drawing/2014/main" id="{AB9FAC6A-AEA4-4ADF-ACB4-390CA12C2D92}"/>
               </a:ext>
             </a:extLst>
           </p:cNvPr>
@@ -8513,7 +8513,7 @@
           <p:nvPr/>
         </p:nvPicPr>
         <p:blipFill>
-          <a:blip xmlns:r="http://schemas.openxmlformats.org/officeDocument/2006/relationships" xmlns:a="http://schemas.openxmlformats.org/drawingml/2006/main" r:embed="R353590d84333416c"/>
+          <a:blip xmlns:r="http://schemas.openxmlformats.org/officeDocument/2006/relationships" xmlns:a="http://schemas.openxmlformats.org/drawingml/2006/main" r:embed="Rbf202f12f80948c3"/>
           <a:srcRect xmlns:a="http://schemas.openxmlformats.org/drawingml/2006/main" l="48000" t="0" r="0" b="10500"/>
           <a:stretch xmlns:a="http://schemas.openxmlformats.org/drawingml/2006/main"/>
         </p:blipFill>
@@ -8532,7 +8532,7 @@
           <p:cNvPr id="12" name="">
             <a:extLst xmlns:a="http://schemas.openxmlformats.org/drawingml/2006/main">
               <a:ext uri="{FF2B5EF4-FFF2-40B4-BE49-F238E27FC236}">
-                <a16:creationId xmlns:a16="http://schemas.microsoft.com/office/drawing/2014/main" id="{0A8AC8B7-5D1C-46D3-8405-08EEE38DA2B7}"/>
+                <a16:creationId xmlns:a16="http://schemas.microsoft.com/office/drawing/2014/main" id="{058E6899-476C-4237-8564-15EA86EC7396}"/>
               </a:ext>
             </a:extLst>
           </p:cNvPr>
@@ -8596,7 +8596,7 @@
     </p:spTree>
     <p:extLst>
       <p:ext uri="{BB962C8B-B14F-4D97-AF65-F5344CB8AC3E}">
-        <p14:creationId xmlns:p14="http://schemas.microsoft.com/office/powerpoint/2010/main" val="2144077386"/>
+        <p14:creationId xmlns:p14="http://schemas.microsoft.com/office/powerpoint/2010/main" val="594950046"/>
       </p:ext>
     </p:extLst>
   </p:cSld>
@@ -8627,7 +8627,7 @@
           <p:cNvPr id="11" name="">
             <a:extLst xmlns:a="http://schemas.openxmlformats.org/drawingml/2006/main">
               <a:ext uri="{FF2B5EF4-FFF2-40B4-BE49-F238E27FC236}">
-                <a16:creationId xmlns:a16="http://schemas.microsoft.com/office/drawing/2014/main" id="{4052C919-DAA1-4BF5-80BA-DDAA69FC8F79}"/>
+                <a16:creationId xmlns:a16="http://schemas.microsoft.com/office/drawing/2014/main" id="{EE9E392A-BF58-45B3-8528-75FCADB62FFE}"/>
               </a:ext>
             </a:extLst>
           </p:cNvPr>
@@ -8693,7 +8693,7 @@
           <p:cNvPr id="2" name="">
             <a:extLst xmlns:a="http://schemas.openxmlformats.org/drawingml/2006/main">
               <a:ext uri="{FF2B5EF4-FFF2-40B4-BE49-F238E27FC236}">
-                <a16:creationId xmlns:a16="http://schemas.microsoft.com/office/drawing/2014/main" id="{EFC0AF5E-7903-4D6D-86BC-A90AC488D382}"/>
+                <a16:creationId xmlns:a16="http://schemas.microsoft.com/office/drawing/2014/main" id="{F256D5AD-CECB-4C25-9FC7-6154DC490345}"/>
               </a:ext>
             </a:extLst>
           </p:cNvPr>
@@ -8759,7 +8759,7 @@
           <p:cNvPr id="3" name="">
             <a:extLst xmlns:a="http://schemas.openxmlformats.org/drawingml/2006/main">
               <a:ext uri="{FF2B5EF4-FFF2-40B4-BE49-F238E27FC236}">
-                <a16:creationId xmlns:a16="http://schemas.microsoft.com/office/drawing/2014/main" id="{625DCAF1-7974-4E1D-A1FF-2D7F5211D9AE}"/>
+                <a16:creationId xmlns:a16="http://schemas.microsoft.com/office/drawing/2014/main" id="{6F120A6B-8CFD-4A06-81B4-1CC8EA41A5D9}"/>
               </a:ext>
             </a:extLst>
           </p:cNvPr>
@@ -8789,7 +8789,7 @@
           <p:cNvPr id="4" name="">
             <a:extLst xmlns:a="http://schemas.openxmlformats.org/drawingml/2006/main">
               <a:ext uri="{FF2B5EF4-FFF2-40B4-BE49-F238E27FC236}">
-                <a16:creationId xmlns:a16="http://schemas.microsoft.com/office/drawing/2014/main" id="{5B5AAA6F-EF41-46AF-9A70-B7C7B3262B02}"/>
+                <a16:creationId xmlns:a16="http://schemas.microsoft.com/office/drawing/2014/main" id="{B10D92EA-3D4C-444A-9A2A-16131414DF5D}"/>
               </a:ext>
             </a:extLst>
           </p:cNvPr>
@@ -8855,7 +8855,7 @@
           <p:cNvPr id="5" name="">
             <a:extLst xmlns:a="http://schemas.openxmlformats.org/drawingml/2006/main">
               <a:ext uri="{FF2B5EF4-FFF2-40B4-BE49-F238E27FC236}">
-                <a16:creationId xmlns:a16="http://schemas.microsoft.com/office/drawing/2014/main" id="{4A70AABA-0878-4BCC-9386-A8977D0C3BC1}"/>
+                <a16:creationId xmlns:a16="http://schemas.microsoft.com/office/drawing/2014/main" id="{11A6ECB7-18F8-4AE0-A1D1-370CF7B1C554}"/>
               </a:ext>
             </a:extLst>
           </p:cNvPr>
@@ -8921,7 +8921,7 @@
           <p:cNvPr id="6" name="">
             <a:extLst xmlns:a="http://schemas.openxmlformats.org/drawingml/2006/main">
               <a:ext uri="{FF2B5EF4-FFF2-40B4-BE49-F238E27FC236}">
-                <a16:creationId xmlns:a16="http://schemas.microsoft.com/office/drawing/2014/main" id="{E8DFED82-1309-411B-BE9B-8D5B993A2ED4}"/>
+                <a16:creationId xmlns:a16="http://schemas.microsoft.com/office/drawing/2014/main" id="{D15A6773-9067-433D-8183-715897DF235F}"/>
               </a:ext>
             </a:extLst>
           </p:cNvPr>
@@ -8987,7 +8987,7 @@
           <p:cNvPr id="7" name="">
             <a:extLst xmlns:a="http://schemas.openxmlformats.org/drawingml/2006/main">
               <a:ext uri="{FF2B5EF4-FFF2-40B4-BE49-F238E27FC236}">
-                <a16:creationId xmlns:a16="http://schemas.microsoft.com/office/drawing/2014/main" id="{356B60EF-7DFF-4D4E-A706-67ED21C8236B}"/>
+                <a16:creationId xmlns:a16="http://schemas.microsoft.com/office/drawing/2014/main" id="{19B45430-EBC6-41D2-BAC4-567C8DF21B44}"/>
               </a:ext>
             </a:extLst>
           </p:cNvPr>
@@ -9537,7 +9537,7 @@
           <p:cNvPr id="8" name="">
             <a:extLst xmlns:a="http://schemas.openxmlformats.org/drawingml/2006/main">
               <a:ext uri="{FF2B5EF4-FFF2-40B4-BE49-F238E27FC236}">
-                <a16:creationId xmlns:a16="http://schemas.microsoft.com/office/drawing/2014/main" id="{B6AF6D7B-3E4E-40D8-85EA-D2888B1F9F13}"/>
+                <a16:creationId xmlns:a16="http://schemas.microsoft.com/office/drawing/2014/main" id="{2A648DEB-E0DF-47B8-8291-0A5425BCEE7B}"/>
               </a:ext>
             </a:extLst>
           </p:cNvPr>
@@ -9603,7 +9603,7 @@
           <p:cNvPr id="9" name="">
             <a:extLst xmlns:a="http://schemas.openxmlformats.org/drawingml/2006/main">
               <a:ext uri="{FF2B5EF4-FFF2-40B4-BE49-F238E27FC236}">
-                <a16:creationId xmlns:a16="http://schemas.microsoft.com/office/drawing/2014/main" id="{32831B2E-905A-4F60-94F8-436F2D749007}"/>
+                <a16:creationId xmlns:a16="http://schemas.microsoft.com/office/drawing/2014/main" id="{3C04CF8A-4B3F-41E4-9399-F339125632C1}"/>
               </a:ext>
             </a:extLst>
           </p:cNvPr>
@@ -9669,7 +9669,7 @@
           <p:cNvPr id="10" name="">
             <a:extLst xmlns:a="http://schemas.openxmlformats.org/drawingml/2006/main">
               <a:ext uri="{FF2B5EF4-FFF2-40B4-BE49-F238E27FC236}">
-                <a16:creationId xmlns:a16="http://schemas.microsoft.com/office/drawing/2014/main" id="{628EAFDC-50E5-4D05-AEF2-F19D82CAD264}"/>
+                <a16:creationId xmlns:a16="http://schemas.microsoft.com/office/drawing/2014/main" id="{2E32A0A0-143D-4F1C-9B7D-C235BAA51798}"/>
               </a:ext>
             </a:extLst>
           </p:cNvPr>
@@ -9733,7 +9733,7 @@
     </p:spTree>
     <p:extLst>
       <p:ext uri="{BB962C8B-B14F-4D97-AF65-F5344CB8AC3E}">
-        <p14:creationId xmlns:p14="http://schemas.microsoft.com/office/powerpoint/2010/main" val="302739661"/>
+        <p14:creationId xmlns:p14="http://schemas.microsoft.com/office/powerpoint/2010/main" val="1991230628"/>
       </p:ext>
     </p:extLst>
   </p:cSld>
@@ -9764,7 +9764,7 @@
           <p:cNvPr id="17" name="">
             <a:extLst xmlns:a="http://schemas.openxmlformats.org/drawingml/2006/main">
               <a:ext uri="{FF2B5EF4-FFF2-40B4-BE49-F238E27FC236}">
-                <a16:creationId xmlns:a16="http://schemas.microsoft.com/office/drawing/2014/main" id="{E14F415E-E19D-46AB-BDDA-2E20BD9AD3B8}"/>
+                <a16:creationId xmlns:a16="http://schemas.microsoft.com/office/drawing/2014/main" id="{0049B9C3-8339-47BA-A3E5-0BFCE0D17496}"/>
               </a:ext>
             </a:extLst>
           </p:cNvPr>
@@ -9830,7 +9830,7 @@
           <p:cNvPr id="2" name="">
             <a:extLst xmlns:a="http://schemas.openxmlformats.org/drawingml/2006/main">
               <a:ext uri="{FF2B5EF4-FFF2-40B4-BE49-F238E27FC236}">
-                <a16:creationId xmlns:a16="http://schemas.microsoft.com/office/drawing/2014/main" id="{AF89162A-D8FC-4B30-B854-BA6157404750}"/>
+                <a16:creationId xmlns:a16="http://schemas.microsoft.com/office/drawing/2014/main" id="{E9D06EB9-C830-483E-B9BC-94C3E5198BB4}"/>
               </a:ext>
             </a:extLst>
           </p:cNvPr>
@@ -9896,7 +9896,7 @@
           <p:cNvPr id="3" name="">
             <a:extLst xmlns:a="http://schemas.openxmlformats.org/drawingml/2006/main">
               <a:ext uri="{FF2B5EF4-FFF2-40B4-BE49-F238E27FC236}">
-                <a16:creationId xmlns:a16="http://schemas.microsoft.com/office/drawing/2014/main" id="{6E8B73AF-0721-44FA-AAD5-AD1000627CBF}"/>
+                <a16:creationId xmlns:a16="http://schemas.microsoft.com/office/drawing/2014/main" id="{E138EF10-A121-4862-B9D4-62C4DB52AFA3}"/>
               </a:ext>
             </a:extLst>
           </p:cNvPr>
@@ -9926,7 +9926,7 @@
           <p:cNvPr id="4" name="">
             <a:extLst xmlns:a="http://schemas.openxmlformats.org/drawingml/2006/main">
               <a:ext uri="{FF2B5EF4-FFF2-40B4-BE49-F238E27FC236}">
-                <a16:creationId xmlns:a16="http://schemas.microsoft.com/office/drawing/2014/main" id="{029CF862-8C06-44A1-A1A5-95CA4A22D72F}"/>
+                <a16:creationId xmlns:a16="http://schemas.microsoft.com/office/drawing/2014/main" id="{0F2A21EC-629E-4C84-8AB2-09078A5516B8}"/>
               </a:ext>
             </a:extLst>
           </p:cNvPr>
@@ -9992,7 +9992,7 @@
           <p:cNvPr id="5" name="">
             <a:extLst xmlns:a="http://schemas.openxmlformats.org/drawingml/2006/main">
               <a:ext uri="{FF2B5EF4-FFF2-40B4-BE49-F238E27FC236}">
-                <a16:creationId xmlns:a16="http://schemas.microsoft.com/office/drawing/2014/main" id="{5E0E5E62-4C0D-428E-BE1B-2983AB57774F}"/>
+                <a16:creationId xmlns:a16="http://schemas.microsoft.com/office/drawing/2014/main" id="{925BB49A-8DEF-41DD-948C-82B058CC33BA}"/>
               </a:ext>
             </a:extLst>
           </p:cNvPr>
@@ -10058,7 +10058,7 @@
           <p:cNvPr id="6" name="">
             <a:extLst xmlns:a="http://schemas.openxmlformats.org/drawingml/2006/main">
               <a:ext uri="{FF2B5EF4-FFF2-40B4-BE49-F238E27FC236}">
-                <a16:creationId xmlns:a16="http://schemas.microsoft.com/office/drawing/2014/main" id="{910652B0-0FFF-4A39-965D-A7CAF09C85B6}"/>
+                <a16:creationId xmlns:a16="http://schemas.microsoft.com/office/drawing/2014/main" id="{8F41B20B-B953-4AEC-97BD-F6689B09429E}"/>
               </a:ext>
             </a:extLst>
           </p:cNvPr>
@@ -10124,7 +10124,7 @@
           <p:cNvPr id="7" name="">
             <a:extLst xmlns:a="http://schemas.openxmlformats.org/drawingml/2006/main">
               <a:ext uri="{FF2B5EF4-FFF2-40B4-BE49-F238E27FC236}">
-                <a16:creationId xmlns:a16="http://schemas.microsoft.com/office/drawing/2014/main" id="{BAF5C125-C216-42B8-AD80-AAC76AECEE1B}"/>
+                <a16:creationId xmlns:a16="http://schemas.microsoft.com/office/drawing/2014/main" id="{AF9A4233-D473-4413-B632-B2C2E4624D04}"/>
               </a:ext>
             </a:extLst>
           </p:cNvPr>
@@ -10190,7 +10190,7 @@
           <p:cNvPr id="8" name="Chart">
             <a:extLst xmlns:a="http://schemas.openxmlformats.org/drawingml/2006/main">
               <a:ext uri="{FF2B5EF4-FFF2-40B4-BE49-F238E27FC236}">
-                <a16:creationId xmlns:a16="http://schemas.microsoft.com/office/drawing/2014/main" id="{12F37AEF-3195-4476-B680-C3F34B279087}"/>
+                <a16:creationId xmlns:a16="http://schemas.microsoft.com/office/drawing/2014/main" id="{0763DF4B-27CB-4DE2-BD7C-88FA3E020C8C}"/>
               </a:ext>
             </a:extLst>
           </p:cNvPr>
@@ -10203,7 +10203,7 @@
         </p:xfrm>
         <a:graphic xmlns:a="http://schemas.openxmlformats.org/drawingml/2006/main">
           <a:graphicData uri="http://schemas.openxmlformats.org/drawingml/2006/chart">
-            <c:chart xmlns:r="http://schemas.openxmlformats.org/officeDocument/2006/relationships" xmlns:c="http://schemas.openxmlformats.org/drawingml/2006/chart" r:id="R2d82e379b4f84206"/>
+            <c:chart xmlns:r="http://schemas.openxmlformats.org/officeDocument/2006/relationships" xmlns:c="http://schemas.openxmlformats.org/drawingml/2006/chart" r:id="R66637495e50c476f"/>
           </a:graphicData>
         </a:graphic>
       </p:graphicFrame>
@@ -10212,7 +10212,7 @@
           <p:cNvPr id="9" name="">
             <a:extLst xmlns:a="http://schemas.openxmlformats.org/drawingml/2006/main">
               <a:ext uri="{FF2B5EF4-FFF2-40B4-BE49-F238E27FC236}">
-                <a16:creationId xmlns:a16="http://schemas.microsoft.com/office/drawing/2014/main" id="{1F2E172E-3A78-4637-9365-B0C706AEEDCD}"/>
+                <a16:creationId xmlns:a16="http://schemas.microsoft.com/office/drawing/2014/main" id="{1F8AA16F-B381-4E7E-8503-AFC874A3646A}"/>
               </a:ext>
             </a:extLst>
           </p:cNvPr>
@@ -10301,7 +10301,7 @@
           <p:cNvPr id="10" name="">
             <a:extLst xmlns:a="http://schemas.openxmlformats.org/drawingml/2006/main">
               <a:ext uri="{FF2B5EF4-FFF2-40B4-BE49-F238E27FC236}">
-                <a16:creationId xmlns:a16="http://schemas.microsoft.com/office/drawing/2014/main" id="{F006AA63-8A74-40EF-A479-29CDC549FA42}"/>
+                <a16:creationId xmlns:a16="http://schemas.microsoft.com/office/drawing/2014/main" id="{6B4C8031-6937-464B-8B6E-B8DD5BE4BD4A}"/>
               </a:ext>
             </a:extLst>
           </p:cNvPr>
@@ -10367,7 +10367,7 @@
           <p:cNvPr id="11" name="">
             <a:extLst xmlns:a="http://schemas.openxmlformats.org/drawingml/2006/main">
               <a:ext uri="{FF2B5EF4-FFF2-40B4-BE49-F238E27FC236}">
-                <a16:creationId xmlns:a16="http://schemas.microsoft.com/office/drawing/2014/main" id="{8B9DE159-6480-4839-A75A-7E9C17CC5973}"/>
+                <a16:creationId xmlns:a16="http://schemas.microsoft.com/office/drawing/2014/main" id="{D87EADC8-8043-4AD1-9DD1-8ED1A7787FD8}"/>
               </a:ext>
             </a:extLst>
           </p:cNvPr>
@@ -10433,7 +10433,7 @@
           <p:cNvPr id="12" name="">
             <a:extLst xmlns:a="http://schemas.openxmlformats.org/drawingml/2006/main">
               <a:ext uri="{FF2B5EF4-FFF2-40B4-BE49-F238E27FC236}">
-                <a16:creationId xmlns:a16="http://schemas.microsoft.com/office/drawing/2014/main" id="{831D33C3-C678-419A-86B2-27BB252BB693}"/>
+                <a16:creationId xmlns:a16="http://schemas.microsoft.com/office/drawing/2014/main" id="{B32AE396-E726-4089-AA69-2FF00A7AA819}"/>
               </a:ext>
             </a:extLst>
           </p:cNvPr>
@@ -10463,7 +10463,7 @@
           <p:cNvPr id="13" name="">
             <a:extLst xmlns:a="http://schemas.openxmlformats.org/drawingml/2006/main">
               <a:ext uri="{FF2B5EF4-FFF2-40B4-BE49-F238E27FC236}">
-                <a16:creationId xmlns:a16="http://schemas.microsoft.com/office/drawing/2014/main" id="{21ED03F7-9600-47E1-8167-10848A780131}"/>
+                <a16:creationId xmlns:a16="http://schemas.microsoft.com/office/drawing/2014/main" id="{3661E719-7206-4A23-859C-F145F38CD3FF}"/>
               </a:ext>
             </a:extLst>
           </p:cNvPr>
@@ -10529,7 +10529,7 @@
           <p:cNvPr id="14" name="">
             <a:extLst xmlns:a="http://schemas.openxmlformats.org/drawingml/2006/main">
               <a:ext uri="{FF2B5EF4-FFF2-40B4-BE49-F238E27FC236}">
-                <a16:creationId xmlns:a16="http://schemas.microsoft.com/office/drawing/2014/main" id="{E8C9D706-63D3-48EF-B431-8E42FC26ABAF}"/>
+                <a16:creationId xmlns:a16="http://schemas.microsoft.com/office/drawing/2014/main" id="{922192DB-A36D-40C4-A1F9-4599C5273082}"/>
               </a:ext>
             </a:extLst>
           </p:cNvPr>
@@ -10618,7 +10618,7 @@
           <p:cNvPr id="15" name="">
             <a:extLst xmlns:a="http://schemas.openxmlformats.org/drawingml/2006/main">
               <a:ext uri="{FF2B5EF4-FFF2-40B4-BE49-F238E27FC236}">
-                <a16:creationId xmlns:a16="http://schemas.microsoft.com/office/drawing/2014/main" id="{60BA563A-9EFA-4A94-AE0C-D6B4060C67C1}"/>
+                <a16:creationId xmlns:a16="http://schemas.microsoft.com/office/drawing/2014/main" id="{1BD2F011-E25A-4B3F-87F0-F525AC0B11E0}"/>
               </a:ext>
             </a:extLst>
           </p:cNvPr>
@@ -10707,7 +10707,7 @@
           <p:cNvPr id="16" name="">
             <a:extLst xmlns:a="http://schemas.openxmlformats.org/drawingml/2006/main">
               <a:ext uri="{FF2B5EF4-FFF2-40B4-BE49-F238E27FC236}">
-                <a16:creationId xmlns:a16="http://schemas.microsoft.com/office/drawing/2014/main" id="{841BB3C5-6A39-444E-B2CF-985341E49B58}"/>
+                <a16:creationId xmlns:a16="http://schemas.microsoft.com/office/drawing/2014/main" id="{D77ECBB7-FEDB-41D9-98B7-012413F32ADD}"/>
               </a:ext>
             </a:extLst>
           </p:cNvPr>
@@ -10771,7 +10771,7 @@
     </p:spTree>
     <p:extLst>
       <p:ext uri="{BB962C8B-B14F-4D97-AF65-F5344CB8AC3E}">
-        <p14:creationId xmlns:p14="http://schemas.microsoft.com/office/powerpoint/2010/main" val="953611177"/>
+        <p14:creationId xmlns:p14="http://schemas.microsoft.com/office/powerpoint/2010/main" val="193584060"/>
       </p:ext>
     </p:extLst>
   </p:cSld>
@@ -10802,7 +10802,7 @@
           <p:cNvPr id="18" name="">
             <a:extLst xmlns:a="http://schemas.openxmlformats.org/drawingml/2006/main">
               <a:ext uri="{FF2B5EF4-FFF2-40B4-BE49-F238E27FC236}">
-                <a16:creationId xmlns:a16="http://schemas.microsoft.com/office/drawing/2014/main" id="{61BA904D-A14A-4E19-B9F4-02098C908FD4}"/>
+                <a16:creationId xmlns:a16="http://schemas.microsoft.com/office/drawing/2014/main" id="{AD6EB4E1-EAC5-4CF8-81E5-1A38FA29D6E3}"/>
               </a:ext>
             </a:extLst>
           </p:cNvPr>
@@ -10868,7 +10868,7 @@
           <p:cNvPr id="2" name="">
             <a:extLst xmlns:a="http://schemas.openxmlformats.org/drawingml/2006/main">
               <a:ext uri="{FF2B5EF4-FFF2-40B4-BE49-F238E27FC236}">
-                <a16:creationId xmlns:a16="http://schemas.microsoft.com/office/drawing/2014/main" id="{6236DC10-D493-43A7-8B71-CFBDA0795399}"/>
+                <a16:creationId xmlns:a16="http://schemas.microsoft.com/office/drawing/2014/main" id="{AA8150FF-2C4E-45BF-8360-72AA994AC5A4}"/>
               </a:ext>
             </a:extLst>
           </p:cNvPr>
@@ -10934,7 +10934,7 @@
           <p:cNvPr id="3" name="">
             <a:extLst xmlns:a="http://schemas.openxmlformats.org/drawingml/2006/main">
               <a:ext uri="{FF2B5EF4-FFF2-40B4-BE49-F238E27FC236}">
-                <a16:creationId xmlns:a16="http://schemas.microsoft.com/office/drawing/2014/main" id="{92746B08-D736-4E7E-9065-BEE050619572}"/>
+                <a16:creationId xmlns:a16="http://schemas.microsoft.com/office/drawing/2014/main" id="{84A8C663-E016-4F51-A31C-223049D4D601}"/>
               </a:ext>
             </a:extLst>
           </p:cNvPr>
@@ -10964,7 +10964,7 @@
           <p:cNvPr id="4" name="">
             <a:extLst xmlns:a="http://schemas.openxmlformats.org/drawingml/2006/main">
               <a:ext uri="{FF2B5EF4-FFF2-40B4-BE49-F238E27FC236}">
-                <a16:creationId xmlns:a16="http://schemas.microsoft.com/office/drawing/2014/main" id="{C8C70559-8C97-45DC-B389-38B253FDA8F8}"/>
+                <a16:creationId xmlns:a16="http://schemas.microsoft.com/office/drawing/2014/main" id="{B2D94E99-EC65-4255-A3B8-825E80BCCB55}"/>
               </a:ext>
             </a:extLst>
           </p:cNvPr>
@@ -11030,7 +11030,7 @@
           <p:cNvPr id="5" name="">
             <a:extLst xmlns:a="http://schemas.openxmlformats.org/drawingml/2006/main">
               <a:ext uri="{FF2B5EF4-FFF2-40B4-BE49-F238E27FC236}">
-                <a16:creationId xmlns:a16="http://schemas.microsoft.com/office/drawing/2014/main" id="{CA207AC7-B840-4526-A6A5-F5569CE375FD}"/>
+                <a16:creationId xmlns:a16="http://schemas.microsoft.com/office/drawing/2014/main" id="{7BD94685-7FDE-42F0-934F-AAF33E848FE3}"/>
               </a:ext>
             </a:extLst>
           </p:cNvPr>
@@ -11096,7 +11096,7 @@
           <p:cNvPr id="6" name="">
             <a:extLst xmlns:a="http://schemas.openxmlformats.org/drawingml/2006/main">
               <a:ext uri="{FF2B5EF4-FFF2-40B4-BE49-F238E27FC236}">
-                <a16:creationId xmlns:a16="http://schemas.microsoft.com/office/drawing/2014/main" id="{EC67EF33-0B4F-4A8F-8B8B-8C59B2E0D7B5}"/>
+                <a16:creationId xmlns:a16="http://schemas.microsoft.com/office/drawing/2014/main" id="{0C1FC930-D9D0-4561-B3C5-37D031BD1687}"/>
               </a:ext>
             </a:extLst>
           </p:cNvPr>
@@ -11162,7 +11162,7 @@
           <p:cNvPr id="7" name="">
             <a:extLst xmlns:a="http://schemas.openxmlformats.org/drawingml/2006/main">
               <a:ext uri="{FF2B5EF4-FFF2-40B4-BE49-F238E27FC236}">
-                <a16:creationId xmlns:a16="http://schemas.microsoft.com/office/drawing/2014/main" id="{0C87865E-CA6B-4D88-9012-5150564F5BCF}"/>
+                <a16:creationId xmlns:a16="http://schemas.microsoft.com/office/drawing/2014/main" id="{43AD19BC-3785-4A82-A22F-9D1B9EB0E346}"/>
               </a:ext>
             </a:extLst>
           </p:cNvPr>
@@ -11228,7 +11228,7 @@
           <p:cNvPr id="8" name="">
             <a:extLst xmlns:a="http://schemas.openxmlformats.org/drawingml/2006/main">
               <a:ext uri="{FF2B5EF4-FFF2-40B4-BE49-F238E27FC236}">
-                <a16:creationId xmlns:a16="http://schemas.microsoft.com/office/drawing/2014/main" id="{75E1A653-97F6-4B79-8EDF-8A1AC9D02712}"/>
+                <a16:creationId xmlns:a16="http://schemas.microsoft.com/office/drawing/2014/main" id="{CB690FBC-0F50-488B-B34D-46EBE135B579}"/>
               </a:ext>
             </a:extLst>
           </p:cNvPr>
@@ -11258,7 +11258,7 @@
           <p:cNvPr id="9" name="">
             <a:extLst xmlns:a="http://schemas.openxmlformats.org/drawingml/2006/main">
               <a:ext uri="{FF2B5EF4-FFF2-40B4-BE49-F238E27FC236}">
-                <a16:creationId xmlns:a16="http://schemas.microsoft.com/office/drawing/2014/main" id="{0E741ED2-65E1-432D-98A0-34BA222DDA91}"/>
+                <a16:creationId xmlns:a16="http://schemas.microsoft.com/office/drawing/2014/main" id="{AA922B5D-AC28-4B13-BD24-A18C3E443ABE}"/>
               </a:ext>
             </a:extLst>
           </p:cNvPr>
@@ -11347,7 +11347,7 @@
           <p:cNvPr id="10" name="">
             <a:extLst xmlns:a="http://schemas.openxmlformats.org/drawingml/2006/main">
               <a:ext uri="{FF2B5EF4-FFF2-40B4-BE49-F238E27FC236}">
-                <a16:creationId xmlns:a16="http://schemas.microsoft.com/office/drawing/2014/main" id="{7FF1C3AD-54AA-4D52-ABDC-E7D19AD2079D}"/>
+                <a16:creationId xmlns:a16="http://schemas.microsoft.com/office/drawing/2014/main" id="{72274803-5CBB-4636-A8A1-99A66B070708}"/>
               </a:ext>
             </a:extLst>
           </p:cNvPr>
@@ -11413,7 +11413,7 @@
           <p:cNvPr id="11" name="">
             <a:extLst xmlns:a="http://schemas.openxmlformats.org/drawingml/2006/main">
               <a:ext uri="{FF2B5EF4-FFF2-40B4-BE49-F238E27FC236}">
-                <a16:creationId xmlns:a16="http://schemas.microsoft.com/office/drawing/2014/main" id="{1A84CB8A-37F4-41A1-9C38-06D985ED411D}"/>
+                <a16:creationId xmlns:a16="http://schemas.microsoft.com/office/drawing/2014/main" id="{24F8BBA4-93C3-4E12-BBAA-C2A4B1B103A3}"/>
               </a:ext>
             </a:extLst>
           </p:cNvPr>
@@ -11479,7 +11479,7 @@
           <p:cNvPr id="12" name="">
             <a:extLst xmlns:a="http://schemas.openxmlformats.org/drawingml/2006/main">
               <a:ext uri="{FF2B5EF4-FFF2-40B4-BE49-F238E27FC236}">
-                <a16:creationId xmlns:a16="http://schemas.microsoft.com/office/drawing/2014/main" id="{A43956A9-7B3E-42E6-9712-B81DECEECBA3}"/>
+                <a16:creationId xmlns:a16="http://schemas.microsoft.com/office/drawing/2014/main" id="{C8B3CBE9-A9F5-42FA-8847-986C36A35753}"/>
               </a:ext>
             </a:extLst>
           </p:cNvPr>
@@ -11545,7 +11545,7 @@
           <p:cNvPr id="13" name="">
             <a:extLst xmlns:a="http://schemas.openxmlformats.org/drawingml/2006/main">
               <a:ext uri="{FF2B5EF4-FFF2-40B4-BE49-F238E27FC236}">
-                <a16:creationId xmlns:a16="http://schemas.microsoft.com/office/drawing/2014/main" id="{59DC8116-97FE-4823-8A23-6BADA41101E0}"/>
+                <a16:creationId xmlns:a16="http://schemas.microsoft.com/office/drawing/2014/main" id="{E4929A03-630E-4267-A4E3-309B15A8730D}"/>
               </a:ext>
             </a:extLst>
           </p:cNvPr>
@@ -11611,7 +11611,7 @@
           <p:cNvPr id="14" name="">
             <a:extLst xmlns:a="http://schemas.openxmlformats.org/drawingml/2006/main">
               <a:ext uri="{FF2B5EF4-FFF2-40B4-BE49-F238E27FC236}">
-                <a16:creationId xmlns:a16="http://schemas.microsoft.com/office/drawing/2014/main" id="{718CD816-053C-4FA1-947E-01DDDD8F6AC0}"/>
+                <a16:creationId xmlns:a16="http://schemas.microsoft.com/office/drawing/2014/main" id="{6529D846-35EC-45F2-B7B8-E27504559774}"/>
               </a:ext>
             </a:extLst>
           </p:cNvPr>
@@ -11677,7 +11677,7 @@
           <p:cNvPr id="15" name="">
             <a:extLst xmlns:a="http://schemas.openxmlformats.org/drawingml/2006/main">
               <a:ext uri="{FF2B5EF4-FFF2-40B4-BE49-F238E27FC236}">
-                <a16:creationId xmlns:a16="http://schemas.microsoft.com/office/drawing/2014/main" id="{453C826A-88CE-412F-B2A3-86DA1AE51AF9}"/>
+                <a16:creationId xmlns:a16="http://schemas.microsoft.com/office/drawing/2014/main" id="{1B5E9C84-1C12-4AAD-B1FA-4A7F43808ED0}"/>
               </a:ext>
             </a:extLst>
           </p:cNvPr>
@@ -11789,7 +11789,7 @@
           <p:cNvPr id="16" name="">
             <a:extLst xmlns:a="http://schemas.openxmlformats.org/drawingml/2006/main">
               <a:ext uri="{FF2B5EF4-FFF2-40B4-BE49-F238E27FC236}">
-                <a16:creationId xmlns:a16="http://schemas.microsoft.com/office/drawing/2014/main" id="{BE5451A5-E731-4FBE-A047-F394170A5759}"/>
+                <a16:creationId xmlns:a16="http://schemas.microsoft.com/office/drawing/2014/main" id="{24BD9327-5E34-4585-BE49-1F1FE0BA99C4}"/>
               </a:ext>
             </a:extLst>
           </p:cNvPr>
@@ -11855,7 +11855,7 @@
           <p:cNvPr id="17" name="">
             <a:extLst xmlns:a="http://schemas.openxmlformats.org/drawingml/2006/main">
               <a:ext uri="{FF2B5EF4-FFF2-40B4-BE49-F238E27FC236}">
-                <a16:creationId xmlns:a16="http://schemas.microsoft.com/office/drawing/2014/main" id="{676EE689-4E3F-45D1-9E5E-08B9BD0D36A6}"/>
+                <a16:creationId xmlns:a16="http://schemas.microsoft.com/office/drawing/2014/main" id="{2B6F4A74-DD77-4505-A1C1-220EA778FA50}"/>
               </a:ext>
             </a:extLst>
           </p:cNvPr>
@@ -11965,7 +11965,7 @@
     </p:spTree>
     <p:extLst>
       <p:ext uri="{BB962C8B-B14F-4D97-AF65-F5344CB8AC3E}">
-        <p14:creationId xmlns:p14="http://schemas.microsoft.com/office/powerpoint/2010/main" val="691483399"/>
+        <p14:creationId xmlns:p14="http://schemas.microsoft.com/office/powerpoint/2010/main" val="1738783540"/>
       </p:ext>
     </p:extLst>
   </p:cSld>

</xml_diff>

<commit_message>
Clarify the builder problem and Arkiv proof in the final deck
</commit_message>
<xml_diff>
--- a/apps/web/public/downloads/arkiv-graph-pitch.pptx
+++ b/apps/web/public/downloads/arkiv-graph-pitch.pptx
@@ -2,20 +2,20 @@
 <file path=ppt/presentation.xml><?xml version="1.0" encoding="utf-8"?>
 <p:presentation xmlns:p="http://schemas.openxmlformats.org/presentationml/2006/main">
   <p:sldMasterIdLst>
-    <p:sldMasterId xmlns:r="http://schemas.openxmlformats.org/officeDocument/2006/relationships" id="2147483648" r:id="R4e83e70411ca4640"/>
+    <p:sldMasterId xmlns:r="http://schemas.openxmlformats.org/officeDocument/2006/relationships" id="2147483648" r:id="R4be02db97e5a4282"/>
   </p:sldMasterIdLst>
   <p:notesMasterIdLst>
-    <p:notesMasterId xmlns:r="http://schemas.openxmlformats.org/officeDocument/2006/relationships" r:id="R342e4f5ac09541c2"/>
+    <p:notesMasterId xmlns:r="http://schemas.openxmlformats.org/officeDocument/2006/relationships" r:id="R0c484a5c72be4548"/>
   </p:notesMasterIdLst>
   <p:sldIdLst>
-    <p:sldId xmlns:r="http://schemas.openxmlformats.org/officeDocument/2006/relationships" id="256" r:id="R3467675ed2ed4d6c"/>
-    <p:sldId xmlns:r="http://schemas.openxmlformats.org/officeDocument/2006/relationships" id="257" r:id="Rf1f736b88e624c38"/>
-    <p:sldId xmlns:r="http://schemas.openxmlformats.org/officeDocument/2006/relationships" id="258" r:id="R784981ff6a9a49c4"/>
-    <p:sldId xmlns:r="http://schemas.openxmlformats.org/officeDocument/2006/relationships" id="259" r:id="Rcf9049d498814e9e"/>
-    <p:sldId xmlns:r="http://schemas.openxmlformats.org/officeDocument/2006/relationships" id="260" r:id="R1ce55aa065484062"/>
-    <p:sldId xmlns:r="http://schemas.openxmlformats.org/officeDocument/2006/relationships" id="261" r:id="Rc11ac4fed5dc40d2"/>
-    <p:sldId xmlns:r="http://schemas.openxmlformats.org/officeDocument/2006/relationships" id="262" r:id="R0d6af6566c8c4ce6"/>
-    <p:sldId xmlns:r="http://schemas.openxmlformats.org/officeDocument/2006/relationships" id="263" r:id="R06da28804a8c4c7e"/>
+    <p:sldId xmlns:r="http://schemas.openxmlformats.org/officeDocument/2006/relationships" id="256" r:id="R0903433509974533"/>
+    <p:sldId xmlns:r="http://schemas.openxmlformats.org/officeDocument/2006/relationships" id="257" r:id="Rb401b1a88d984291"/>
+    <p:sldId xmlns:r="http://schemas.openxmlformats.org/officeDocument/2006/relationships" id="258" r:id="R41e637b62d35480e"/>
+    <p:sldId xmlns:r="http://schemas.openxmlformats.org/officeDocument/2006/relationships" id="259" r:id="R2cfd8074c14c4184"/>
+    <p:sldId xmlns:r="http://schemas.openxmlformats.org/officeDocument/2006/relationships" id="260" r:id="Rf35012de840f4dc0"/>
+    <p:sldId xmlns:r="http://schemas.openxmlformats.org/officeDocument/2006/relationships" id="261" r:id="R9de2d7d1520e4d6b"/>
+    <p:sldId xmlns:r="http://schemas.openxmlformats.org/officeDocument/2006/relationships" id="262" r:id="R83347c9252964738"/>
+    <p:sldId xmlns:r="http://schemas.openxmlformats.org/officeDocument/2006/relationships" id="263" r:id="R34ec6ca397e64b8f"/>
   </p:sldIdLst>
   <p:sldSz cx="18288000" cy="10287000"/>
   <p:notesSz cx="6858000" cy="9144000"/>
@@ -519,7 +519,7 @@
           <a:lstStyle xmlns:a="http://schemas.openxmlformats.org/drawingml/2006/main"/>
           <a:p xmlns:a="http://schemas.openxmlformats.org/drawingml/2006/main">
             <a:r>
-              <a:t>A coding client receives a reviewed context packet. If the reviewer later withdraws that review, a cached approval can be stale even when the packet's content hash is unchanged. A later client must retrieve and evaluate current evidence before starting the next task. The example is the project-operated session in https://arkivgraph.ajnasnb.com/data/two-client-session.json, not a quantified claim about customer incidents.</a:t>
+              <a:t>An AI tool developer needs a fresh review decision before the next task. A coding client receives a reviewed context packet. If the reviewer later withdraws that review, a cached approval can be stale even when the packet's content hash is unchanged. A later client must retrieve and evaluate current evidence before starting the next task. The example is the project-operated session in https://arkivgraph.ajnasnb.com/data/two-client-session.json, not a quantified claim about customer incidents.</a:t>
             </a:r>
           </a:p>
         </p:txBody>
@@ -729,7 +729,7 @@
           <a:lstStyle xmlns:a="http://schemas.openxmlformats.org/drawingml/2006/main"/>
           <a:p xmlns:a="http://schemas.openxmlformats.org/drawingml/2006/main">
             <a:r>
-              <a:t>AI Passport checks the context review before hosted inference using @cf/meta/llama-3.2-3b-instruct. The coding flow links selected Qarinah context to exact source bytes, interprets a finite guard specification and passes six boundary cases. Generated JavaScript is exported for inspection and is not executed. The screenshot is the recorded15October coding run. India number tutor calculates deterministic exact paise/lakh/crore in English/Hindi. UPI Safety Quest uses project-authored NPCI-linked learning material, deterministic scoring and an optional AI coach. No payment or outside adoption is claimed. https://arkivgraph.ajnasnb.com/data/ai-evaluation.json ; https://arkivgraph.ajnasnb.com/?view=handoff.</a:t>
+              <a:t>AI Passport checks the context review before hosted inference using @cf/meta/llama-3.2-3b-instruct. The coding flow links selected Qarinah context to exact source bytes, interprets a finite guard specification and passes six boundary cases. Generated JavaScript is exported for inspection and is not executed. The screenshot is the recorded 15 October coding run, run ID 351a5039-ff2e-403d-abfc-5363e4120e98, documented in https://arkivgraph.ajnasnb.com/data/launch-capture-evidence.json. The separate eight-case report is https://arkivgraph.ajnasnb.com/data/ai-evaluation.json. India number tutor calculates deterministic exact paise/lakh/crore in English/Hindi. UPI Safety Quest uses project-authored NPCI-linked learning material, deterministic scoring and an optional AI coach. No payment or outside adoption is claimed. https://arkivgraph.ajnasnb.com/?view=handoff.</a:t>
             </a:r>
           </a:p>
         </p:txBody>
@@ -799,7 +799,7 @@
           <a:lstStyle xmlns:a="http://schemas.openxmlformats.org/drawingml/2006/main"/>
           <a:p xmlns:a="http://schemas.openxmlformats.org/drawingml/2006/main">
             <a:r>
-              <a:t>The value used here is shared public indexed discovery outside the originating application API. A controlled failure test blocks this project's domains while a clean npm consumer reads both pinned graphs through Arkiv RPC, checks source bytes and refuses the withdrawn session. A private database can implement the same local graph and verification protocol, but another public discovery layer is needed to preserve cross-application access when the originating API is unavailable. IPFS distributes content-addressed bytes and still needs indexed review/creator discovery. Another public protocol could supply similar properties. Arkiv Graph contributes versioned schema, signed manifest, bounded readers, trust-state handling and CLI/MCP integration. These are present integration advantages. Independent adoption and an ecosystem moat remain unproven. https://arkivgraph.ajnasnb.com/data/backend-independence.json ; https://github.com/AjnasNB/arkiv-graph/blob/main/ARKIV_GRAPH.md.</a:t>
+              <a:t>The value used here is shared public indexed discovery outside the originating application API. In a controlled in-process fetch fault-injection test, an isolated clean npm consumer rejects project API requests while reading both pinned graphs through Arkiv RPC, checking source bytes and refusing the withdrawn session. This is not an actual website outage, OS firewall or network sandbox. A private database can implement the same local graph and verification protocol, but another public discovery layer is needed to preserve cross-application access when the originating API is unavailable. IPFS distributes content-addressed bytes and still needs indexed review/creator discovery. Another public protocol could supply similar properties. Arkiv Graph contributes versioned schema, signed manifest, bounded readers, trust-state handling and CLI/MCP integration. These are present integration advantages. Independent adoption and an ecosystem moat remain unproven. https://arkivgraph.ajnasnb.com/data/backend-independence.json ; https://github.com/AjnasNB/arkiv-graph/blob/main/ARKIV_GRAPH.md.</a:t>
             </a:r>
           </a:p>
         </p:txBody>
@@ -869,7 +869,7 @@
           <a:lstStyle xmlns:a="http://schemas.openxmlformats.org/drawingml/2006/main"/>
           <a:p xmlns:a="http://schemas.openxmlformats.org/drawingml/2006/main">
             <a:r>
-              <a:t>All counts describe project-run checks.271localtests and19trustsafeguards have different scopes. Both public npm packages were installed anonymously outside the workspace and matched reviewed release integrity. Graph0.4.0's exact documented local example passes with2nodes/1edge and fetch disabled. Download statistics for7/30-day windows returned404at2026-10-16T07:21:26.823Z; unavailable is not0users.18historical Lighthouse13.5desktop-simulated mobile audits use3coldruns perroute/phase;87/88/41before and98/98/96after. These scores do not grade later website changes, physical phones, field INP or this hackathon. https://arkivgraph.ajnasnb.com/data/mobile-performance.json ; https://arkivgraph.ajnasnb.com/data/npm-usage.json ; https://arkivgraph.ajnasnb.com/data/quickstart-proof.json ; https://arkivgraph.ajnasnb.com/data/security-evaluation.json.</a:t>
+              <a:t>All counts describe project-run checks. The current full suite passes 274 local tests. These and the 19 trust safeguards have different scopes. Graph 0.4.0 and AI Passport 0.6.0 were installed anonymously outside the workspace and matched reviewed release integrity. Graph 0.4.0's exact documented local example passes with 2 nodes and 1 edge with fetch disabled. The active patch versions shown here are Graph 0.4.1 and AI Passport 0.6.1, published. Historical clean-install evidence remains attributed to its recorded version until refreshed. Download statistics for 7-day and 30-day windows returned HTTP 404 at 2026-10-16T16:20:28.697Z. Unavailable does not mean zero users. The 18 historical Lighthouse 13.5 desktop-simulated mobile audits use 3 cold runs per route and phase. Before scores are 87/88/41 and after scores are 98/98/96. These scores do not grade later website changes, physical phones, field INP or this hackathon. https://arkivgraph.ajnasnb.com/data/mobile-performance.json ; https://arkivgraph.ajnasnb.com/data/npm-usage.json ; https://arkivgraph.ajnasnb.com/data/quickstart-proof.json ; https://arkivgraph.ajnasnb.com/data/security-evaluation.json.</a:t>
             </a:r>
           </a:p>
         </p:txBody>
@@ -939,7 +939,7 @@
           <a:lstStyle xmlns:a="http://schemas.openxmlformats.org/drawingml/2006/main"/>
           <a:p xmlns:a="http://schemas.openxmlformats.org/drawingml/2006/main">
             <a:r>
-              <a:t>Use Node24+. In a new folder npm init -y and npm install @ajnasnb/arkiv-graph@0.4.0. Copy the complete graph.mjs from https://github.com/AjnasNB/arkiv-graph/blob/main/docs/GETTING_STARTED.md before node graph.mjs. That local example validates schema and traversal only. For online reads, independently review issuer/root/chain/profile policy before npx arkiv-graph verify reader.json or npx arkiv-graph mcp reader.json. Readers need no wallet. Publishing requires a funded dedicated Tiramisu testnet wallet and deliberate broadcast. No custom contract deployment is needed. Limits: one live RPC still supplies unseen history/completeness, clearing history loses retained observations, small separate root demo with manual authority/policy rotation, no scale or outside-adoption evidence. Friction https://github.com/AjnasNB/arkiv-graph/blob/main/arkiv/friction.md and schema https://github.com/AjnasNB/arkiv-graph/blob/main/arkiv/schema.md.</a:t>
+              <a:t>Use Node.js 24+. In a new folder run npm init -y and npm install @ajnasnb/arkiv-graph@0.4.1. Graph 0.4.1 is published. Copy the complete graph.mjs from https://github.com/AjnasNB/arkiv-graph/blob/main/docs/GETTING_STARTED.md before node graph.mjs. That local example validates schema and traversal only. For online reads, independently review issuer/root/chain/profile policy before npx arkiv-graph verify reader.json or npx arkiv-graph mcp reader.json. Readers need no wallet. Publishing requires a funded dedicated Tiramisu testnet wallet and deliberate broadcast. No custom contract deployment is needed. Limits: one live RPC still supplies unseen history/completeness, clearing history loses retained observations, small separate root demo with manual authority/policy rotation, no scale or outside-adoption evidence. Friction https://github.com/AjnasNB/arkiv-graph/blob/main/arkiv/friction.md and schema https://github.com/AjnasNB/arkiv-graph/blob/main/arkiv/schema.md.</a:t>
             </a:r>
           </a:p>
         </p:txBody>
@@ -986,7 +986,7 @@
           <p:cNvPr id="3" name="Title">
             <a:extLst xmlns:a="http://schemas.openxmlformats.org/drawingml/2006/main">
               <a:ext uri="{FF2B5EF4-FFF2-40B4-BE49-F238E27FC236}">
-                <a16:creationId xmlns:a16="http://schemas.microsoft.com/office/drawing/2014/main" id="{3451585E-8539-40EC-8565-61EB0CCDE886}"/>
+                <a16:creationId xmlns:a16="http://schemas.microsoft.com/office/drawing/2014/main" id="{64172018-7738-4A31-9468-33FEE3D2F93D}"/>
               </a:ext>
             </a:extLst>
           </p:cNvPr>
@@ -1143,7 +1143,7 @@
           <p:cNvPr id="2" name="Subtitle">
             <a:extLst xmlns:a="http://schemas.openxmlformats.org/drawingml/2006/main">
               <a:ext uri="{FF2B5EF4-FFF2-40B4-BE49-F238E27FC236}">
-                <a16:creationId xmlns:a16="http://schemas.microsoft.com/office/drawing/2014/main" id="{C917930E-5F40-4F35-945E-E6C1795F2382}"/>
+                <a16:creationId xmlns:a16="http://schemas.microsoft.com/office/drawing/2014/main" id="{33EC97AE-ACB4-42A0-8CA7-7E29B5FDEEEF}"/>
               </a:ext>
             </a:extLst>
           </p:cNvPr>
@@ -1317,7 +1317,7 @@
           <p:cNvPr id="2" name="Section title">
             <a:extLst xmlns:a="http://schemas.openxmlformats.org/drawingml/2006/main">
               <a:ext uri="{FF2B5EF4-FFF2-40B4-BE49-F238E27FC236}">
-                <a16:creationId xmlns:a16="http://schemas.microsoft.com/office/drawing/2014/main" id="{8C9AAE0A-FB0A-413E-9E10-794DF41C5A09}"/>
+                <a16:creationId xmlns:a16="http://schemas.microsoft.com/office/drawing/2014/main" id="{F4A58D9F-253C-483B-BE55-D0B90F4A7AD7}"/>
               </a:ext>
             </a:extLst>
           </p:cNvPr>
@@ -1491,7 +1491,7 @@
           <p:cNvPr id="3" name="Title">
             <a:extLst xmlns:a="http://schemas.openxmlformats.org/drawingml/2006/main">
               <a:ext uri="{FF2B5EF4-FFF2-40B4-BE49-F238E27FC236}">
-                <a16:creationId xmlns:a16="http://schemas.microsoft.com/office/drawing/2014/main" id="{4FCFBE10-96F7-4CF4-8C29-18572B1D5360}"/>
+                <a16:creationId xmlns:a16="http://schemas.microsoft.com/office/drawing/2014/main" id="{E7CAF89D-07B9-4C5F-A918-04C43B564A07}"/>
               </a:ext>
             </a:extLst>
           </p:cNvPr>
@@ -1648,7 +1648,7 @@
           <p:cNvPr id="2" name="Body">
             <a:extLst xmlns:a="http://schemas.openxmlformats.org/drawingml/2006/main">
               <a:ext uri="{FF2B5EF4-FFF2-40B4-BE49-F238E27FC236}">
-                <a16:creationId xmlns:a16="http://schemas.microsoft.com/office/drawing/2014/main" id="{46E60E40-8B15-4070-A73F-6AD9F93246D4}"/>
+                <a16:creationId xmlns:a16="http://schemas.microsoft.com/office/drawing/2014/main" id="{B78FAB2D-F3A7-48A7-9570-32A47B4FFB6C}"/>
               </a:ext>
             </a:extLst>
           </p:cNvPr>
@@ -1822,7 +1822,7 @@
           <p:cNvPr id="4" name="Title">
             <a:extLst xmlns:a="http://schemas.openxmlformats.org/drawingml/2006/main">
               <a:ext uri="{FF2B5EF4-FFF2-40B4-BE49-F238E27FC236}">
-                <a16:creationId xmlns:a16="http://schemas.microsoft.com/office/drawing/2014/main" id="{CBE5E132-E22E-4CD8-8878-4E465A9158EF}"/>
+                <a16:creationId xmlns:a16="http://schemas.microsoft.com/office/drawing/2014/main" id="{24A5C065-FBCA-48BE-B48F-246E5D9884AE}"/>
               </a:ext>
             </a:extLst>
           </p:cNvPr>
@@ -1979,7 +1979,7 @@
           <p:cNvPr id="2" name="Left column">
             <a:extLst xmlns:a="http://schemas.openxmlformats.org/drawingml/2006/main">
               <a:ext uri="{FF2B5EF4-FFF2-40B4-BE49-F238E27FC236}">
-                <a16:creationId xmlns:a16="http://schemas.microsoft.com/office/drawing/2014/main" id="{D3CEF924-1CED-49F1-90C1-C7753662483D}"/>
+                <a16:creationId xmlns:a16="http://schemas.microsoft.com/office/drawing/2014/main" id="{993164F2-242F-4D8B-9D84-C47B5CC5A0CB}"/>
               </a:ext>
             </a:extLst>
           </p:cNvPr>
@@ -2136,7 +2136,7 @@
           <p:cNvPr id="3" name="Right column">
             <a:extLst xmlns:a="http://schemas.openxmlformats.org/drawingml/2006/main">
               <a:ext uri="{FF2B5EF4-FFF2-40B4-BE49-F238E27FC236}">
-                <a16:creationId xmlns:a16="http://schemas.microsoft.com/office/drawing/2014/main" id="{F1C15449-7685-4E12-A0A5-B675327E7AA4}"/>
+                <a16:creationId xmlns:a16="http://schemas.microsoft.com/office/drawing/2014/main" id="{E6A3B6EA-BA30-4ACC-97B0-C3F43148DEDE}"/>
               </a:ext>
             </a:extLst>
           </p:cNvPr>
@@ -2310,7 +2310,7 @@
           <p:cNvPr id="3" name="Title">
             <a:extLst xmlns:a="http://schemas.openxmlformats.org/drawingml/2006/main">
               <a:ext uri="{FF2B5EF4-FFF2-40B4-BE49-F238E27FC236}">
-                <a16:creationId xmlns:a16="http://schemas.microsoft.com/office/drawing/2014/main" id="{D368F10B-1590-4989-ABB9-3C50C8239509}"/>
+                <a16:creationId xmlns:a16="http://schemas.microsoft.com/office/drawing/2014/main" id="{3B7C8AC1-57BB-4C60-B210-C37686D4C404}"/>
               </a:ext>
             </a:extLst>
           </p:cNvPr>
@@ -2467,7 +2467,7 @@
           <p:cNvPr id="2" name="Left column">
             <a:extLst xmlns:a="http://schemas.openxmlformats.org/drawingml/2006/main">
               <a:ext uri="{FF2B5EF4-FFF2-40B4-BE49-F238E27FC236}">
-                <a16:creationId xmlns:a16="http://schemas.microsoft.com/office/drawing/2014/main" id="{20C638FB-2BCF-44C7-8913-FA9CF1340442}"/>
+                <a16:creationId xmlns:a16="http://schemas.microsoft.com/office/drawing/2014/main" id="{5C915635-6291-42BE-A0BF-539A92DC57F3}"/>
               </a:ext>
             </a:extLst>
           </p:cNvPr>
@@ -2662,12 +2662,12 @@
   </p:cSld>
   <p:clrMap bg1="lt1" tx1="dk1" bg2="lt2" tx2="dk2" accent1="accent1" accent2="accent2" accent3="accent3" accent4="accent4" accent5="accent5" accent6="accent6" hlink="hlink" folHlink="folHlink"/>
   <p:sldLayoutIdLst>
-    <p:sldLayoutId xmlns:r="http://schemas.openxmlformats.org/officeDocument/2006/relationships" id="2147483649" r:id="Rbd658da0326643c8"/>
-    <p:sldLayoutId xmlns:r="http://schemas.openxmlformats.org/officeDocument/2006/relationships" id="2147483650" r:id="R90b759bb5dcb4d4b"/>
-    <p:sldLayoutId xmlns:r="http://schemas.openxmlformats.org/officeDocument/2006/relationships" id="2147483651" r:id="R9788bb0678234863"/>
-    <p:sldLayoutId xmlns:r="http://schemas.openxmlformats.org/officeDocument/2006/relationships" id="2147483652" r:id="R64f1d04dec01455e"/>
-    <p:sldLayoutId xmlns:r="http://schemas.openxmlformats.org/officeDocument/2006/relationships" id="2147483653" r:id="Re5ccb1eb630442b0"/>
-    <p:sldLayoutId xmlns:r="http://schemas.openxmlformats.org/officeDocument/2006/relationships" id="2147483654" r:id="R53bf817631d9483c"/>
+    <p:sldLayoutId xmlns:r="http://schemas.openxmlformats.org/officeDocument/2006/relationships" id="2147483649" r:id="R62d0f7ef0bee4ea9"/>
+    <p:sldLayoutId xmlns:r="http://schemas.openxmlformats.org/officeDocument/2006/relationships" id="2147483650" r:id="R498334d1a2af40c9"/>
+    <p:sldLayoutId xmlns:r="http://schemas.openxmlformats.org/officeDocument/2006/relationships" id="2147483651" r:id="Rafe44591c0e94e7a"/>
+    <p:sldLayoutId xmlns:r="http://schemas.openxmlformats.org/officeDocument/2006/relationships" id="2147483652" r:id="R1eba727621ac40fd"/>
+    <p:sldLayoutId xmlns:r="http://schemas.openxmlformats.org/officeDocument/2006/relationships" id="2147483653" r:id="R6b199df99d2045d1"/>
+    <p:sldLayoutId xmlns:r="http://schemas.openxmlformats.org/officeDocument/2006/relationships" id="2147483654" r:id="Raf805a8f8bdd4814"/>
   </p:sldLayoutIdLst>
   <p:txStyles>
     <p:titleStyle>
@@ -3480,7 +3480,7 @@
           <p:cNvPr id="12" name="">
             <a:extLst xmlns:a="http://schemas.openxmlformats.org/drawingml/2006/main">
               <a:ext uri="{FF2B5EF4-FFF2-40B4-BE49-F238E27FC236}">
-                <a16:creationId xmlns:a16="http://schemas.microsoft.com/office/drawing/2014/main" id="{206A2F7D-68B5-44FD-9FE0-8693BBB4FD1B}"/>
+                <a16:creationId xmlns:a16="http://schemas.microsoft.com/office/drawing/2014/main" id="{0A6A26D2-DD4E-4871-B86A-33D6E5A9ECA0}"/>
               </a:ext>
             </a:extLst>
           </p:cNvPr>
@@ -3546,7 +3546,7 @@
           <p:cNvPr id="2" name="">
             <a:extLst xmlns:a="http://schemas.openxmlformats.org/drawingml/2006/main">
               <a:ext uri="{FF2B5EF4-FFF2-40B4-BE49-F238E27FC236}">
-                <a16:creationId xmlns:a16="http://schemas.microsoft.com/office/drawing/2014/main" id="{2F605279-2872-4142-9BEF-635088336FBE}"/>
+                <a16:creationId xmlns:a16="http://schemas.microsoft.com/office/drawing/2014/main" id="{D66E2E23-E2AF-4044-9060-8178A71CF789}"/>
               </a:ext>
             </a:extLst>
           </p:cNvPr>
@@ -3612,7 +3612,7 @@
           <p:cNvPr id="3" name="">
             <a:extLst xmlns:a="http://schemas.openxmlformats.org/drawingml/2006/main">
               <a:ext uri="{FF2B5EF4-FFF2-40B4-BE49-F238E27FC236}">
-                <a16:creationId xmlns:a16="http://schemas.microsoft.com/office/drawing/2014/main" id="{51827CFC-E304-4E0C-83D9-35B70AE5F229}"/>
+                <a16:creationId xmlns:a16="http://schemas.microsoft.com/office/drawing/2014/main" id="{20507DB1-AA17-401C-8D0F-21FC31868D93}"/>
               </a:ext>
             </a:extLst>
           </p:cNvPr>
@@ -3642,7 +3642,7 @@
           <p:cNvPr id="4" name="">
             <a:extLst xmlns:a="http://schemas.openxmlformats.org/drawingml/2006/main">
               <a:ext uri="{FF2B5EF4-FFF2-40B4-BE49-F238E27FC236}">
-                <a16:creationId xmlns:a16="http://schemas.microsoft.com/office/drawing/2014/main" id="{0C64E689-7671-4340-88AE-24DDCFDDDE70}"/>
+                <a16:creationId xmlns:a16="http://schemas.microsoft.com/office/drawing/2014/main" id="{4FAB199E-FA5A-41CF-8E76-A1140BA77E3A}"/>
               </a:ext>
             </a:extLst>
           </p:cNvPr>
@@ -3708,7 +3708,7 @@
           <p:cNvPr id="5" name="">
             <a:extLst xmlns:a="http://schemas.openxmlformats.org/drawingml/2006/main">
               <a:ext uri="{FF2B5EF4-FFF2-40B4-BE49-F238E27FC236}">
-                <a16:creationId xmlns:a16="http://schemas.microsoft.com/office/drawing/2014/main" id="{7AF4FF5A-9D17-4A54-96A4-C798E053714B}"/>
+                <a16:creationId xmlns:a16="http://schemas.microsoft.com/office/drawing/2014/main" id="{334C0271-DC9E-4EF4-BF83-1254818C45DA}"/>
               </a:ext>
             </a:extLst>
           </p:cNvPr>
@@ -3774,7 +3774,7 @@
           <p:cNvPr id="6" name="">
             <a:extLst xmlns:a="http://schemas.openxmlformats.org/drawingml/2006/main">
               <a:ext uri="{FF2B5EF4-FFF2-40B4-BE49-F238E27FC236}">
-                <a16:creationId xmlns:a16="http://schemas.microsoft.com/office/drawing/2014/main" id="{181028E4-B5AD-4BC1-8C30-9E9546431741}"/>
+                <a16:creationId xmlns:a16="http://schemas.microsoft.com/office/drawing/2014/main" id="{C667A47F-955B-4AA1-AABD-7F5A97895671}"/>
               </a:ext>
             </a:extLst>
           </p:cNvPr>
@@ -3840,7 +3840,7 @@
           <p:cNvPr id="7" name="">
             <a:extLst xmlns:a="http://schemas.openxmlformats.org/drawingml/2006/main">
               <a:ext uri="{FF2B5EF4-FFF2-40B4-BE49-F238E27FC236}">
-                <a16:creationId xmlns:a16="http://schemas.microsoft.com/office/drawing/2014/main" id="{F606A571-2467-4105-82FD-FCF9DB0E9D9C}"/>
+                <a16:creationId xmlns:a16="http://schemas.microsoft.com/office/drawing/2014/main" id="{B99D729B-810F-47AD-AEB8-0A0888144B3A}"/>
               </a:ext>
             </a:extLst>
           </p:cNvPr>
@@ -3929,7 +3929,7 @@
           <p:cNvPr id="8" name="">
             <a:extLst xmlns:a="http://schemas.openxmlformats.org/drawingml/2006/main">
               <a:ext uri="{FF2B5EF4-FFF2-40B4-BE49-F238E27FC236}">
-                <a16:creationId xmlns:a16="http://schemas.microsoft.com/office/drawing/2014/main" id="{8660A22B-0C60-4C59-A03E-A00CAD336925}"/>
+                <a16:creationId xmlns:a16="http://schemas.microsoft.com/office/drawing/2014/main" id="{BAC982E9-68BA-4765-9E41-4D479C992989}"/>
               </a:ext>
             </a:extLst>
           </p:cNvPr>
@@ -4018,7 +4018,7 @@
           <p:cNvPr id="9" name="">
             <a:extLst xmlns:a="http://schemas.openxmlformats.org/drawingml/2006/main">
               <a:ext uri="{FF2B5EF4-FFF2-40B4-BE49-F238E27FC236}">
-                <a16:creationId xmlns:a16="http://schemas.microsoft.com/office/drawing/2014/main" id="{36CDE356-1E0F-4AD9-AB77-42F03C3D5D0C}"/>
+                <a16:creationId xmlns:a16="http://schemas.microsoft.com/office/drawing/2014/main" id="{3880B861-00BB-495B-A8AD-7130EF4ACA13}"/>
               </a:ext>
             </a:extLst>
           </p:cNvPr>
@@ -4107,7 +4107,7 @@
           <p:cNvPr id="10" name="">
             <a:extLst xmlns:a="http://schemas.openxmlformats.org/drawingml/2006/main">
               <a:ext uri="{FF2B5EF4-FFF2-40B4-BE49-F238E27FC236}">
-                <a16:creationId xmlns:a16="http://schemas.microsoft.com/office/drawing/2014/main" id="{95313F3C-CA4F-4AFC-9B8B-6B1B2F97152A}"/>
+                <a16:creationId xmlns:a16="http://schemas.microsoft.com/office/drawing/2014/main" id="{5EEB7328-9747-41FD-8A6E-1CC7A0DDBC3C}"/>
               </a:ext>
             </a:extLst>
           </p:cNvPr>
@@ -4117,7 +4117,7 @@
           <p:nvPr/>
         </p:nvPicPr>
         <p:blipFill>
-          <a:blip xmlns:r="http://schemas.openxmlformats.org/officeDocument/2006/relationships" xmlns:a="http://schemas.openxmlformats.org/drawingml/2006/main" r:embed="R23865e238f004bdd"/>
+          <a:blip xmlns:r="http://schemas.openxmlformats.org/officeDocument/2006/relationships" xmlns:a="http://schemas.openxmlformats.org/drawingml/2006/main" r:embed="Ra8a4e1dde4b74876"/>
           <a:stretch xmlns:a="http://schemas.openxmlformats.org/drawingml/2006/main"/>
         </p:blipFill>
         <p:spPr>
@@ -4135,7 +4135,7 @@
           <p:cNvPr id="11" name="">
             <a:extLst xmlns:a="http://schemas.openxmlformats.org/drawingml/2006/main">
               <a:ext uri="{FF2B5EF4-FFF2-40B4-BE49-F238E27FC236}">
-                <a16:creationId xmlns:a16="http://schemas.microsoft.com/office/drawing/2014/main" id="{F69D500E-C9B3-4012-8AC2-4C9F878EB816}"/>
+                <a16:creationId xmlns:a16="http://schemas.microsoft.com/office/drawing/2014/main" id="{8FD6FF77-97BB-4B33-94EB-5BC8F3C80295}"/>
               </a:ext>
             </a:extLst>
           </p:cNvPr>
@@ -4199,7 +4199,7 @@
     </p:spTree>
     <p:extLst>
       <p:ext uri="{BB962C8B-B14F-4D97-AF65-F5344CB8AC3E}">
-        <p14:creationId xmlns:p14="http://schemas.microsoft.com/office/powerpoint/2010/main" val="956176809"/>
+        <p14:creationId xmlns:p14="http://schemas.microsoft.com/office/powerpoint/2010/main" val="642558421"/>
       </p:ext>
     </p:extLst>
   </p:cSld>
@@ -4230,7 +4230,7 @@
           <p:cNvPr id="17" name="">
             <a:extLst xmlns:a="http://schemas.openxmlformats.org/drawingml/2006/main">
               <a:ext uri="{FF2B5EF4-FFF2-40B4-BE49-F238E27FC236}">
-                <a16:creationId xmlns:a16="http://schemas.microsoft.com/office/drawing/2014/main" id="{BE6827E8-40F0-4457-9F42-C9B28D926C25}"/>
+                <a16:creationId xmlns:a16="http://schemas.microsoft.com/office/drawing/2014/main" id="{84DD1D04-6610-4E21-ABF1-CCDF7FF698B4}"/>
               </a:ext>
             </a:extLst>
           </p:cNvPr>
@@ -4296,7 +4296,7 @@
           <p:cNvPr id="2" name="">
             <a:extLst xmlns:a="http://schemas.openxmlformats.org/drawingml/2006/main">
               <a:ext uri="{FF2B5EF4-FFF2-40B4-BE49-F238E27FC236}">
-                <a16:creationId xmlns:a16="http://schemas.microsoft.com/office/drawing/2014/main" id="{4EA1A273-ED8A-4B5E-AAE8-92716B996902}"/>
+                <a16:creationId xmlns:a16="http://schemas.microsoft.com/office/drawing/2014/main" id="{E4A4E097-F73D-44EA-B9E5-6818AD16F7C0}"/>
               </a:ext>
             </a:extLst>
           </p:cNvPr>
@@ -4362,7 +4362,7 @@
           <p:cNvPr id="3" name="">
             <a:extLst xmlns:a="http://schemas.openxmlformats.org/drawingml/2006/main">
               <a:ext uri="{FF2B5EF4-FFF2-40B4-BE49-F238E27FC236}">
-                <a16:creationId xmlns:a16="http://schemas.microsoft.com/office/drawing/2014/main" id="{224F233C-C104-44F3-9FDE-E62D0BEE3100}"/>
+                <a16:creationId xmlns:a16="http://schemas.microsoft.com/office/drawing/2014/main" id="{967CC1EA-3DC8-4E1A-BB6E-D4C9E59A4B9B}"/>
               </a:ext>
             </a:extLst>
           </p:cNvPr>
@@ -4392,7 +4392,7 @@
           <p:cNvPr id="4" name="">
             <a:extLst xmlns:a="http://schemas.openxmlformats.org/drawingml/2006/main">
               <a:ext uri="{FF2B5EF4-FFF2-40B4-BE49-F238E27FC236}">
-                <a16:creationId xmlns:a16="http://schemas.microsoft.com/office/drawing/2014/main" id="{81C3DF52-B458-45FA-9C9B-FC872D4CC6C3}"/>
+                <a16:creationId xmlns:a16="http://schemas.microsoft.com/office/drawing/2014/main" id="{562D1634-750E-49EB-8C7D-3070832A1F1B}"/>
               </a:ext>
             </a:extLst>
           </p:cNvPr>
@@ -4458,7 +4458,7 @@
           <p:cNvPr id="5" name="">
             <a:extLst xmlns:a="http://schemas.openxmlformats.org/drawingml/2006/main">
               <a:ext uri="{FF2B5EF4-FFF2-40B4-BE49-F238E27FC236}">
-                <a16:creationId xmlns:a16="http://schemas.microsoft.com/office/drawing/2014/main" id="{7CAE9902-AA49-4C83-A8E2-65D14A2B6108}"/>
+                <a16:creationId xmlns:a16="http://schemas.microsoft.com/office/drawing/2014/main" id="{91FC4439-0AF5-4A42-B020-C0ED9A97D31F}"/>
               </a:ext>
             </a:extLst>
           </p:cNvPr>
@@ -4524,7 +4524,7 @@
           <p:cNvPr id="6" name="">
             <a:extLst xmlns:a="http://schemas.openxmlformats.org/drawingml/2006/main">
               <a:ext uri="{FF2B5EF4-FFF2-40B4-BE49-F238E27FC236}">
-                <a16:creationId xmlns:a16="http://schemas.microsoft.com/office/drawing/2014/main" id="{75AA0970-AFED-40AA-A2A1-5447898AB9D7}"/>
+                <a16:creationId xmlns:a16="http://schemas.microsoft.com/office/drawing/2014/main" id="{856343D1-86DB-4E3A-B274-CF96226A5911}"/>
               </a:ext>
             </a:extLst>
           </p:cNvPr>
@@ -4613,7 +4613,7 @@
           <p:cNvPr id="7" name="">
             <a:extLst xmlns:a="http://schemas.openxmlformats.org/drawingml/2006/main">
               <a:ext uri="{FF2B5EF4-FFF2-40B4-BE49-F238E27FC236}">
-                <a16:creationId xmlns:a16="http://schemas.microsoft.com/office/drawing/2014/main" id="{DF55ACA3-9C38-4BDF-8878-4F35E971F9DE}"/>
+                <a16:creationId xmlns:a16="http://schemas.microsoft.com/office/drawing/2014/main" id="{FA8E0C72-6640-49D8-82B5-554F390B04BC}"/>
               </a:ext>
             </a:extLst>
           </p:cNvPr>
@@ -4669,7 +4669,7 @@
                 <a:ea typeface="Arial"/>
                 <a:cs typeface="Arial"/>
               </a:rPr>
-              <a:t>A second AI tool needs more than the old approval.</a:t>
+              <a:t>AI tool developers need a fresh review decision before the next task.</a:t>
             </a:r>
           </a:p>
         </p:txBody>
@@ -4679,7 +4679,7 @@
           <p:cNvPr id="8" name="">
             <a:extLst xmlns:a="http://schemas.openxmlformats.org/drawingml/2006/main">
               <a:ext uri="{FF2B5EF4-FFF2-40B4-BE49-F238E27FC236}">
-                <a16:creationId xmlns:a16="http://schemas.microsoft.com/office/drawing/2014/main" id="{9DF562D0-0791-4878-A203-7729267D29A1}"/>
+                <a16:creationId xmlns:a16="http://schemas.microsoft.com/office/drawing/2014/main" id="{4CBFC348-FC77-46D8-A45B-B95A31F7E345}"/>
               </a:ext>
             </a:extLst>
           </p:cNvPr>
@@ -4745,7 +4745,7 @@
           <p:cNvPr id="9" name="">
             <a:extLst xmlns:a="http://schemas.openxmlformats.org/drawingml/2006/main">
               <a:ext uri="{FF2B5EF4-FFF2-40B4-BE49-F238E27FC236}">
-                <a16:creationId xmlns:a16="http://schemas.microsoft.com/office/drawing/2014/main" id="{E0CCC5B4-E2CF-418C-A2E3-37CB3BA7129C}"/>
+                <a16:creationId xmlns:a16="http://schemas.microsoft.com/office/drawing/2014/main" id="{1D2D980B-4010-45AD-9BE2-798C409F5E58}"/>
               </a:ext>
             </a:extLst>
           </p:cNvPr>
@@ -4811,7 +4811,7 @@
           <p:cNvPr id="10" name="">
             <a:extLst xmlns:a="http://schemas.openxmlformats.org/drawingml/2006/main">
               <a:ext uri="{FF2B5EF4-FFF2-40B4-BE49-F238E27FC236}">
-                <a16:creationId xmlns:a16="http://schemas.microsoft.com/office/drawing/2014/main" id="{0285B78C-758C-40AD-B5E1-ED663693D40F}"/>
+                <a16:creationId xmlns:a16="http://schemas.microsoft.com/office/drawing/2014/main" id="{4C9F3D91-8E5E-4729-919A-FB4F60062C28}"/>
               </a:ext>
             </a:extLst>
           </p:cNvPr>
@@ -4841,7 +4841,7 @@
           <p:cNvPr id="11" name="">
             <a:extLst xmlns:a="http://schemas.openxmlformats.org/drawingml/2006/main">
               <a:ext uri="{FF2B5EF4-FFF2-40B4-BE49-F238E27FC236}">
-                <a16:creationId xmlns:a16="http://schemas.microsoft.com/office/drawing/2014/main" id="{406D58FB-F412-419D-906B-E7BCCF8CE13A}"/>
+                <a16:creationId xmlns:a16="http://schemas.microsoft.com/office/drawing/2014/main" id="{F213EC8B-01C9-45B7-AAF4-EDE75AA81B51}"/>
               </a:ext>
             </a:extLst>
           </p:cNvPr>
@@ -4907,7 +4907,7 @@
           <p:cNvPr id="12" name="">
             <a:extLst xmlns:a="http://schemas.openxmlformats.org/drawingml/2006/main">
               <a:ext uri="{FF2B5EF4-FFF2-40B4-BE49-F238E27FC236}">
-                <a16:creationId xmlns:a16="http://schemas.microsoft.com/office/drawing/2014/main" id="{653E8090-5DE6-4EAD-B1DC-9A3B2A013D70}"/>
+                <a16:creationId xmlns:a16="http://schemas.microsoft.com/office/drawing/2014/main" id="{4BDEE575-2174-4CC9-9F81-998E23766262}"/>
               </a:ext>
             </a:extLst>
           </p:cNvPr>
@@ -4996,7 +4996,7 @@
           <p:cNvPr id="13" name="">
             <a:extLst xmlns:a="http://schemas.openxmlformats.org/drawingml/2006/main">
               <a:ext uri="{FF2B5EF4-FFF2-40B4-BE49-F238E27FC236}">
-                <a16:creationId xmlns:a16="http://schemas.microsoft.com/office/drawing/2014/main" id="{42D11487-B68D-483C-8F34-3EEFEDC34BC4}"/>
+                <a16:creationId xmlns:a16="http://schemas.microsoft.com/office/drawing/2014/main" id="{EF5E4158-AF33-44FF-B679-6D4CD7B35E9A}"/>
               </a:ext>
             </a:extLst>
           </p:cNvPr>
@@ -5062,7 +5062,7 @@
           <p:cNvPr id="14" name="">
             <a:extLst xmlns:a="http://schemas.openxmlformats.org/drawingml/2006/main">
               <a:ext uri="{FF2B5EF4-FFF2-40B4-BE49-F238E27FC236}">
-                <a16:creationId xmlns:a16="http://schemas.microsoft.com/office/drawing/2014/main" id="{075F639B-E7F0-4EB6-B484-4998A242EF75}"/>
+                <a16:creationId xmlns:a16="http://schemas.microsoft.com/office/drawing/2014/main" id="{33EF0DBD-1E31-4A02-BAC7-77CEA7F52180}"/>
               </a:ext>
             </a:extLst>
           </p:cNvPr>
@@ -5151,7 +5151,7 @@
           <p:cNvPr id="15" name="">
             <a:extLst xmlns:a="http://schemas.openxmlformats.org/drawingml/2006/main">
               <a:ext uri="{FF2B5EF4-FFF2-40B4-BE49-F238E27FC236}">
-                <a16:creationId xmlns:a16="http://schemas.microsoft.com/office/drawing/2014/main" id="{0564567A-C39F-4B26-A529-D44DA276F923}"/>
+                <a16:creationId xmlns:a16="http://schemas.microsoft.com/office/drawing/2014/main" id="{B7D68905-3CB2-42DE-B089-425E59621B54}"/>
               </a:ext>
             </a:extLst>
           </p:cNvPr>
@@ -5217,7 +5217,7 @@
           <p:cNvPr id="16" name="">
             <a:extLst xmlns:a="http://schemas.openxmlformats.org/drawingml/2006/main">
               <a:ext uri="{FF2B5EF4-FFF2-40B4-BE49-F238E27FC236}">
-                <a16:creationId xmlns:a16="http://schemas.microsoft.com/office/drawing/2014/main" id="{FF55A032-8793-4782-BD2F-1F199A1EE6CD}"/>
+                <a16:creationId xmlns:a16="http://schemas.microsoft.com/office/drawing/2014/main" id="{E7B20D8F-7F66-424F-A4E9-4F4FC271D49B}"/>
               </a:ext>
             </a:extLst>
           </p:cNvPr>
@@ -5304,7 +5304,7 @@
     </p:spTree>
     <p:extLst>
       <p:ext uri="{BB962C8B-B14F-4D97-AF65-F5344CB8AC3E}">
-        <p14:creationId xmlns:p14="http://schemas.microsoft.com/office/powerpoint/2010/main" val="708456314"/>
+        <p14:creationId xmlns:p14="http://schemas.microsoft.com/office/powerpoint/2010/main" val="453027141"/>
       </p:ext>
     </p:extLst>
   </p:cSld>
@@ -5335,7 +5335,7 @@
           <p:cNvPr id="23" name="">
             <a:extLst xmlns:a="http://schemas.openxmlformats.org/drawingml/2006/main">
               <a:ext uri="{FF2B5EF4-FFF2-40B4-BE49-F238E27FC236}">
-                <a16:creationId xmlns:a16="http://schemas.microsoft.com/office/drawing/2014/main" id="{382A296E-3611-48CF-978A-89C9D76562AF}"/>
+                <a16:creationId xmlns:a16="http://schemas.microsoft.com/office/drawing/2014/main" id="{C5800D60-DEFE-4029-9FCA-3FC48DE19A1E}"/>
               </a:ext>
             </a:extLst>
           </p:cNvPr>
@@ -5401,7 +5401,7 @@
           <p:cNvPr id="2" name="">
             <a:extLst xmlns:a="http://schemas.openxmlformats.org/drawingml/2006/main">
               <a:ext uri="{FF2B5EF4-FFF2-40B4-BE49-F238E27FC236}">
-                <a16:creationId xmlns:a16="http://schemas.microsoft.com/office/drawing/2014/main" id="{3DFC1B93-CB0A-481C-AADB-DDC375A6C2F3}"/>
+                <a16:creationId xmlns:a16="http://schemas.microsoft.com/office/drawing/2014/main" id="{BBE8B874-D22C-4E1E-A5CD-B0293B72482C}"/>
               </a:ext>
             </a:extLst>
           </p:cNvPr>
@@ -5467,7 +5467,7 @@
           <p:cNvPr id="3" name="">
             <a:extLst xmlns:a="http://schemas.openxmlformats.org/drawingml/2006/main">
               <a:ext uri="{FF2B5EF4-FFF2-40B4-BE49-F238E27FC236}">
-                <a16:creationId xmlns:a16="http://schemas.microsoft.com/office/drawing/2014/main" id="{7F5F6A2E-2D47-4F85-9A2D-B3C90E0C0FEF}"/>
+                <a16:creationId xmlns:a16="http://schemas.microsoft.com/office/drawing/2014/main" id="{8A3B376E-4456-4C8C-9BDC-103A87711EAC}"/>
               </a:ext>
             </a:extLst>
           </p:cNvPr>
@@ -5497,7 +5497,7 @@
           <p:cNvPr id="4" name="">
             <a:extLst xmlns:a="http://schemas.openxmlformats.org/drawingml/2006/main">
               <a:ext uri="{FF2B5EF4-FFF2-40B4-BE49-F238E27FC236}">
-                <a16:creationId xmlns:a16="http://schemas.microsoft.com/office/drawing/2014/main" id="{57A42C68-DA39-4557-BCAB-9E7A9C3DF2EF}"/>
+                <a16:creationId xmlns:a16="http://schemas.microsoft.com/office/drawing/2014/main" id="{63BA8172-3D54-4979-B63F-EECB307A43B0}"/>
               </a:ext>
             </a:extLst>
           </p:cNvPr>
@@ -5563,7 +5563,7 @@
           <p:cNvPr id="5" name="">
             <a:extLst xmlns:a="http://schemas.openxmlformats.org/drawingml/2006/main">
               <a:ext uri="{FF2B5EF4-FFF2-40B4-BE49-F238E27FC236}">
-                <a16:creationId xmlns:a16="http://schemas.microsoft.com/office/drawing/2014/main" id="{66E14704-5ADF-4E95-B7B0-0897F89950A5}"/>
+                <a16:creationId xmlns:a16="http://schemas.microsoft.com/office/drawing/2014/main" id="{EAD0571B-C49C-430C-B1BB-770F02D4A3EE}"/>
               </a:ext>
             </a:extLst>
           </p:cNvPr>
@@ -5629,7 +5629,7 @@
           <p:cNvPr id="6" name="">
             <a:extLst xmlns:a="http://schemas.openxmlformats.org/drawingml/2006/main">
               <a:ext uri="{FF2B5EF4-FFF2-40B4-BE49-F238E27FC236}">
-                <a16:creationId xmlns:a16="http://schemas.microsoft.com/office/drawing/2014/main" id="{A06FEDC2-A425-4CAC-91A8-D06A6AB562CE}"/>
+                <a16:creationId xmlns:a16="http://schemas.microsoft.com/office/drawing/2014/main" id="{BE15A6D2-249A-4FC9-86FB-A4308C3DF2C4}"/>
               </a:ext>
             </a:extLst>
           </p:cNvPr>
@@ -5695,7 +5695,7 @@
           <p:cNvPr id="7" name="">
             <a:extLst xmlns:a="http://schemas.openxmlformats.org/drawingml/2006/main">
               <a:ext uri="{FF2B5EF4-FFF2-40B4-BE49-F238E27FC236}">
-                <a16:creationId xmlns:a16="http://schemas.microsoft.com/office/drawing/2014/main" id="{A66E7544-3DAB-4824-83C2-246B33797E43}"/>
+                <a16:creationId xmlns:a16="http://schemas.microsoft.com/office/drawing/2014/main" id="{5F7F21F1-3C12-45BB-9FF8-E92408289576}"/>
               </a:ext>
             </a:extLst>
           </p:cNvPr>
@@ -5761,7 +5761,7 @@
           <p:cNvPr id="8" name="">
             <a:extLst xmlns:a="http://schemas.openxmlformats.org/drawingml/2006/main">
               <a:ext uri="{FF2B5EF4-FFF2-40B4-BE49-F238E27FC236}">
-                <a16:creationId xmlns:a16="http://schemas.microsoft.com/office/drawing/2014/main" id="{F3600617-BB63-41DB-A6E2-4EAC03A4984D}"/>
+                <a16:creationId xmlns:a16="http://schemas.microsoft.com/office/drawing/2014/main" id="{1A321CE2-12D2-49AD-AD93-749EA505BE5F}"/>
               </a:ext>
             </a:extLst>
           </p:cNvPr>
@@ -5827,7 +5827,7 @@
           <p:cNvPr id="9" name="">
             <a:extLst xmlns:a="http://schemas.openxmlformats.org/drawingml/2006/main">
               <a:ext uri="{FF2B5EF4-FFF2-40B4-BE49-F238E27FC236}">
-                <a16:creationId xmlns:a16="http://schemas.microsoft.com/office/drawing/2014/main" id="{07D6062A-C9C3-4143-9E68-93A618908432}"/>
+                <a16:creationId xmlns:a16="http://schemas.microsoft.com/office/drawing/2014/main" id="{A7D8ED95-F71D-4872-B3BE-3B3A0E0DA3C2}"/>
               </a:ext>
             </a:extLst>
           </p:cNvPr>
@@ -5893,7 +5893,7 @@
           <p:cNvPr id="10" name="">
             <a:extLst xmlns:a="http://schemas.openxmlformats.org/drawingml/2006/main">
               <a:ext uri="{FF2B5EF4-FFF2-40B4-BE49-F238E27FC236}">
-                <a16:creationId xmlns:a16="http://schemas.microsoft.com/office/drawing/2014/main" id="{9B26DA0C-D27D-486E-B05F-5B630CD80127}"/>
+                <a16:creationId xmlns:a16="http://schemas.microsoft.com/office/drawing/2014/main" id="{65FEF1A3-8D0A-438A-BA9D-2DDA965EA1AD}"/>
               </a:ext>
             </a:extLst>
           </p:cNvPr>
@@ -5925,7 +5925,7 @@
           <p:cNvPr id="11" name="">
             <a:extLst xmlns:a="http://schemas.openxmlformats.org/drawingml/2006/main">
               <a:ext uri="{FF2B5EF4-FFF2-40B4-BE49-F238E27FC236}">
-                <a16:creationId xmlns:a16="http://schemas.microsoft.com/office/drawing/2014/main" id="{EB0190F5-3BD3-45E7-BA37-5B79AD5FCAB0}"/>
+                <a16:creationId xmlns:a16="http://schemas.microsoft.com/office/drawing/2014/main" id="{8945636B-BC3B-416E-9003-0A76B2219E99}"/>
               </a:ext>
             </a:extLst>
           </p:cNvPr>
@@ -6037,7 +6037,7 @@
           <p:cNvPr id="12" name="">
             <a:extLst xmlns:a="http://schemas.openxmlformats.org/drawingml/2006/main">
               <a:ext uri="{FF2B5EF4-FFF2-40B4-BE49-F238E27FC236}">
-                <a16:creationId xmlns:a16="http://schemas.microsoft.com/office/drawing/2014/main" id="{7B6AB031-74BE-4D6D-88C6-661459AF9CF9}"/>
+                <a16:creationId xmlns:a16="http://schemas.microsoft.com/office/drawing/2014/main" id="{5A6CBFAF-806A-4244-8D87-CF74389A973A}"/>
               </a:ext>
             </a:extLst>
           </p:cNvPr>
@@ -6126,7 +6126,7 @@
           <p:cNvPr id="13" name="">
             <a:extLst xmlns:a="http://schemas.openxmlformats.org/drawingml/2006/main">
               <a:ext uri="{FF2B5EF4-FFF2-40B4-BE49-F238E27FC236}">
-                <a16:creationId xmlns:a16="http://schemas.microsoft.com/office/drawing/2014/main" id="{47DAC6E0-8513-4559-8D43-B9D60FC4E9BD}"/>
+                <a16:creationId xmlns:a16="http://schemas.microsoft.com/office/drawing/2014/main" id="{E898C7D9-DFB7-430A-9339-A4EF2AF77027}"/>
               </a:ext>
             </a:extLst>
           </p:cNvPr>
@@ -6192,7 +6192,7 @@
           <p:cNvPr id="14" name="">
             <a:extLst xmlns:a="http://schemas.openxmlformats.org/drawingml/2006/main">
               <a:ext uri="{FF2B5EF4-FFF2-40B4-BE49-F238E27FC236}">
-                <a16:creationId xmlns:a16="http://schemas.microsoft.com/office/drawing/2014/main" id="{6D05FB6C-1747-4501-8D47-9FFDD409DA7F}"/>
+                <a16:creationId xmlns:a16="http://schemas.microsoft.com/office/drawing/2014/main" id="{796DA97F-885C-46A3-A192-1768B0B6CEA1}"/>
               </a:ext>
             </a:extLst>
           </p:cNvPr>
@@ -6222,7 +6222,7 @@
           <p:cNvPr id="15" name="">
             <a:extLst xmlns:a="http://schemas.openxmlformats.org/drawingml/2006/main">
               <a:ext uri="{FF2B5EF4-FFF2-40B4-BE49-F238E27FC236}">
-                <a16:creationId xmlns:a16="http://schemas.microsoft.com/office/drawing/2014/main" id="{2E85B963-6AB4-4C8C-BCFE-BD116CBE3ED5}"/>
+                <a16:creationId xmlns:a16="http://schemas.microsoft.com/office/drawing/2014/main" id="{50FFA309-B0C8-4F53-AAFB-C7B867ACCC43}"/>
               </a:ext>
             </a:extLst>
           </p:cNvPr>
@@ -6334,7 +6334,7 @@
           <p:cNvPr id="16" name="">
             <a:extLst xmlns:a="http://schemas.openxmlformats.org/drawingml/2006/main">
               <a:ext uri="{FF2B5EF4-FFF2-40B4-BE49-F238E27FC236}">
-                <a16:creationId xmlns:a16="http://schemas.microsoft.com/office/drawing/2014/main" id="{D3FD17A9-F205-4FE6-992C-6AA064AA2E9F}"/>
+                <a16:creationId xmlns:a16="http://schemas.microsoft.com/office/drawing/2014/main" id="{69D70D6E-DD37-4C9C-BC77-80F9760DDE6D}"/>
               </a:ext>
             </a:extLst>
           </p:cNvPr>
@@ -6423,7 +6423,7 @@
           <p:cNvPr id="17" name="">
             <a:extLst xmlns:a="http://schemas.openxmlformats.org/drawingml/2006/main">
               <a:ext uri="{FF2B5EF4-FFF2-40B4-BE49-F238E27FC236}">
-                <a16:creationId xmlns:a16="http://schemas.microsoft.com/office/drawing/2014/main" id="{755C8EF8-AE64-4B9F-92F9-24BB68A07AD1}"/>
+                <a16:creationId xmlns:a16="http://schemas.microsoft.com/office/drawing/2014/main" id="{40B86D99-1545-4AE5-9DAC-B657260BD696}"/>
               </a:ext>
             </a:extLst>
           </p:cNvPr>
@@ -6489,7 +6489,7 @@
           <p:cNvPr id="18" name="">
             <a:extLst xmlns:a="http://schemas.openxmlformats.org/drawingml/2006/main">
               <a:ext uri="{FF2B5EF4-FFF2-40B4-BE49-F238E27FC236}">
-                <a16:creationId xmlns:a16="http://schemas.microsoft.com/office/drawing/2014/main" id="{EB028AEA-C498-47E7-8B42-34F1C7973D1C}"/>
+                <a16:creationId xmlns:a16="http://schemas.microsoft.com/office/drawing/2014/main" id="{C9734AD2-8ECE-4BDA-ACAA-820175D8BA22}"/>
               </a:ext>
             </a:extLst>
           </p:cNvPr>
@@ -6521,7 +6521,7 @@
           <p:cNvPr id="19" name="">
             <a:extLst xmlns:a="http://schemas.openxmlformats.org/drawingml/2006/main">
               <a:ext uri="{FF2B5EF4-FFF2-40B4-BE49-F238E27FC236}">
-                <a16:creationId xmlns:a16="http://schemas.microsoft.com/office/drawing/2014/main" id="{95AAF7D3-6E38-464B-B25D-D1F6B0090AFB}"/>
+                <a16:creationId xmlns:a16="http://schemas.microsoft.com/office/drawing/2014/main" id="{A476CEEB-DE1E-4F2E-8B28-D7AF98382E8F}"/>
               </a:ext>
             </a:extLst>
           </p:cNvPr>
@@ -6633,7 +6633,7 @@
           <p:cNvPr id="20" name="">
             <a:extLst xmlns:a="http://schemas.openxmlformats.org/drawingml/2006/main">
               <a:ext uri="{FF2B5EF4-FFF2-40B4-BE49-F238E27FC236}">
-                <a16:creationId xmlns:a16="http://schemas.microsoft.com/office/drawing/2014/main" id="{BD633FCD-E865-4EAB-A0CC-A556D4071465}"/>
+                <a16:creationId xmlns:a16="http://schemas.microsoft.com/office/drawing/2014/main" id="{C1959DB8-128B-43CD-8AFA-40F2B605D9EA}"/>
               </a:ext>
             </a:extLst>
           </p:cNvPr>
@@ -6722,7 +6722,7 @@
           <p:cNvPr id="21" name="">
             <a:extLst xmlns:a="http://schemas.openxmlformats.org/drawingml/2006/main">
               <a:ext uri="{FF2B5EF4-FFF2-40B4-BE49-F238E27FC236}">
-                <a16:creationId xmlns:a16="http://schemas.microsoft.com/office/drawing/2014/main" id="{6550E9D6-C20D-4F48-AD3A-1F0A2C33B1A1}"/>
+                <a16:creationId xmlns:a16="http://schemas.microsoft.com/office/drawing/2014/main" id="{79A0A406-EEF0-48CA-A9DC-1093EA4DB124}"/>
               </a:ext>
             </a:extLst>
           </p:cNvPr>
@@ -6752,7 +6752,7 @@
           <p:cNvPr id="22" name="">
             <a:extLst xmlns:a="http://schemas.openxmlformats.org/drawingml/2006/main">
               <a:ext uri="{FF2B5EF4-FFF2-40B4-BE49-F238E27FC236}">
-                <a16:creationId xmlns:a16="http://schemas.microsoft.com/office/drawing/2014/main" id="{B11E99BF-82EF-4165-AD35-9BDBA621BC9D}"/>
+                <a16:creationId xmlns:a16="http://schemas.microsoft.com/office/drawing/2014/main" id="{F654DB11-1A8D-4A81-B024-3A3B390CB74B}"/>
               </a:ext>
             </a:extLst>
           </p:cNvPr>
@@ -6816,7 +6816,7 @@
     </p:spTree>
     <p:extLst>
       <p:ext uri="{BB962C8B-B14F-4D97-AF65-F5344CB8AC3E}">
-        <p14:creationId xmlns:p14="http://schemas.microsoft.com/office/powerpoint/2010/main" val="1799325939"/>
+        <p14:creationId xmlns:p14="http://schemas.microsoft.com/office/powerpoint/2010/main" val="846705950"/>
       </p:ext>
     </p:extLst>
   </p:cSld>
@@ -6847,7 +6847,7 @@
           <p:cNvPr id="16" name="">
             <a:extLst xmlns:a="http://schemas.openxmlformats.org/drawingml/2006/main">
               <a:ext uri="{FF2B5EF4-FFF2-40B4-BE49-F238E27FC236}">
-                <a16:creationId xmlns:a16="http://schemas.microsoft.com/office/drawing/2014/main" id="{0741E363-99A2-4936-BD5E-B2B432A4EF96}"/>
+                <a16:creationId xmlns:a16="http://schemas.microsoft.com/office/drawing/2014/main" id="{B8C35576-D86D-4077-AB96-110DE02D4E47}"/>
               </a:ext>
             </a:extLst>
           </p:cNvPr>
@@ -6913,7 +6913,7 @@
           <p:cNvPr id="2" name="">
             <a:extLst xmlns:a="http://schemas.openxmlformats.org/drawingml/2006/main">
               <a:ext uri="{FF2B5EF4-FFF2-40B4-BE49-F238E27FC236}">
-                <a16:creationId xmlns:a16="http://schemas.microsoft.com/office/drawing/2014/main" id="{4A25AC3C-1D77-42F8-B00B-CFF5760EF928}"/>
+                <a16:creationId xmlns:a16="http://schemas.microsoft.com/office/drawing/2014/main" id="{E98A9D17-C72A-4F6C-881B-8D483E657F67}"/>
               </a:ext>
             </a:extLst>
           </p:cNvPr>
@@ -6979,7 +6979,7 @@
           <p:cNvPr id="3" name="">
             <a:extLst xmlns:a="http://schemas.openxmlformats.org/drawingml/2006/main">
               <a:ext uri="{FF2B5EF4-FFF2-40B4-BE49-F238E27FC236}">
-                <a16:creationId xmlns:a16="http://schemas.microsoft.com/office/drawing/2014/main" id="{10B06ADA-D21A-4130-AF86-C69CA425C47F}"/>
+                <a16:creationId xmlns:a16="http://schemas.microsoft.com/office/drawing/2014/main" id="{E127F9B0-1C66-4CDA-B721-E124B863E732}"/>
               </a:ext>
             </a:extLst>
           </p:cNvPr>
@@ -7009,7 +7009,7 @@
           <p:cNvPr id="4" name="">
             <a:extLst xmlns:a="http://schemas.openxmlformats.org/drawingml/2006/main">
               <a:ext uri="{FF2B5EF4-FFF2-40B4-BE49-F238E27FC236}">
-                <a16:creationId xmlns:a16="http://schemas.microsoft.com/office/drawing/2014/main" id="{BEE76D49-F4A8-41A9-B366-DADAB8B40CB3}"/>
+                <a16:creationId xmlns:a16="http://schemas.microsoft.com/office/drawing/2014/main" id="{01E543E6-3BE1-426A-B93C-D8942E1C133D}"/>
               </a:ext>
             </a:extLst>
           </p:cNvPr>
@@ -7075,7 +7075,7 @@
           <p:cNvPr id="5" name="">
             <a:extLst xmlns:a="http://schemas.openxmlformats.org/drawingml/2006/main">
               <a:ext uri="{FF2B5EF4-FFF2-40B4-BE49-F238E27FC236}">
-                <a16:creationId xmlns:a16="http://schemas.microsoft.com/office/drawing/2014/main" id="{A3EE8ECF-6534-4802-A3B1-F35E87444BBB}"/>
+                <a16:creationId xmlns:a16="http://schemas.microsoft.com/office/drawing/2014/main" id="{FF13C53A-A855-48FC-A16E-F8D015E9A5BC}"/>
               </a:ext>
             </a:extLst>
           </p:cNvPr>
@@ -7141,7 +7141,7 @@
           <p:cNvPr id="6" name="">
             <a:extLst xmlns:a="http://schemas.openxmlformats.org/drawingml/2006/main">
               <a:ext uri="{FF2B5EF4-FFF2-40B4-BE49-F238E27FC236}">
-                <a16:creationId xmlns:a16="http://schemas.microsoft.com/office/drawing/2014/main" id="{B09825FB-94F9-4D78-BE87-7A902867468F}"/>
+                <a16:creationId xmlns:a16="http://schemas.microsoft.com/office/drawing/2014/main" id="{4E14E52A-5F95-43BF-800D-040069D53CE3}"/>
               </a:ext>
             </a:extLst>
           </p:cNvPr>
@@ -7207,7 +7207,7 @@
           <p:cNvPr id="7" name="">
             <a:extLst xmlns:a="http://schemas.openxmlformats.org/drawingml/2006/main">
               <a:ext uri="{FF2B5EF4-FFF2-40B4-BE49-F238E27FC236}">
-                <a16:creationId xmlns:a16="http://schemas.microsoft.com/office/drawing/2014/main" id="{6C6E8D69-C0EE-4B3F-998D-078869DF9DE3}"/>
+                <a16:creationId xmlns:a16="http://schemas.microsoft.com/office/drawing/2014/main" id="{03855383-883B-434E-BCC0-A5E9C94C9D10}"/>
               </a:ext>
             </a:extLst>
           </p:cNvPr>
@@ -7273,7 +7273,7 @@
           <p:cNvPr id="8" name="">
             <a:extLst xmlns:a="http://schemas.openxmlformats.org/drawingml/2006/main">
               <a:ext uri="{FF2B5EF4-FFF2-40B4-BE49-F238E27FC236}">
-                <a16:creationId xmlns:a16="http://schemas.microsoft.com/office/drawing/2014/main" id="{02186970-5069-4EEA-88EE-6E80EA309178}"/>
+                <a16:creationId xmlns:a16="http://schemas.microsoft.com/office/drawing/2014/main" id="{07873491-F47D-4926-9712-7C17671589C0}"/>
               </a:ext>
             </a:extLst>
           </p:cNvPr>
@@ -7362,7 +7362,7 @@
           <p:cNvPr id="9" name="">
             <a:extLst xmlns:a="http://schemas.openxmlformats.org/drawingml/2006/main">
               <a:ext uri="{FF2B5EF4-FFF2-40B4-BE49-F238E27FC236}">
-                <a16:creationId xmlns:a16="http://schemas.microsoft.com/office/drawing/2014/main" id="{F71B7CDF-383D-4652-858C-EF79404B996F}"/>
+                <a16:creationId xmlns:a16="http://schemas.microsoft.com/office/drawing/2014/main" id="{5164745A-AA12-48D6-B0C2-4869B61ABD47}"/>
               </a:ext>
             </a:extLst>
           </p:cNvPr>
@@ -7451,7 +7451,7 @@
           <p:cNvPr id="10" name="">
             <a:extLst xmlns:a="http://schemas.openxmlformats.org/drawingml/2006/main">
               <a:ext uri="{FF2B5EF4-FFF2-40B4-BE49-F238E27FC236}">
-                <a16:creationId xmlns:a16="http://schemas.microsoft.com/office/drawing/2014/main" id="{D8BF35E7-A5B9-44FE-B97A-6767C94C8B70}"/>
+                <a16:creationId xmlns:a16="http://schemas.microsoft.com/office/drawing/2014/main" id="{3F24984F-FEA9-4A06-8DA7-109B247C0321}"/>
               </a:ext>
             </a:extLst>
           </p:cNvPr>
@@ -7540,7 +7540,7 @@
           <p:cNvPr id="11" name="">
             <a:extLst xmlns:a="http://schemas.openxmlformats.org/drawingml/2006/main">
               <a:ext uri="{FF2B5EF4-FFF2-40B4-BE49-F238E27FC236}">
-                <a16:creationId xmlns:a16="http://schemas.microsoft.com/office/drawing/2014/main" id="{49FED891-AA0B-400D-8C65-0456E249B0DF}"/>
+                <a16:creationId xmlns:a16="http://schemas.microsoft.com/office/drawing/2014/main" id="{D7F5551C-A45A-4A39-A373-5188A6EAF2D9}"/>
               </a:ext>
             </a:extLst>
           </p:cNvPr>
@@ -7570,7 +7570,7 @@
           <p:cNvPr id="12" name="">
             <a:extLst xmlns:a="http://schemas.openxmlformats.org/drawingml/2006/main">
               <a:ext uri="{FF2B5EF4-FFF2-40B4-BE49-F238E27FC236}">
-                <a16:creationId xmlns:a16="http://schemas.microsoft.com/office/drawing/2014/main" id="{08ADDCAB-4D8F-476A-AF4A-DB3DE8B6E7AD}"/>
+                <a16:creationId xmlns:a16="http://schemas.microsoft.com/office/drawing/2014/main" id="{731EF9CF-8E42-4163-BD23-79FBF5C49A87}"/>
               </a:ext>
             </a:extLst>
           </p:cNvPr>
@@ -7580,7 +7580,7 @@
           <p:nvPr/>
         </p:nvPicPr>
         <p:blipFill>
-          <a:blip xmlns:r="http://schemas.openxmlformats.org/officeDocument/2006/relationships" xmlns:a="http://schemas.openxmlformats.org/drawingml/2006/main" r:embed="Rc4d629c68b32492e"/>
+          <a:blip xmlns:r="http://schemas.openxmlformats.org/officeDocument/2006/relationships" xmlns:a="http://schemas.openxmlformats.org/drawingml/2006/main" r:embed="R6803e51d3ed14737"/>
           <a:stretch xmlns:a="http://schemas.openxmlformats.org/drawingml/2006/main"/>
         </p:blipFill>
         <p:spPr>
@@ -7598,7 +7598,7 @@
           <p:cNvPr id="13" name="">
             <a:extLst xmlns:a="http://schemas.openxmlformats.org/drawingml/2006/main">
               <a:ext uri="{FF2B5EF4-FFF2-40B4-BE49-F238E27FC236}">
-                <a16:creationId xmlns:a16="http://schemas.microsoft.com/office/drawing/2014/main" id="{C0A9EE09-D774-4C8F-8E7C-DAC6F3AE03E2}"/>
+                <a16:creationId xmlns:a16="http://schemas.microsoft.com/office/drawing/2014/main" id="{17D20E9E-E6EA-47AC-9C69-00A6B5929B55}"/>
               </a:ext>
             </a:extLst>
           </p:cNvPr>
@@ -7608,7 +7608,7 @@
           <p:nvPr/>
         </p:nvPicPr>
         <p:blipFill>
-          <a:blip xmlns:r="http://schemas.openxmlformats.org/officeDocument/2006/relationships" xmlns:a="http://schemas.openxmlformats.org/drawingml/2006/main" r:embed="R74eb9b65b90e4c5f"/>
+          <a:blip xmlns:r="http://schemas.openxmlformats.org/officeDocument/2006/relationships" xmlns:a="http://schemas.openxmlformats.org/drawingml/2006/main" r:embed="Re70a9c4dd7dc43db"/>
           <a:stretch xmlns:a="http://schemas.openxmlformats.org/drawingml/2006/main"/>
         </p:blipFill>
         <p:spPr>
@@ -7626,7 +7626,7 @@
           <p:cNvPr id="14" name="">
             <a:extLst xmlns:a="http://schemas.openxmlformats.org/drawingml/2006/main">
               <a:ext uri="{FF2B5EF4-FFF2-40B4-BE49-F238E27FC236}">
-                <a16:creationId xmlns:a16="http://schemas.microsoft.com/office/drawing/2014/main" id="{049C774A-8E16-44B6-BB56-E0030990B59B}"/>
+                <a16:creationId xmlns:a16="http://schemas.microsoft.com/office/drawing/2014/main" id="{25C5DF18-5899-4AE0-AE2F-2969A3829E3A}"/>
               </a:ext>
             </a:extLst>
           </p:cNvPr>
@@ -7692,7 +7692,7 @@
           <p:cNvPr id="15" name="">
             <a:extLst xmlns:a="http://schemas.openxmlformats.org/drawingml/2006/main">
               <a:ext uri="{FF2B5EF4-FFF2-40B4-BE49-F238E27FC236}">
-                <a16:creationId xmlns:a16="http://schemas.microsoft.com/office/drawing/2014/main" id="{B1EB8BB0-F109-475B-823D-C470ADFAC4F1}"/>
+                <a16:creationId xmlns:a16="http://schemas.microsoft.com/office/drawing/2014/main" id="{EDCAC2F4-76EC-4A29-B3C1-0FFB865643E4}"/>
               </a:ext>
             </a:extLst>
           </p:cNvPr>
@@ -7756,7 +7756,7 @@
     </p:spTree>
     <p:extLst>
       <p:ext uri="{BB962C8B-B14F-4D97-AF65-F5344CB8AC3E}">
-        <p14:creationId xmlns:p14="http://schemas.microsoft.com/office/powerpoint/2010/main" val="118096012"/>
+        <p14:creationId xmlns:p14="http://schemas.microsoft.com/office/powerpoint/2010/main" val="1072904236"/>
       </p:ext>
     </p:extLst>
   </p:cSld>
@@ -7787,7 +7787,7 @@
           <p:cNvPr id="13" name="">
             <a:extLst xmlns:a="http://schemas.openxmlformats.org/drawingml/2006/main">
               <a:ext uri="{FF2B5EF4-FFF2-40B4-BE49-F238E27FC236}">
-                <a16:creationId xmlns:a16="http://schemas.microsoft.com/office/drawing/2014/main" id="{6DC53978-267A-4E97-A54A-2DCBE243F86E}"/>
+                <a16:creationId xmlns:a16="http://schemas.microsoft.com/office/drawing/2014/main" id="{F8B634C7-AF18-40CF-8BC5-798ACCFA871B}"/>
               </a:ext>
             </a:extLst>
           </p:cNvPr>
@@ -7853,7 +7853,7 @@
           <p:cNvPr id="2" name="">
             <a:extLst xmlns:a="http://schemas.openxmlformats.org/drawingml/2006/main">
               <a:ext uri="{FF2B5EF4-FFF2-40B4-BE49-F238E27FC236}">
-                <a16:creationId xmlns:a16="http://schemas.microsoft.com/office/drawing/2014/main" id="{338125E5-DC41-466B-A9A6-19164C02BE5E}"/>
+                <a16:creationId xmlns:a16="http://schemas.microsoft.com/office/drawing/2014/main" id="{804C5A97-DCF9-4E2C-A805-4A9F05B0C3DB}"/>
               </a:ext>
             </a:extLst>
           </p:cNvPr>
@@ -7919,7 +7919,7 @@
           <p:cNvPr id="3" name="">
             <a:extLst xmlns:a="http://schemas.openxmlformats.org/drawingml/2006/main">
               <a:ext uri="{FF2B5EF4-FFF2-40B4-BE49-F238E27FC236}">
-                <a16:creationId xmlns:a16="http://schemas.microsoft.com/office/drawing/2014/main" id="{80B5CEE9-031B-4E2C-9B45-0272510971AC}"/>
+                <a16:creationId xmlns:a16="http://schemas.microsoft.com/office/drawing/2014/main" id="{8A803BB9-3075-4766-9432-D5546834607D}"/>
               </a:ext>
             </a:extLst>
           </p:cNvPr>
@@ -7949,7 +7949,7 @@
           <p:cNvPr id="4" name="">
             <a:extLst xmlns:a="http://schemas.openxmlformats.org/drawingml/2006/main">
               <a:ext uri="{FF2B5EF4-FFF2-40B4-BE49-F238E27FC236}">
-                <a16:creationId xmlns:a16="http://schemas.microsoft.com/office/drawing/2014/main" id="{CFBB7E9C-1423-478C-90FA-D164341CD706}"/>
+                <a16:creationId xmlns:a16="http://schemas.microsoft.com/office/drawing/2014/main" id="{DBBDA135-DDF0-407F-A883-0BEBBC788549}"/>
               </a:ext>
             </a:extLst>
           </p:cNvPr>
@@ -8015,7 +8015,7 @@
           <p:cNvPr id="5" name="">
             <a:extLst xmlns:a="http://schemas.openxmlformats.org/drawingml/2006/main">
               <a:ext uri="{FF2B5EF4-FFF2-40B4-BE49-F238E27FC236}">
-                <a16:creationId xmlns:a16="http://schemas.microsoft.com/office/drawing/2014/main" id="{D7120637-34E2-438C-B66E-403ECC8E3AAC}"/>
+                <a16:creationId xmlns:a16="http://schemas.microsoft.com/office/drawing/2014/main" id="{7CD358B3-526A-442E-8ACA-EBC9DA409200}"/>
               </a:ext>
             </a:extLst>
           </p:cNvPr>
@@ -8081,7 +8081,7 @@
           <p:cNvPr id="6" name="">
             <a:extLst xmlns:a="http://schemas.openxmlformats.org/drawingml/2006/main">
               <a:ext uri="{FF2B5EF4-FFF2-40B4-BE49-F238E27FC236}">
-                <a16:creationId xmlns:a16="http://schemas.microsoft.com/office/drawing/2014/main" id="{F7E8C14E-7F7F-4CA7-AE8D-D4478153E8A4}"/>
+                <a16:creationId xmlns:a16="http://schemas.microsoft.com/office/drawing/2014/main" id="{85C0A6CE-99BA-401F-9D66-492C9460581D}"/>
               </a:ext>
             </a:extLst>
           </p:cNvPr>
@@ -8147,7 +8147,7 @@
           <p:cNvPr id="7" name="">
             <a:extLst xmlns:a="http://schemas.openxmlformats.org/drawingml/2006/main">
               <a:ext uri="{FF2B5EF4-FFF2-40B4-BE49-F238E27FC236}">
-                <a16:creationId xmlns:a16="http://schemas.microsoft.com/office/drawing/2014/main" id="{4DFDF57B-FF23-4E46-A0B8-2C73FE6C1708}"/>
+                <a16:creationId xmlns:a16="http://schemas.microsoft.com/office/drawing/2014/main" id="{B24FBA1F-8832-4E24-AA9B-A178A81BDE83}"/>
               </a:ext>
             </a:extLst>
           </p:cNvPr>
@@ -8213,7 +8213,7 @@
           <p:cNvPr id="8" name="">
             <a:extLst xmlns:a="http://schemas.openxmlformats.org/drawingml/2006/main">
               <a:ext uri="{FF2B5EF4-FFF2-40B4-BE49-F238E27FC236}">
-                <a16:creationId xmlns:a16="http://schemas.microsoft.com/office/drawing/2014/main" id="{CA0321FE-7ACD-4342-9877-3DEC9549F20A}"/>
+                <a16:creationId xmlns:a16="http://schemas.microsoft.com/office/drawing/2014/main" id="{153B9007-E1A2-4E5F-8244-5254A0E9DB2C}"/>
               </a:ext>
             </a:extLst>
           </p:cNvPr>
@@ -8325,7 +8325,7 @@
           <p:cNvPr id="9" name="">
             <a:extLst xmlns:a="http://schemas.openxmlformats.org/drawingml/2006/main">
               <a:ext uri="{FF2B5EF4-FFF2-40B4-BE49-F238E27FC236}">
-                <a16:creationId xmlns:a16="http://schemas.microsoft.com/office/drawing/2014/main" id="{3631B2C8-4D0F-4506-A7CD-B65FF8C93758}"/>
+                <a16:creationId xmlns:a16="http://schemas.microsoft.com/office/drawing/2014/main" id="{DEEE2F4B-D072-4CEB-85CD-32E2E22E0F1C}"/>
               </a:ext>
             </a:extLst>
           </p:cNvPr>
@@ -8391,7 +8391,7 @@
           <p:cNvPr id="10" name="">
             <a:extLst xmlns:a="http://schemas.openxmlformats.org/drawingml/2006/main">
               <a:ext uri="{FF2B5EF4-FFF2-40B4-BE49-F238E27FC236}">
-                <a16:creationId xmlns:a16="http://schemas.microsoft.com/office/drawing/2014/main" id="{58D3FB44-43FF-44B7-B54C-3534203B3C91}"/>
+                <a16:creationId xmlns:a16="http://schemas.microsoft.com/office/drawing/2014/main" id="{29EC7BE4-5BAA-44C7-BEB2-0A46FDB270EA}"/>
               </a:ext>
             </a:extLst>
           </p:cNvPr>
@@ -8503,7 +8503,7 @@
           <p:cNvPr id="11" name="">
             <a:extLst xmlns:a="http://schemas.openxmlformats.org/drawingml/2006/main">
               <a:ext uri="{FF2B5EF4-FFF2-40B4-BE49-F238E27FC236}">
-                <a16:creationId xmlns:a16="http://schemas.microsoft.com/office/drawing/2014/main" id="{AB9FAC6A-AEA4-4ADF-ACB4-390CA12C2D92}"/>
+                <a16:creationId xmlns:a16="http://schemas.microsoft.com/office/drawing/2014/main" id="{EE0A22D3-1EA6-43DF-A861-D8115D71AF80}"/>
               </a:ext>
             </a:extLst>
           </p:cNvPr>
@@ -8513,7 +8513,7 @@
           <p:nvPr/>
         </p:nvPicPr>
         <p:blipFill>
-          <a:blip xmlns:r="http://schemas.openxmlformats.org/officeDocument/2006/relationships" xmlns:a="http://schemas.openxmlformats.org/drawingml/2006/main" r:embed="Rbf202f12f80948c3"/>
+          <a:blip xmlns:r="http://schemas.openxmlformats.org/officeDocument/2006/relationships" xmlns:a="http://schemas.openxmlformats.org/drawingml/2006/main" r:embed="Rf0c9e443919d4d66"/>
           <a:srcRect xmlns:a="http://schemas.openxmlformats.org/drawingml/2006/main" l="48000" t="0" r="0" b="10500"/>
           <a:stretch xmlns:a="http://schemas.openxmlformats.org/drawingml/2006/main"/>
         </p:blipFill>
@@ -8532,7 +8532,7 @@
           <p:cNvPr id="12" name="">
             <a:extLst xmlns:a="http://schemas.openxmlformats.org/drawingml/2006/main">
               <a:ext uri="{FF2B5EF4-FFF2-40B4-BE49-F238E27FC236}">
-                <a16:creationId xmlns:a16="http://schemas.microsoft.com/office/drawing/2014/main" id="{058E6899-476C-4237-8564-15EA86EC7396}"/>
+                <a16:creationId xmlns:a16="http://schemas.microsoft.com/office/drawing/2014/main" id="{6E56B914-C9D4-4058-B800-A205E50C788B}"/>
               </a:ext>
             </a:extLst>
           </p:cNvPr>
@@ -8596,7 +8596,7 @@
     </p:spTree>
     <p:extLst>
       <p:ext uri="{BB962C8B-B14F-4D97-AF65-F5344CB8AC3E}">
-        <p14:creationId xmlns:p14="http://schemas.microsoft.com/office/powerpoint/2010/main" val="594950046"/>
+        <p14:creationId xmlns:p14="http://schemas.microsoft.com/office/powerpoint/2010/main" val="1596385444"/>
       </p:ext>
     </p:extLst>
   </p:cSld>
@@ -8624,10 +8624,10 @@
       </p:grpSpPr>
       <p:sp>
         <p:nvSpPr>
-          <p:cNvPr id="11" name="">
-            <a:extLst xmlns:a="http://schemas.openxmlformats.org/drawingml/2006/main">
-              <a:ext uri="{FF2B5EF4-FFF2-40B4-BE49-F238E27FC236}">
-                <a16:creationId xmlns:a16="http://schemas.microsoft.com/office/drawing/2014/main" id="{EE9E392A-BF58-45B3-8528-75FCADB62FFE}"/>
+          <p:cNvPr id="13" name="">
+            <a:extLst xmlns:a="http://schemas.openxmlformats.org/drawingml/2006/main">
+              <a:ext uri="{FF2B5EF4-FFF2-40B4-BE49-F238E27FC236}">
+                <a16:creationId xmlns:a16="http://schemas.microsoft.com/office/drawing/2014/main" id="{10104FAE-6770-416D-ABE6-B16C82813830}"/>
               </a:ext>
             </a:extLst>
           </p:cNvPr>
@@ -8693,7 +8693,7 @@
           <p:cNvPr id="2" name="">
             <a:extLst xmlns:a="http://schemas.openxmlformats.org/drawingml/2006/main">
               <a:ext uri="{FF2B5EF4-FFF2-40B4-BE49-F238E27FC236}">
-                <a16:creationId xmlns:a16="http://schemas.microsoft.com/office/drawing/2014/main" id="{F256D5AD-CECB-4C25-9FC7-6154DC490345}"/>
+                <a16:creationId xmlns:a16="http://schemas.microsoft.com/office/drawing/2014/main" id="{8A23B7A8-77D4-46FE-B4B6-52C9116FCE16}"/>
               </a:ext>
             </a:extLst>
           </p:cNvPr>
@@ -8759,7 +8759,7 @@
           <p:cNvPr id="3" name="">
             <a:extLst xmlns:a="http://schemas.openxmlformats.org/drawingml/2006/main">
               <a:ext uri="{FF2B5EF4-FFF2-40B4-BE49-F238E27FC236}">
-                <a16:creationId xmlns:a16="http://schemas.microsoft.com/office/drawing/2014/main" id="{6F120A6B-8CFD-4A06-81B4-1CC8EA41A5D9}"/>
+                <a16:creationId xmlns:a16="http://schemas.microsoft.com/office/drawing/2014/main" id="{6D79A7A5-ACDF-4FB0-B1AD-4FFD3203CFD1}"/>
               </a:ext>
             </a:extLst>
           </p:cNvPr>
@@ -8789,7 +8789,7 @@
           <p:cNvPr id="4" name="">
             <a:extLst xmlns:a="http://schemas.openxmlformats.org/drawingml/2006/main">
               <a:ext uri="{FF2B5EF4-FFF2-40B4-BE49-F238E27FC236}">
-                <a16:creationId xmlns:a16="http://schemas.microsoft.com/office/drawing/2014/main" id="{B10D92EA-3D4C-444A-9A2A-16131414DF5D}"/>
+                <a16:creationId xmlns:a16="http://schemas.microsoft.com/office/drawing/2014/main" id="{E28B94BD-AEF7-418B-AC98-2912ACEA7FFB}"/>
               </a:ext>
             </a:extLst>
           </p:cNvPr>
@@ -8855,7 +8855,7 @@
           <p:cNvPr id="5" name="">
             <a:extLst xmlns:a="http://schemas.openxmlformats.org/drawingml/2006/main">
               <a:ext uri="{FF2B5EF4-FFF2-40B4-BE49-F238E27FC236}">
-                <a16:creationId xmlns:a16="http://schemas.microsoft.com/office/drawing/2014/main" id="{11A6ECB7-18F8-4AE0-A1D1-370CF7B1C554}"/>
+                <a16:creationId xmlns:a16="http://schemas.microsoft.com/office/drawing/2014/main" id="{788D2D3A-5C68-42E5-B62D-F0671257D022}"/>
               </a:ext>
             </a:extLst>
           </p:cNvPr>
@@ -8921,7 +8921,7 @@
           <p:cNvPr id="6" name="">
             <a:extLst xmlns:a="http://schemas.openxmlformats.org/drawingml/2006/main">
               <a:ext uri="{FF2B5EF4-FFF2-40B4-BE49-F238E27FC236}">
-                <a16:creationId xmlns:a16="http://schemas.microsoft.com/office/drawing/2014/main" id="{D15A6773-9067-433D-8183-715897DF235F}"/>
+                <a16:creationId xmlns:a16="http://schemas.microsoft.com/office/drawing/2014/main" id="{D5B83B41-2B3A-48E1-86A0-6F236E4261A6}"/>
               </a:ext>
             </a:extLst>
           </p:cNvPr>
@@ -8987,7 +8987,7 @@
           <p:cNvPr id="7" name="">
             <a:extLst xmlns:a="http://schemas.openxmlformats.org/drawingml/2006/main">
               <a:ext uri="{FF2B5EF4-FFF2-40B4-BE49-F238E27FC236}">
-                <a16:creationId xmlns:a16="http://schemas.microsoft.com/office/drawing/2014/main" id="{19B45430-EBC6-41D2-BAC4-567C8DF21B44}"/>
+                <a16:creationId xmlns:a16="http://schemas.microsoft.com/office/drawing/2014/main" id="{D995C5CE-9052-4D5F-B738-60164F1CBC9D}"/>
               </a:ext>
             </a:extLst>
           </p:cNvPr>
@@ -8995,8 +8995,8 @@
           <p:nvPr/>
         </p:nvGraphicFramePr>
         <p:xfrm>
-          <a:off xmlns:a="http://schemas.openxmlformats.org/drawingml/2006/main" x="1000125" y="3371850"/>
-          <a:ext xmlns:a="http://schemas.openxmlformats.org/drawingml/2006/main" cx="16192500" cy="4229100"/>
+          <a:off xmlns:a="http://schemas.openxmlformats.org/drawingml/2006/main" x="1000125" y="3143250"/>
+          <a:ext xmlns:a="http://schemas.openxmlformats.org/drawingml/2006/main" cx="16192500" cy="3429000"/>
         </p:xfrm>
         <a:graphic xmlns:a="http://schemas.openxmlformats.org/drawingml/2006/main">
           <a:graphicData uri="http://schemas.openxmlformats.org/drawingml/2006/table">
@@ -9007,14 +9007,14 @@
                 <a:gridCol w="5715000"/>
                 <a:gridCol w="5905500"/>
               </a:tblGrid>
-              <a:tr h="800100">
+              <a:tr h="685800">
                 <a:tc>
                   <a:txBody>
                     <a:bodyPr/>
                     <a:lstStyle/>
                     <a:p>
                       <a:r>
-                        <a:rPr sz="2250" b="1">
+                        <a:rPr sz="2175" b="1">
                           <a:solidFill>
                             <a:srgbClr val="F9F8F3"/>
                           </a:solidFill>
@@ -9062,7 +9062,7 @@
                     <a:lstStyle/>
                     <a:p>
                       <a:r>
-                        <a:rPr sz="2250" b="1">
+                        <a:rPr sz="2175" b="1">
                           <a:solidFill>
                             <a:srgbClr val="F9F8F3"/>
                           </a:solidFill>
@@ -9104,7 +9104,7 @@
                     <a:lstStyle/>
                     <a:p>
                       <a:r>
-                        <a:rPr sz="2250" b="1">
+                        <a:rPr sz="2175" b="1">
                           <a:solidFill>
                             <a:srgbClr val="F9F8F3"/>
                           </a:solidFill>
@@ -9141,14 +9141,14 @@
                   </a:tcPr>
                 </a:tc>
               </a:tr>
-              <a:tr h="1143000">
+              <a:tr h="914400">
                 <a:tc>
                   <a:txBody>
                     <a:bodyPr/>
                     <a:lstStyle/>
                     <a:p>
                       <a:r>
-                        <a:rPr sz="2325" b="0">
+                        <a:rPr sz="2250" b="0">
                           <a:solidFill>
                             <a:srgbClr val="17372E"/>
                           </a:solidFill>
@@ -9190,7 +9190,7 @@
                     <a:lstStyle/>
                     <a:p>
                       <a:r>
-                        <a:rPr sz="2325" b="0">
+                        <a:rPr sz="2250" b="0">
                           <a:solidFill>
                             <a:srgbClr val="17372E"/>
                           </a:solidFill>
@@ -9226,7 +9226,7 @@
                     <a:lstStyle/>
                     <a:p>
                       <a:r>
-                        <a:rPr sz="2325" b="0">
+                        <a:rPr sz="2250" b="0">
                           <a:solidFill>
                             <a:srgbClr val="17372E"/>
                           </a:solidFill>
@@ -9239,7 +9239,7 @@
                     </a:p>
                     <a:p>
                       <a:r>
-                        <a:rPr sz="2325" b="0">
+                        <a:rPr sz="2250" b="0">
                           <a:solidFill>
                             <a:srgbClr val="17372E"/>
                           </a:solidFill>
@@ -9270,14 +9270,14 @@
                   </a:tcPr>
                 </a:tc>
               </a:tr>
-              <a:tr h="1143000">
+              <a:tr h="914400">
                 <a:tc>
                   <a:txBody>
                     <a:bodyPr/>
                     <a:lstStyle/>
                     <a:p>
                       <a:r>
-                        <a:rPr sz="2325" b="0">
+                        <a:rPr sz="2250" b="0">
                           <a:solidFill>
                             <a:srgbClr val="17372E"/>
                           </a:solidFill>
@@ -9319,7 +9319,7 @@
                     <a:lstStyle/>
                     <a:p>
                       <a:r>
-                        <a:rPr sz="2325" b="0">
+                        <a:rPr sz="2250" b="0">
                           <a:solidFill>
                             <a:srgbClr val="17372E"/>
                           </a:solidFill>
@@ -9355,7 +9355,7 @@
                     <a:lstStyle/>
                     <a:p>
                       <a:r>
-                        <a:rPr sz="2325" b="0">
+                        <a:rPr sz="2250" b="0">
                           <a:solidFill>
                             <a:srgbClr val="17372E"/>
                           </a:solidFill>
@@ -9368,7 +9368,7 @@
                     </a:p>
                     <a:p>
                       <a:r>
-                        <a:rPr sz="2325" b="0">
+                        <a:rPr sz="2250" b="0">
                           <a:solidFill>
                             <a:srgbClr val="17372E"/>
                           </a:solidFill>
@@ -9399,14 +9399,14 @@
                   </a:tcPr>
                 </a:tc>
               </a:tr>
-              <a:tr h="1143000">
+              <a:tr h="914400">
                 <a:tc>
                   <a:txBody>
                     <a:bodyPr/>
                     <a:lstStyle/>
                     <a:p>
                       <a:r>
-                        <a:rPr sz="2325" b="0">
+                        <a:rPr sz="2250" b="0">
                           <a:solidFill>
                             <a:srgbClr val="17372E"/>
                           </a:solidFill>
@@ -9448,7 +9448,7 @@
                     <a:lstStyle/>
                     <a:p>
                       <a:r>
-                        <a:rPr sz="2325" b="0">
+                        <a:rPr sz="2250" b="0">
                           <a:solidFill>
                             <a:srgbClr val="17372E"/>
                           </a:solidFill>
@@ -9484,7 +9484,7 @@
                     <a:lstStyle/>
                     <a:p>
                       <a:r>
-                        <a:rPr sz="2325" b="0">
+                        <a:rPr sz="2250" b="0">
                           <a:solidFill>
                             <a:srgbClr val="17372E"/>
                           </a:solidFill>
@@ -9497,7 +9497,7 @@
                     </a:p>
                     <a:p>
                       <a:r>
-                        <a:rPr sz="2325" b="0">
+                        <a:rPr sz="2250" b="0">
                           <a:solidFill>
                             <a:srgbClr val="17372E"/>
                           </a:solidFill>
@@ -9537,7 +9537,162 @@
           <p:cNvPr id="8" name="">
             <a:extLst xmlns:a="http://schemas.openxmlformats.org/drawingml/2006/main">
               <a:ext uri="{FF2B5EF4-FFF2-40B4-BE49-F238E27FC236}">
-                <a16:creationId xmlns:a16="http://schemas.microsoft.com/office/drawing/2014/main" id="{2A648DEB-E0DF-47B8-8291-0A5425BCEE7B}"/>
+                <a16:creationId xmlns:a16="http://schemas.microsoft.com/office/drawing/2014/main" id="{356BA9C2-18F1-43F0-9CB0-4E2BF1970BF3}"/>
+              </a:ext>
+            </a:extLst>
+          </p:cNvPr>
+          <p:cNvSpPr>
+            <a:spLocks xmlns:a="http://schemas.openxmlformats.org/drawingml/2006/main" noGrp="1"/>
+          </p:cNvSpPr>
+          <p:nvPr/>
+        </p:nvSpPr>
+        <p:spPr>
+          <a:xfrm xmlns:a="http://schemas.openxmlformats.org/drawingml/2006/main">
+            <a:off x="1000125" y="6848475"/>
+            <a:ext cx="5429250" cy="495300"/>
+          </a:xfrm>
+          <a:prstGeom xmlns:a="http://schemas.openxmlformats.org/drawingml/2006/main" prst="rect">
+            <a:avLst/>
+          </a:prstGeom>
+          <a:noFill xmlns:a="http://schemas.openxmlformats.org/drawingml/2006/main"/>
+          <a:ln xmlns:a="http://schemas.openxmlformats.org/drawingml/2006/main" w="0">
+            <a:noFill/>
+          </a:ln>
+        </p:spPr>
+        <p:txBody>
+          <a:bodyPr xmlns:a="http://schemas.openxmlformats.org/drawingml/2006/main" lIns="0" tIns="0" rIns="0" bIns="0"/>
+          <a:lstStyle xmlns:a="http://schemas.openxmlformats.org/drawingml/2006/main">
+            <a:defPPr>
+              <a:defRPr sz="2325" b="1">
+                <a:solidFill>
+                  <a:srgbClr val="225B4B"/>
+                </a:solidFill>
+                <a:latin typeface="Arial"/>
+                <a:ea typeface="Arial"/>
+                <a:cs typeface="Arial"/>
+              </a:defRPr>
+            </a:defPPr>
+          </a:lstStyle>
+          <a:p xmlns:a="http://schemas.openxmlformats.org/drawingml/2006/main">
+            <a:pPr>
+              <a:defRPr sz="2325" b="1">
+                <a:solidFill>
+                  <a:srgbClr val="225B4B"/>
+                </a:solidFill>
+                <a:latin typeface="Arial"/>
+                <a:ea typeface="Arial"/>
+                <a:cs typeface="Arial"/>
+              </a:defRPr>
+            </a:pPr>
+            <a:r>
+              <a:rPr sz="2325" b="1">
+                <a:solidFill>
+                  <a:srgbClr val="225B4B"/>
+                </a:solidFill>
+                <a:latin typeface="Arial"/>
+                <a:ea typeface="Arial"/>
+                <a:cs typeface="Arial"/>
+              </a:rPr>
+              <a:t>Controlled fetch test</a:t>
+            </a:r>
+          </a:p>
+        </p:txBody>
+      </p:sp>
+      <p:sp>
+        <p:nvSpPr>
+          <p:cNvPr id="9" name="">
+            <a:extLst xmlns:a="http://schemas.openxmlformats.org/drawingml/2006/main">
+              <a:ext uri="{FF2B5EF4-FFF2-40B4-BE49-F238E27FC236}">
+                <a16:creationId xmlns:a16="http://schemas.microsoft.com/office/drawing/2014/main" id="{621E3294-C521-48CE-9FCD-0DCD17BD1E81}"/>
+              </a:ext>
+            </a:extLst>
+          </p:cNvPr>
+          <p:cNvSpPr>
+            <a:spLocks xmlns:a="http://schemas.openxmlformats.org/drawingml/2006/main" noGrp="1"/>
+          </p:cNvSpPr>
+          <p:nvPr/>
+        </p:nvSpPr>
+        <p:spPr>
+          <a:xfrm xmlns:a="http://schemas.openxmlformats.org/drawingml/2006/main">
+            <a:off x="6762750" y="6848475"/>
+            <a:ext cx="10477500" cy="857250"/>
+          </a:xfrm>
+          <a:prstGeom xmlns:a="http://schemas.openxmlformats.org/drawingml/2006/main" prst="rect">
+            <a:avLst/>
+          </a:prstGeom>
+          <a:noFill xmlns:a="http://schemas.openxmlformats.org/drawingml/2006/main"/>
+          <a:ln xmlns:a="http://schemas.openxmlformats.org/drawingml/2006/main" w="0">
+            <a:noFill/>
+          </a:ln>
+        </p:spPr>
+        <p:txBody>
+          <a:bodyPr xmlns:a="http://schemas.openxmlformats.org/drawingml/2006/main" lIns="0" tIns="0" rIns="0" bIns="0"/>
+          <a:lstStyle xmlns:a="http://schemas.openxmlformats.org/drawingml/2006/main">
+            <a:defPPr>
+              <a:defRPr sz="2325" b="0">
+                <a:solidFill>
+                  <a:srgbClr val="17372E"/>
+                </a:solidFill>
+                <a:latin typeface="Arial"/>
+                <a:ea typeface="Arial"/>
+                <a:cs typeface="Arial"/>
+              </a:defRPr>
+            </a:defPPr>
+          </a:lstStyle>
+          <a:p xmlns:a="http://schemas.openxmlformats.org/drawingml/2006/main">
+            <a:pPr>
+              <a:defRPr sz="2325" b="0">
+                <a:solidFill>
+                  <a:srgbClr val="17372E"/>
+                </a:solidFill>
+                <a:latin typeface="Arial"/>
+                <a:ea typeface="Arial"/>
+                <a:cs typeface="Arial"/>
+              </a:defRPr>
+            </a:pPr>
+            <a:r>
+              <a:rPr sz="2325" b="0">
+                <a:solidFill>
+                  <a:srgbClr val="17372E"/>
+                </a:solidFill>
+                <a:latin typeface="Arial"/>
+                <a:ea typeface="Arial"/>
+                <a:cs typeface="Arial"/>
+              </a:rPr>
+              <a:t>A clean npm consumer verified both graphs through Arkiv RPC.</a:t>
+            </a:r>
+          </a:p>
+          <a:p xmlns:a="http://schemas.openxmlformats.org/drawingml/2006/main">
+            <a:pPr>
+              <a:defRPr sz="2325" b="0">
+                <a:solidFill>
+                  <a:srgbClr val="17372E"/>
+                </a:solidFill>
+                <a:latin typeface="Arial"/>
+                <a:ea typeface="Arial"/>
+                <a:cs typeface="Arial"/>
+              </a:defRPr>
+            </a:pPr>
+            <a:r>
+              <a:rPr sz="2325" b="0">
+                <a:solidFill>
+                  <a:srgbClr val="17372E"/>
+                </a:solidFill>
+                <a:latin typeface="Arial"/>
+                <a:ea typeface="Arial"/>
+                <a:cs typeface="Arial"/>
+              </a:rPr>
+              <a:t>In-process fetch blocking rejected project API requests.</a:t>
+            </a:r>
+          </a:p>
+        </p:txBody>
+      </p:sp>
+      <p:sp>
+        <p:nvSpPr>
+          <p:cNvPr id="10" name="">
+            <a:extLst xmlns:a="http://schemas.openxmlformats.org/drawingml/2006/main">
+              <a:ext uri="{FF2B5EF4-FFF2-40B4-BE49-F238E27FC236}">
+                <a16:creationId xmlns:a16="http://schemas.microsoft.com/office/drawing/2014/main" id="{D8AA8487-C5B6-49AF-9623-D139755DA742}"/>
               </a:ext>
             </a:extLst>
           </p:cNvPr>
@@ -9600,10 +9755,10 @@
       </p:sp>
       <p:sp>
         <p:nvSpPr>
-          <p:cNvPr id="9" name="">
-            <a:extLst xmlns:a="http://schemas.openxmlformats.org/drawingml/2006/main">
-              <a:ext uri="{FF2B5EF4-FFF2-40B4-BE49-F238E27FC236}">
-                <a16:creationId xmlns:a16="http://schemas.microsoft.com/office/drawing/2014/main" id="{3C04CF8A-4B3F-41E4-9399-F339125632C1}"/>
+          <p:cNvPr id="11" name="">
+            <a:extLst xmlns:a="http://schemas.openxmlformats.org/drawingml/2006/main">
+              <a:ext uri="{FF2B5EF4-FFF2-40B4-BE49-F238E27FC236}">
+                <a16:creationId xmlns:a16="http://schemas.microsoft.com/office/drawing/2014/main" id="{7B382292-DC26-4B00-8D2C-F8E9FA699027}"/>
               </a:ext>
             </a:extLst>
           </p:cNvPr>
@@ -9629,7 +9784,7 @@
           <a:bodyPr xmlns:a="http://schemas.openxmlformats.org/drawingml/2006/main" lIns="0" tIns="0" rIns="0" bIns="0"/>
           <a:lstStyle xmlns:a="http://schemas.openxmlformats.org/drawingml/2006/main">
             <a:defPPr>
-              <a:defRPr sz="2475" b="0">
+              <a:defRPr sz="2325" b="0">
                 <a:solidFill>
                   <a:srgbClr val="17372E"/>
                 </a:solidFill>
@@ -9641,7 +9796,7 @@
           </a:lstStyle>
           <a:p xmlns:a="http://schemas.openxmlformats.org/drawingml/2006/main">
             <a:pPr>
-              <a:defRPr sz="2475" b="0">
+              <a:defRPr sz="2325" b="0">
                 <a:solidFill>
                   <a:srgbClr val="17372E"/>
                 </a:solidFill>
@@ -9651,7 +9806,7 @@
               </a:defRPr>
             </a:pPr>
             <a:r>
-              <a:rPr sz="2475" b="0">
+              <a:rPr sz="2325" b="0">
                 <a:solidFill>
                   <a:srgbClr val="17372E"/>
                 </a:solidFill>
@@ -9666,10 +9821,10 @@
       </p:sp>
       <p:sp>
         <p:nvSpPr>
-          <p:cNvPr id="10" name="">
-            <a:extLst xmlns:a="http://schemas.openxmlformats.org/drawingml/2006/main">
-              <a:ext uri="{FF2B5EF4-FFF2-40B4-BE49-F238E27FC236}">
-                <a16:creationId xmlns:a16="http://schemas.microsoft.com/office/drawing/2014/main" id="{2E32A0A0-143D-4F1C-9B7D-C235BAA51798}"/>
+          <p:cNvPr id="12" name="">
+            <a:extLst xmlns:a="http://schemas.openxmlformats.org/drawingml/2006/main">
+              <a:ext uri="{FF2B5EF4-FFF2-40B4-BE49-F238E27FC236}">
+                <a16:creationId xmlns:a16="http://schemas.microsoft.com/office/drawing/2014/main" id="{B816DE86-B505-4B9D-9BAF-633E62196363}"/>
               </a:ext>
             </a:extLst>
           </p:cNvPr>
@@ -9725,7 +9880,7 @@
                 <a:ea typeface="Arial"/>
                 <a:cs typeface="Arial"/>
               </a:rPr>
-              <a:t>Defensibility today comes from integration quality. Independent adoption is still to earn.</a:t>
+              <a:t>Current differentiation comes from integration quality. Independent adoption is still to earn.</a:t>
             </a:r>
           </a:p>
         </p:txBody>
@@ -9733,7 +9888,7 @@
     </p:spTree>
     <p:extLst>
       <p:ext uri="{BB962C8B-B14F-4D97-AF65-F5344CB8AC3E}">
-        <p14:creationId xmlns:p14="http://schemas.microsoft.com/office/powerpoint/2010/main" val="1991230628"/>
+        <p14:creationId xmlns:p14="http://schemas.microsoft.com/office/powerpoint/2010/main" val="1939341093"/>
       </p:ext>
     </p:extLst>
   </p:cSld>
@@ -9764,7 +9919,7 @@
           <p:cNvPr id="17" name="">
             <a:extLst xmlns:a="http://schemas.openxmlformats.org/drawingml/2006/main">
               <a:ext uri="{FF2B5EF4-FFF2-40B4-BE49-F238E27FC236}">
-                <a16:creationId xmlns:a16="http://schemas.microsoft.com/office/drawing/2014/main" id="{0049B9C3-8339-47BA-A3E5-0BFCE0D17496}"/>
+                <a16:creationId xmlns:a16="http://schemas.microsoft.com/office/drawing/2014/main" id="{8926EA9A-5570-4818-898B-687ABBEB9A91}"/>
               </a:ext>
             </a:extLst>
           </p:cNvPr>
@@ -9820,7 +9975,7 @@
                 <a:ea typeface="Arial"/>
                 <a:cs typeface="Arial"/>
               </a:rPr>
-              <a:t>PUBLISHED PACKAGES / REPRODUCIBLE EVIDENCE</a:t>
+              <a:t>PACKAGES / REPRODUCIBLE EVIDENCE</a:t>
             </a:r>
           </a:p>
         </p:txBody>
@@ -9830,7 +9985,7 @@
           <p:cNvPr id="2" name="">
             <a:extLst xmlns:a="http://schemas.openxmlformats.org/drawingml/2006/main">
               <a:ext uri="{FF2B5EF4-FFF2-40B4-BE49-F238E27FC236}">
-                <a16:creationId xmlns:a16="http://schemas.microsoft.com/office/drawing/2014/main" id="{E9D06EB9-C830-483E-B9BC-94C3E5198BB4}"/>
+                <a16:creationId xmlns:a16="http://schemas.microsoft.com/office/drawing/2014/main" id="{2A42438D-7C31-46CC-A8F3-45C57A46F563}"/>
               </a:ext>
             </a:extLst>
           </p:cNvPr>
@@ -9896,7 +10051,7 @@
           <p:cNvPr id="3" name="">
             <a:extLst xmlns:a="http://schemas.openxmlformats.org/drawingml/2006/main">
               <a:ext uri="{FF2B5EF4-FFF2-40B4-BE49-F238E27FC236}">
-                <a16:creationId xmlns:a16="http://schemas.microsoft.com/office/drawing/2014/main" id="{E138EF10-A121-4862-B9D4-62C4DB52AFA3}"/>
+                <a16:creationId xmlns:a16="http://schemas.microsoft.com/office/drawing/2014/main" id="{EEC0E259-8A97-4441-9622-ED959B477BBB}"/>
               </a:ext>
             </a:extLst>
           </p:cNvPr>
@@ -9926,7 +10081,7 @@
           <p:cNvPr id="4" name="">
             <a:extLst xmlns:a="http://schemas.openxmlformats.org/drawingml/2006/main">
               <a:ext uri="{FF2B5EF4-FFF2-40B4-BE49-F238E27FC236}">
-                <a16:creationId xmlns:a16="http://schemas.microsoft.com/office/drawing/2014/main" id="{0F2A21EC-629E-4C84-8AB2-09078A5516B8}"/>
+                <a16:creationId xmlns:a16="http://schemas.microsoft.com/office/drawing/2014/main" id="{62950DF8-38A4-48D9-8199-D7C684CBED94}"/>
               </a:ext>
             </a:extLst>
           </p:cNvPr>
@@ -9992,7 +10147,7 @@
           <p:cNvPr id="5" name="">
             <a:extLst xmlns:a="http://schemas.openxmlformats.org/drawingml/2006/main">
               <a:ext uri="{FF2B5EF4-FFF2-40B4-BE49-F238E27FC236}">
-                <a16:creationId xmlns:a16="http://schemas.microsoft.com/office/drawing/2014/main" id="{925BB49A-8DEF-41DD-948C-82B058CC33BA}"/>
+                <a16:creationId xmlns:a16="http://schemas.microsoft.com/office/drawing/2014/main" id="{94694185-8EC8-4E45-BED5-C4EA177C7841}"/>
               </a:ext>
             </a:extLst>
           </p:cNvPr>
@@ -10058,7 +10213,7 @@
           <p:cNvPr id="6" name="">
             <a:extLst xmlns:a="http://schemas.openxmlformats.org/drawingml/2006/main">
               <a:ext uri="{FF2B5EF4-FFF2-40B4-BE49-F238E27FC236}">
-                <a16:creationId xmlns:a16="http://schemas.microsoft.com/office/drawing/2014/main" id="{8F41B20B-B953-4AEC-97BD-F6689B09429E}"/>
+                <a16:creationId xmlns:a16="http://schemas.microsoft.com/office/drawing/2014/main" id="{98D0B19A-7CCF-4A16-88E6-02198D746DDA}"/>
               </a:ext>
             </a:extLst>
           </p:cNvPr>
@@ -10114,7 +10269,7 @@
                 <a:ea typeface="Georgia"/>
                 <a:cs typeface="Georgia"/>
               </a:rPr>
-              <a:t>Published packages, reproducible checks</a:t>
+              <a:t>Packages and reproducible checks</a:t>
             </a:r>
           </a:p>
         </p:txBody>
@@ -10124,7 +10279,7 @@
           <p:cNvPr id="7" name="">
             <a:extLst xmlns:a="http://schemas.openxmlformats.org/drawingml/2006/main">
               <a:ext uri="{FF2B5EF4-FFF2-40B4-BE49-F238E27FC236}">
-                <a16:creationId xmlns:a16="http://schemas.microsoft.com/office/drawing/2014/main" id="{AF9A4233-D473-4413-B632-B2C2E4624D04}"/>
+                <a16:creationId xmlns:a16="http://schemas.microsoft.com/office/drawing/2014/main" id="{5D04D9C2-2AFD-42AA-8EE3-40D24788E5F8}"/>
               </a:ext>
             </a:extLst>
           </p:cNvPr>
@@ -10190,7 +10345,7 @@
           <p:cNvPr id="8" name="Chart">
             <a:extLst xmlns:a="http://schemas.openxmlformats.org/drawingml/2006/main">
               <a:ext uri="{FF2B5EF4-FFF2-40B4-BE49-F238E27FC236}">
-                <a16:creationId xmlns:a16="http://schemas.microsoft.com/office/drawing/2014/main" id="{0763DF4B-27CB-4DE2-BD7C-88FA3E020C8C}"/>
+                <a16:creationId xmlns:a16="http://schemas.microsoft.com/office/drawing/2014/main" id="{E801544E-C197-40EE-9C32-6A8E13453B2F}"/>
               </a:ext>
             </a:extLst>
           </p:cNvPr>
@@ -10203,7 +10358,7 @@
         </p:xfrm>
         <a:graphic xmlns:a="http://schemas.openxmlformats.org/drawingml/2006/main">
           <a:graphicData uri="http://schemas.openxmlformats.org/drawingml/2006/chart">
-            <c:chart xmlns:r="http://schemas.openxmlformats.org/officeDocument/2006/relationships" xmlns:c="http://schemas.openxmlformats.org/drawingml/2006/chart" r:id="R66637495e50c476f"/>
+            <c:chart xmlns:r="http://schemas.openxmlformats.org/officeDocument/2006/relationships" xmlns:c="http://schemas.openxmlformats.org/drawingml/2006/chart" r:id="Rc4c86db34e744e65"/>
           </a:graphicData>
         </a:graphic>
       </p:graphicFrame>
@@ -10212,7 +10367,7 @@
           <p:cNvPr id="9" name="">
             <a:extLst xmlns:a="http://schemas.openxmlformats.org/drawingml/2006/main">
               <a:ext uri="{FF2B5EF4-FFF2-40B4-BE49-F238E27FC236}">
-                <a16:creationId xmlns:a16="http://schemas.microsoft.com/office/drawing/2014/main" id="{1F8AA16F-B381-4E7E-8503-AFC874A3646A}"/>
+                <a16:creationId xmlns:a16="http://schemas.microsoft.com/office/drawing/2014/main" id="{43738BA7-5E26-41EE-A6F8-A9670FA72EA0}"/>
               </a:ext>
             </a:extLst>
           </p:cNvPr>
@@ -10301,7 +10456,7 @@
           <p:cNvPr id="10" name="">
             <a:extLst xmlns:a="http://schemas.openxmlformats.org/drawingml/2006/main">
               <a:ext uri="{FF2B5EF4-FFF2-40B4-BE49-F238E27FC236}">
-                <a16:creationId xmlns:a16="http://schemas.microsoft.com/office/drawing/2014/main" id="{6B4C8031-6937-464B-8B6E-B8DD5BE4BD4A}"/>
+                <a16:creationId xmlns:a16="http://schemas.microsoft.com/office/drawing/2014/main" id="{5287F990-C53B-4EE0-B36C-4B3DF8BE30FA}"/>
               </a:ext>
             </a:extLst>
           </p:cNvPr>
@@ -10357,7 +10512,7 @@
                 <a:ea typeface="Georgia"/>
                 <a:cs typeface="Georgia"/>
               </a:rPr>
-              <a:t>271 local tests</a:t>
+              <a:t>274 local tests</a:t>
             </a:r>
           </a:p>
         </p:txBody>
@@ -10367,7 +10522,7 @@
           <p:cNvPr id="11" name="">
             <a:extLst xmlns:a="http://schemas.openxmlformats.org/drawingml/2006/main">
               <a:ext uri="{FF2B5EF4-FFF2-40B4-BE49-F238E27FC236}">
-                <a16:creationId xmlns:a16="http://schemas.microsoft.com/office/drawing/2014/main" id="{D87EADC8-8043-4AD1-9DD1-8ED1A7787FD8}"/>
+                <a16:creationId xmlns:a16="http://schemas.microsoft.com/office/drawing/2014/main" id="{A94DF03A-06AB-4A7F-9C23-EBE9A79EFDB2}"/>
               </a:ext>
             </a:extLst>
           </p:cNvPr>
@@ -10433,7 +10588,7 @@
           <p:cNvPr id="12" name="">
             <a:extLst xmlns:a="http://schemas.openxmlformats.org/drawingml/2006/main">
               <a:ext uri="{FF2B5EF4-FFF2-40B4-BE49-F238E27FC236}">
-                <a16:creationId xmlns:a16="http://schemas.microsoft.com/office/drawing/2014/main" id="{B32AE396-E726-4089-AA69-2FF00A7AA819}"/>
+                <a16:creationId xmlns:a16="http://schemas.microsoft.com/office/drawing/2014/main" id="{D0288833-88A4-4D23-9AC7-5015A010F936}"/>
               </a:ext>
             </a:extLst>
           </p:cNvPr>
@@ -10463,7 +10618,7 @@
           <p:cNvPr id="13" name="">
             <a:extLst xmlns:a="http://schemas.openxmlformats.org/drawingml/2006/main">
               <a:ext uri="{FF2B5EF4-FFF2-40B4-BE49-F238E27FC236}">
-                <a16:creationId xmlns:a16="http://schemas.microsoft.com/office/drawing/2014/main" id="{3661E719-7206-4A23-859C-F145F38CD3FF}"/>
+                <a16:creationId xmlns:a16="http://schemas.microsoft.com/office/drawing/2014/main" id="{12219C17-4713-43F8-A622-652ACDC4FD41}"/>
               </a:ext>
             </a:extLst>
           </p:cNvPr>
@@ -10529,7 +10684,7 @@
           <p:cNvPr id="14" name="">
             <a:extLst xmlns:a="http://schemas.openxmlformats.org/drawingml/2006/main">
               <a:ext uri="{FF2B5EF4-FFF2-40B4-BE49-F238E27FC236}">
-                <a16:creationId xmlns:a16="http://schemas.microsoft.com/office/drawing/2014/main" id="{922192DB-A36D-40C4-A1F9-4599C5273082}"/>
+                <a16:creationId xmlns:a16="http://schemas.microsoft.com/office/drawing/2014/main" id="{4025F731-717F-47AF-829D-53AD9524950A}"/>
               </a:ext>
             </a:extLst>
           </p:cNvPr>
@@ -10585,7 +10740,7 @@
                 <a:ea typeface="Consolas"/>
                 <a:cs typeface="Consolas"/>
               </a:rPr>
-              <a:t>arkiv-graph  0.4.0</a:t>
+              <a:t>arkiv-graph  0.4.1</a:t>
             </a:r>
           </a:p>
           <a:p xmlns:a="http://schemas.openxmlformats.org/drawingml/2006/main">
@@ -10608,7 +10763,7 @@
                 <a:ea typeface="Consolas"/>
                 <a:cs typeface="Consolas"/>
               </a:rPr>
-              <a:t>ai-passport  0.6.0</a:t>
+              <a:t>ai-passport  0.6.1</a:t>
             </a:r>
           </a:p>
         </p:txBody>
@@ -10618,7 +10773,7 @@
           <p:cNvPr id="15" name="">
             <a:extLst xmlns:a="http://schemas.openxmlformats.org/drawingml/2006/main">
               <a:ext uri="{FF2B5EF4-FFF2-40B4-BE49-F238E27FC236}">
-                <a16:creationId xmlns:a16="http://schemas.microsoft.com/office/drawing/2014/main" id="{1BD2F011-E25A-4B3F-87F0-F525AC0B11E0}"/>
+                <a16:creationId xmlns:a16="http://schemas.microsoft.com/office/drawing/2014/main" id="{6868AF58-BBD7-4444-97A9-DFB9707220DD}"/>
               </a:ext>
             </a:extLst>
           </p:cNvPr>
@@ -10707,7 +10862,7 @@
           <p:cNvPr id="16" name="">
             <a:extLst xmlns:a="http://schemas.openxmlformats.org/drawingml/2006/main">
               <a:ext uri="{FF2B5EF4-FFF2-40B4-BE49-F238E27FC236}">
-                <a16:creationId xmlns:a16="http://schemas.microsoft.com/office/drawing/2014/main" id="{D77ECBB7-FEDB-41D9-98B7-012413F32ADD}"/>
+                <a16:creationId xmlns:a16="http://schemas.microsoft.com/office/drawing/2014/main" id="{83DD98C6-9410-47A1-B43E-73A1F9EBD264}"/>
               </a:ext>
             </a:extLst>
           </p:cNvPr>
@@ -10771,7 +10926,7 @@
     </p:spTree>
     <p:extLst>
       <p:ext uri="{BB962C8B-B14F-4D97-AF65-F5344CB8AC3E}">
-        <p14:creationId xmlns:p14="http://schemas.microsoft.com/office/powerpoint/2010/main" val="193584060"/>
+        <p14:creationId xmlns:p14="http://schemas.microsoft.com/office/powerpoint/2010/main" val="227464002"/>
       </p:ext>
     </p:extLst>
   </p:cSld>
@@ -10802,7 +10957,7 @@
           <p:cNvPr id="18" name="">
             <a:extLst xmlns:a="http://schemas.openxmlformats.org/drawingml/2006/main">
               <a:ext uri="{FF2B5EF4-FFF2-40B4-BE49-F238E27FC236}">
-                <a16:creationId xmlns:a16="http://schemas.microsoft.com/office/drawing/2014/main" id="{AD6EB4E1-EAC5-4CF8-81E5-1A38FA29D6E3}"/>
+                <a16:creationId xmlns:a16="http://schemas.microsoft.com/office/drawing/2014/main" id="{63BC7154-5B82-4053-BD63-2568AAB5D0D5}"/>
               </a:ext>
             </a:extLst>
           </p:cNvPr>
@@ -10868,7 +11023,7 @@
           <p:cNvPr id="2" name="">
             <a:extLst xmlns:a="http://schemas.openxmlformats.org/drawingml/2006/main">
               <a:ext uri="{FF2B5EF4-FFF2-40B4-BE49-F238E27FC236}">
-                <a16:creationId xmlns:a16="http://schemas.microsoft.com/office/drawing/2014/main" id="{AA8150FF-2C4E-45BF-8360-72AA994AC5A4}"/>
+                <a16:creationId xmlns:a16="http://schemas.microsoft.com/office/drawing/2014/main" id="{148036F8-EC29-490C-80CC-B9C8AA7AEFC9}"/>
               </a:ext>
             </a:extLst>
           </p:cNvPr>
@@ -10934,7 +11089,7 @@
           <p:cNvPr id="3" name="">
             <a:extLst xmlns:a="http://schemas.openxmlformats.org/drawingml/2006/main">
               <a:ext uri="{FF2B5EF4-FFF2-40B4-BE49-F238E27FC236}">
-                <a16:creationId xmlns:a16="http://schemas.microsoft.com/office/drawing/2014/main" id="{84A8C663-E016-4F51-A31C-223049D4D601}"/>
+                <a16:creationId xmlns:a16="http://schemas.microsoft.com/office/drawing/2014/main" id="{DDAFCB36-0484-4F74-8BF8-D593D917DEEE}"/>
               </a:ext>
             </a:extLst>
           </p:cNvPr>
@@ -10964,7 +11119,7 @@
           <p:cNvPr id="4" name="">
             <a:extLst xmlns:a="http://schemas.openxmlformats.org/drawingml/2006/main">
               <a:ext uri="{FF2B5EF4-FFF2-40B4-BE49-F238E27FC236}">
-                <a16:creationId xmlns:a16="http://schemas.microsoft.com/office/drawing/2014/main" id="{B2D94E99-EC65-4255-A3B8-825E80BCCB55}"/>
+                <a16:creationId xmlns:a16="http://schemas.microsoft.com/office/drawing/2014/main" id="{CE2B14A6-6FF5-4B58-8097-21CFAE02BECD}"/>
               </a:ext>
             </a:extLst>
           </p:cNvPr>
@@ -11030,7 +11185,7 @@
           <p:cNvPr id="5" name="">
             <a:extLst xmlns:a="http://schemas.openxmlformats.org/drawingml/2006/main">
               <a:ext uri="{FF2B5EF4-FFF2-40B4-BE49-F238E27FC236}">
-                <a16:creationId xmlns:a16="http://schemas.microsoft.com/office/drawing/2014/main" id="{7BD94685-7FDE-42F0-934F-AAF33E848FE3}"/>
+                <a16:creationId xmlns:a16="http://schemas.microsoft.com/office/drawing/2014/main" id="{75BC97B7-C645-413C-A977-A56295688082}"/>
               </a:ext>
             </a:extLst>
           </p:cNvPr>
@@ -11096,7 +11251,7 @@
           <p:cNvPr id="6" name="">
             <a:extLst xmlns:a="http://schemas.openxmlformats.org/drawingml/2006/main">
               <a:ext uri="{FF2B5EF4-FFF2-40B4-BE49-F238E27FC236}">
-                <a16:creationId xmlns:a16="http://schemas.microsoft.com/office/drawing/2014/main" id="{0C1FC930-D9D0-4561-B3C5-37D031BD1687}"/>
+                <a16:creationId xmlns:a16="http://schemas.microsoft.com/office/drawing/2014/main" id="{1B953FFA-04C6-4FA7-9FF7-F92F6B7A8F43}"/>
               </a:ext>
             </a:extLst>
           </p:cNvPr>
@@ -11162,7 +11317,7 @@
           <p:cNvPr id="7" name="">
             <a:extLst xmlns:a="http://schemas.openxmlformats.org/drawingml/2006/main">
               <a:ext uri="{FF2B5EF4-FFF2-40B4-BE49-F238E27FC236}">
-                <a16:creationId xmlns:a16="http://schemas.microsoft.com/office/drawing/2014/main" id="{43AD19BC-3785-4A82-A22F-9D1B9EB0E346}"/>
+                <a16:creationId xmlns:a16="http://schemas.microsoft.com/office/drawing/2014/main" id="{DD35C85A-E59C-4B90-8EEB-C3212E8E29B5}"/>
               </a:ext>
             </a:extLst>
           </p:cNvPr>
@@ -11228,7 +11383,7 @@
           <p:cNvPr id="8" name="">
             <a:extLst xmlns:a="http://schemas.openxmlformats.org/drawingml/2006/main">
               <a:ext uri="{FF2B5EF4-FFF2-40B4-BE49-F238E27FC236}">
-                <a16:creationId xmlns:a16="http://schemas.microsoft.com/office/drawing/2014/main" id="{CB690FBC-0F50-488B-B34D-46EBE135B579}"/>
+                <a16:creationId xmlns:a16="http://schemas.microsoft.com/office/drawing/2014/main" id="{37EC6430-4E04-43BE-A30D-D1E9AFE1C71E}"/>
               </a:ext>
             </a:extLst>
           </p:cNvPr>
@@ -11258,7 +11413,7 @@
           <p:cNvPr id="9" name="">
             <a:extLst xmlns:a="http://schemas.openxmlformats.org/drawingml/2006/main">
               <a:ext uri="{FF2B5EF4-FFF2-40B4-BE49-F238E27FC236}">
-                <a16:creationId xmlns:a16="http://schemas.microsoft.com/office/drawing/2014/main" id="{AA922B5D-AC28-4B13-BD24-A18C3E443ABE}"/>
+                <a16:creationId xmlns:a16="http://schemas.microsoft.com/office/drawing/2014/main" id="{CEC80DE2-8C9D-430B-B478-EDCCD91691C8}"/>
               </a:ext>
             </a:extLst>
           </p:cNvPr>
@@ -11337,7 +11492,7 @@
                 <a:ea typeface="Consolas"/>
                 <a:cs typeface="Consolas"/>
               </a:rPr>
-              <a:t>npm install @ajnasnb/arkiv-graph@0.4.0</a:t>
+              <a:t>npm install @ajnasnb/arkiv-graph@0.4.1</a:t>
             </a:r>
           </a:p>
         </p:txBody>
@@ -11347,7 +11502,7 @@
           <p:cNvPr id="10" name="">
             <a:extLst xmlns:a="http://schemas.openxmlformats.org/drawingml/2006/main">
               <a:ext uri="{FF2B5EF4-FFF2-40B4-BE49-F238E27FC236}">
-                <a16:creationId xmlns:a16="http://schemas.microsoft.com/office/drawing/2014/main" id="{72274803-5CBB-4636-A8A1-99A66B070708}"/>
+                <a16:creationId xmlns:a16="http://schemas.microsoft.com/office/drawing/2014/main" id="{11C89E40-3AB9-467A-A4D5-CDCF76DA1C4C}"/>
               </a:ext>
             </a:extLst>
           </p:cNvPr>
@@ -11413,7 +11568,7 @@
           <p:cNvPr id="11" name="">
             <a:extLst xmlns:a="http://schemas.openxmlformats.org/drawingml/2006/main">
               <a:ext uri="{FF2B5EF4-FFF2-40B4-BE49-F238E27FC236}">
-                <a16:creationId xmlns:a16="http://schemas.microsoft.com/office/drawing/2014/main" id="{24F8BBA4-93C3-4E12-BBAA-C2A4B1B103A3}"/>
+                <a16:creationId xmlns:a16="http://schemas.microsoft.com/office/drawing/2014/main" id="{99FF3867-5A52-433A-BB32-004713CD5211}"/>
               </a:ext>
             </a:extLst>
           </p:cNvPr>
@@ -11479,7 +11634,7 @@
           <p:cNvPr id="12" name="">
             <a:extLst xmlns:a="http://schemas.openxmlformats.org/drawingml/2006/main">
               <a:ext uri="{FF2B5EF4-FFF2-40B4-BE49-F238E27FC236}">
-                <a16:creationId xmlns:a16="http://schemas.microsoft.com/office/drawing/2014/main" id="{C8B3CBE9-A9F5-42FA-8847-986C36A35753}"/>
+                <a16:creationId xmlns:a16="http://schemas.microsoft.com/office/drawing/2014/main" id="{15F7415C-C8B3-4864-B04C-2A667123C40F}"/>
               </a:ext>
             </a:extLst>
           </p:cNvPr>
@@ -11490,8 +11645,384 @@
         </p:nvSpPr>
         <p:spPr>
           <a:xfrm xmlns:a="http://schemas.openxmlformats.org/drawingml/2006/main">
-            <a:off x="1000125" y="8220075"/>
-            <a:ext cx="9525000" cy="485775"/>
+            <a:off x="1000125" y="8124825"/>
+            <a:ext cx="9525000" cy="685800"/>
+          </a:xfrm>
+          <a:prstGeom xmlns:a="http://schemas.openxmlformats.org/drawingml/2006/main" prst="rect">
+            <a:avLst/>
+          </a:prstGeom>
+          <a:noFill xmlns:a="http://schemas.openxmlformats.org/drawingml/2006/main"/>
+          <a:ln xmlns:a="http://schemas.openxmlformats.org/drawingml/2006/main" w="0">
+            <a:noFill/>
+          </a:ln>
+        </p:spPr>
+        <p:txBody>
+          <a:bodyPr xmlns:a="http://schemas.openxmlformats.org/drawingml/2006/main" lIns="0" tIns="0" rIns="0" bIns="0"/>
+          <a:lstStyle xmlns:a="http://schemas.openxmlformats.org/drawingml/2006/main">
+            <a:defPPr>
+              <a:defRPr sz="1950" b="0">
+                <a:solidFill>
+                  <a:srgbClr val="C4D8CD"/>
+                </a:solidFill>
+                <a:latin typeface="Arial"/>
+                <a:ea typeface="Arial"/>
+                <a:cs typeface="Arial"/>
+              </a:defRPr>
+            </a:defPPr>
+          </a:lstStyle>
+          <a:p xmlns:a="http://schemas.openxmlformats.org/drawingml/2006/main">
+            <a:pPr>
+              <a:defRPr sz="1950" b="0">
+                <a:solidFill>
+                  <a:srgbClr val="C4D8CD"/>
+                </a:solidFill>
+                <a:latin typeface="Arial"/>
+                <a:ea typeface="Arial"/>
+                <a:cs typeface="Arial"/>
+              </a:defRPr>
+            </a:pPr>
+            <a:r>
+              <a:rPr sz="1950" b="0">
+                <a:solidFill>
+                  <a:srgbClr val="C4D8CD"/>
+                </a:solidFill>
+                <a:latin typeface="Arial"/>
+                <a:ea typeface="Arial"/>
+                <a:cs typeface="Arial"/>
+              </a:rPr>
+              <a:t>No account, wallet or model is needed for this local example.</a:t>
+            </a:r>
+          </a:p>
+        </p:txBody>
+      </p:sp>
+      <p:sp>
+        <p:nvSpPr>
+          <p:cNvPr id="13" name="">
+            <a:extLst xmlns:a="http://schemas.openxmlformats.org/drawingml/2006/main">
+              <a:ext uri="{FF2B5EF4-FFF2-40B4-BE49-F238E27FC236}">
+                <a16:creationId xmlns:a16="http://schemas.microsoft.com/office/drawing/2014/main" id="{99211EB2-A6AF-41F5-B772-074F461F69B4}"/>
+              </a:ext>
+            </a:extLst>
+          </p:cNvPr>
+          <p:cNvSpPr>
+            <a:spLocks xmlns:a="http://schemas.openxmlformats.org/drawingml/2006/main" noGrp="1"/>
+          </p:cNvSpPr>
+          <p:nvPr/>
+        </p:nvSpPr>
+        <p:spPr>
+          <a:xfrm xmlns:a="http://schemas.openxmlformats.org/drawingml/2006/main">
+            <a:off x="1000125" y="8810625"/>
+            <a:ext cx="9810750" cy="438150"/>
+          </a:xfrm>
+          <a:prstGeom xmlns:a="http://schemas.openxmlformats.org/drawingml/2006/main" prst="rect">
+            <a:avLst/>
+          </a:prstGeom>
+          <a:noFill xmlns:a="http://schemas.openxmlformats.org/drawingml/2006/main"/>
+          <a:ln xmlns:a="http://schemas.openxmlformats.org/drawingml/2006/main" w="0">
+            <a:noFill/>
+          </a:ln>
+        </p:spPr>
+        <p:txBody>
+          <a:bodyPr xmlns:a="http://schemas.openxmlformats.org/drawingml/2006/main" lIns="0" tIns="0" rIns="0" bIns="0"/>
+          <a:lstStyle xmlns:a="http://schemas.openxmlformats.org/drawingml/2006/main">
+            <a:defPPr>
+              <a:defRPr sz="2250" b="0">
+                <a:solidFill>
+                  <a:srgbClr val="F9F8F3"/>
+                </a:solidFill>
+                <a:latin typeface="Arial"/>
+                <a:ea typeface="Arial"/>
+                <a:cs typeface="Arial"/>
+              </a:defRPr>
+            </a:defPPr>
+          </a:lstStyle>
+          <a:p xmlns:a="http://schemas.openxmlformats.org/drawingml/2006/main">
+            <a:pPr>
+              <a:defRPr sz="2250" b="0">
+                <a:solidFill>
+                  <a:srgbClr val="F9F8F3"/>
+                </a:solidFill>
+                <a:latin typeface="Arial"/>
+                <a:ea typeface="Arial"/>
+                <a:cs typeface="Arial"/>
+              </a:defRPr>
+            </a:pPr>
+            <a:r>
+              <a:rPr sz="2250" b="0">
+                <a:solidFill>
+                  <a:srgbClr val="F9F8F3"/>
+                </a:solidFill>
+                <a:latin typeface="Arial"/>
+                <a:ea typeface="Arial"/>
+                <a:cs typeface="Arial"/>
+              </a:rPr>
+              <a:t>arkivgraph.ajnasnb.com/?view=sdk</a:t>
+            </a:r>
+          </a:p>
+        </p:txBody>
+      </p:sp>
+      <p:sp>
+        <p:nvSpPr>
+          <p:cNvPr id="14" name="">
+            <a:extLst xmlns:a="http://schemas.openxmlformats.org/drawingml/2006/main">
+              <a:ext uri="{FF2B5EF4-FFF2-40B4-BE49-F238E27FC236}">
+                <a16:creationId xmlns:a16="http://schemas.microsoft.com/office/drawing/2014/main" id="{98F3BD72-F8A8-46E0-A794-674494B1FBB9}"/>
+              </a:ext>
+            </a:extLst>
+          </p:cNvPr>
+          <p:cNvSpPr>
+            <a:spLocks xmlns:a="http://schemas.openxmlformats.org/drawingml/2006/main" noGrp="1"/>
+          </p:cNvSpPr>
+          <p:nvPr/>
+        </p:nvSpPr>
+        <p:spPr>
+          <a:xfrm xmlns:a="http://schemas.openxmlformats.org/drawingml/2006/main">
+            <a:off x="11763375" y="3295650"/>
+            <a:ext cx="5524500" cy="1047750"/>
+          </a:xfrm>
+          <a:prstGeom xmlns:a="http://schemas.openxmlformats.org/drawingml/2006/main" prst="rect">
+            <a:avLst/>
+          </a:prstGeom>
+          <a:noFill xmlns:a="http://schemas.openxmlformats.org/drawingml/2006/main"/>
+          <a:ln xmlns:a="http://schemas.openxmlformats.org/drawingml/2006/main" w="0">
+            <a:noFill/>
+          </a:ln>
+        </p:spPr>
+        <p:txBody>
+          <a:bodyPr xmlns:a="http://schemas.openxmlformats.org/drawingml/2006/main" lIns="0" tIns="0" rIns="0" bIns="0"/>
+          <a:lstStyle xmlns:a="http://schemas.openxmlformats.org/drawingml/2006/main">
+            <a:defPPr>
+              <a:defRPr sz="3075" b="0">
+                <a:solidFill>
+                  <a:srgbClr val="F9F8F3"/>
+                </a:solidFill>
+                <a:latin typeface="Georgia"/>
+                <a:ea typeface="Georgia"/>
+                <a:cs typeface="Georgia"/>
+              </a:defRPr>
+            </a:defPPr>
+          </a:lstStyle>
+          <a:p xmlns:a="http://schemas.openxmlformats.org/drawingml/2006/main">
+            <a:pPr>
+              <a:defRPr sz="3075" b="0">
+                <a:solidFill>
+                  <a:srgbClr val="F9F8F3"/>
+                </a:solidFill>
+                <a:latin typeface="Georgia"/>
+                <a:ea typeface="Georgia"/>
+                <a:cs typeface="Georgia"/>
+              </a:defRPr>
+            </a:pPr>
+            <a:r>
+              <a:rPr sz="3075" b="0">
+                <a:solidFill>
+                  <a:srgbClr val="F9F8F3"/>
+                </a:solidFill>
+                <a:latin typeface="Georgia"/>
+                <a:ea typeface="Georgia"/>
+                <a:cs typeface="Georgia"/>
+              </a:rPr>
+              <a:t>What I would validate next</a:t>
+            </a:r>
+          </a:p>
+        </p:txBody>
+      </p:sp>
+      <p:sp>
+        <p:nvSpPr>
+          <p:cNvPr id="15" name="">
+            <a:extLst xmlns:a="http://schemas.openxmlformats.org/drawingml/2006/main">
+              <a:ext uri="{FF2B5EF4-FFF2-40B4-BE49-F238E27FC236}">
+                <a16:creationId xmlns:a16="http://schemas.microsoft.com/office/drawing/2014/main" id="{26E0DFC2-CE36-4860-BD4E-E9490F839E72}"/>
+              </a:ext>
+            </a:extLst>
+          </p:cNvPr>
+          <p:cNvSpPr>
+            <a:spLocks xmlns:a="http://schemas.openxmlformats.org/drawingml/2006/main" noGrp="1"/>
+          </p:cNvSpPr>
+          <p:nvPr/>
+        </p:nvSpPr>
+        <p:spPr>
+          <a:xfrm xmlns:a="http://schemas.openxmlformats.org/drawingml/2006/main">
+            <a:off x="11763375" y="4791075"/>
+            <a:ext cx="5524500" cy="1857375"/>
+          </a:xfrm>
+          <a:prstGeom xmlns:a="http://schemas.openxmlformats.org/drawingml/2006/main" prst="rect">
+            <a:avLst/>
+          </a:prstGeom>
+          <a:noFill xmlns:a="http://schemas.openxmlformats.org/drawingml/2006/main"/>
+          <a:ln xmlns:a="http://schemas.openxmlformats.org/drawingml/2006/main" w="0">
+            <a:noFill/>
+          </a:ln>
+        </p:spPr>
+        <p:txBody>
+          <a:bodyPr xmlns:a="http://schemas.openxmlformats.org/drawingml/2006/main" lIns="0" tIns="0" rIns="0" bIns="0"/>
+          <a:lstStyle xmlns:a="http://schemas.openxmlformats.org/drawingml/2006/main">
+            <a:defPPr>
+              <a:defRPr sz="2400" b="0">
+                <a:solidFill>
+                  <a:srgbClr val="C4D8CD"/>
+                </a:solidFill>
+                <a:latin typeface="Arial"/>
+                <a:ea typeface="Arial"/>
+                <a:cs typeface="Arial"/>
+              </a:defRPr>
+            </a:defPPr>
+          </a:lstStyle>
+          <a:p xmlns:a="http://schemas.openxmlformats.org/drawingml/2006/main">
+            <a:pPr>
+              <a:defRPr sz="2400" b="0">
+                <a:solidFill>
+                  <a:srgbClr val="C4D8CD"/>
+                </a:solidFill>
+                <a:latin typeface="Arial"/>
+                <a:ea typeface="Arial"/>
+                <a:cs typeface="Arial"/>
+              </a:defRPr>
+            </a:pPr>
+            <a:r>
+              <a:rPr sz="2400" b="0">
+                <a:solidFill>
+                  <a:srgbClr val="C4D8CD"/>
+                </a:solidFill>
+                <a:latin typeface="Arial"/>
+                <a:ea typeface="Arial"/>
+                <a:cs typeface="Arial"/>
+              </a:rPr>
+              <a:t>An unaided outside integration</a:t>
+            </a:r>
+          </a:p>
+          <a:p xmlns:a="http://schemas.openxmlformats.org/drawingml/2006/main">
+            <a:pPr>
+              <a:defRPr sz="2400" b="0">
+                <a:solidFill>
+                  <a:srgbClr val="C4D8CD"/>
+                </a:solidFill>
+                <a:latin typeface="Arial"/>
+                <a:ea typeface="Arial"/>
+                <a:cs typeface="Arial"/>
+              </a:defRPr>
+            </a:pPr>
+            <a:r>
+              <a:rPr sz="2400" b="0">
+                <a:solidFill>
+                  <a:srgbClr val="C4D8CD"/>
+                </a:solidFill>
+                <a:latin typeface="Arial"/>
+                <a:ea typeface="Arial"/>
+                <a:cs typeface="Arial"/>
+              </a:rPr>
+              <a:t>A second-provider strategy</a:t>
+            </a:r>
+          </a:p>
+          <a:p xmlns:a="http://schemas.openxmlformats.org/drawingml/2006/main">
+            <a:pPr>
+              <a:defRPr sz="2400" b="0">
+                <a:solidFill>
+                  <a:srgbClr val="C4D8CD"/>
+                </a:solidFill>
+                <a:latin typeface="Arial"/>
+                <a:ea typeface="Arial"/>
+                <a:cs typeface="Arial"/>
+              </a:defRPr>
+            </a:pPr>
+            <a:r>
+              <a:rPr sz="2400" b="0">
+                <a:solidFill>
+                  <a:srgbClr val="C4D8CD"/>
+                </a:solidFill>
+                <a:latin typeface="Arial"/>
+                <a:ea typeface="Arial"/>
+                <a:cs typeface="Arial"/>
+              </a:rPr>
+              <a:t>Larger graphs and real phones</a:t>
+            </a:r>
+          </a:p>
+        </p:txBody>
+      </p:sp>
+      <p:sp>
+        <p:nvSpPr>
+          <p:cNvPr id="16" name="">
+            <a:extLst xmlns:a="http://schemas.openxmlformats.org/drawingml/2006/main">
+              <a:ext uri="{FF2B5EF4-FFF2-40B4-BE49-F238E27FC236}">
+                <a16:creationId xmlns:a16="http://schemas.microsoft.com/office/drawing/2014/main" id="{CC5B82AE-035F-4E97-996A-7795C1DA886B}"/>
+              </a:ext>
+            </a:extLst>
+          </p:cNvPr>
+          <p:cNvSpPr>
+            <a:spLocks xmlns:a="http://schemas.openxmlformats.org/drawingml/2006/main" noGrp="1"/>
+          </p:cNvSpPr>
+          <p:nvPr/>
+        </p:nvSpPr>
+        <p:spPr>
+          <a:xfrm xmlns:a="http://schemas.openxmlformats.org/drawingml/2006/main">
+            <a:off x="11763375" y="7267575"/>
+            <a:ext cx="5524500" cy="514350"/>
+          </a:xfrm>
+          <a:prstGeom xmlns:a="http://schemas.openxmlformats.org/drawingml/2006/main" prst="rect">
+            <a:avLst/>
+          </a:prstGeom>
+          <a:noFill xmlns:a="http://schemas.openxmlformats.org/drawingml/2006/main"/>
+          <a:ln xmlns:a="http://schemas.openxmlformats.org/drawingml/2006/main" w="0">
+            <a:noFill/>
+          </a:ln>
+        </p:spPr>
+        <p:txBody>
+          <a:bodyPr xmlns:a="http://schemas.openxmlformats.org/drawingml/2006/main" lIns="0" tIns="0" rIns="0" bIns="0"/>
+          <a:lstStyle xmlns:a="http://schemas.openxmlformats.org/drawingml/2006/main">
+            <a:defPPr>
+              <a:defRPr sz="2250" b="1">
+                <a:solidFill>
+                  <a:srgbClr val="F9F8F3"/>
+                </a:solidFill>
+                <a:latin typeface="Arial"/>
+                <a:ea typeface="Arial"/>
+                <a:cs typeface="Arial"/>
+              </a:defRPr>
+            </a:defPPr>
+          </a:lstStyle>
+          <a:p xmlns:a="http://schemas.openxmlformats.org/drawingml/2006/main">
+            <a:pPr>
+              <a:defRPr sz="2250" b="1">
+                <a:solidFill>
+                  <a:srgbClr val="F9F8F3"/>
+                </a:solidFill>
+                <a:latin typeface="Arial"/>
+                <a:ea typeface="Arial"/>
+                <a:cs typeface="Arial"/>
+              </a:defRPr>
+            </a:pPr>
+            <a:r>
+              <a:rPr sz="2250" b="1">
+                <a:solidFill>
+                  <a:srgbClr val="F9F8F3"/>
+                </a:solidFill>
+                <a:latin typeface="Arial"/>
+                <a:ea typeface="Arial"/>
+                <a:cs typeface="Arial"/>
+              </a:rPr>
+              <a:t>Current trust boundary</a:t>
+            </a:r>
+          </a:p>
+        </p:txBody>
+      </p:sp>
+      <p:sp>
+        <p:nvSpPr>
+          <p:cNvPr id="17" name="">
+            <a:extLst xmlns:a="http://schemas.openxmlformats.org/drawingml/2006/main">
+              <a:ext uri="{FF2B5EF4-FFF2-40B4-BE49-F238E27FC236}">
+                <a16:creationId xmlns:a16="http://schemas.microsoft.com/office/drawing/2014/main" id="{CB8684B4-4E53-4B16-A927-97AD1141AFC6}"/>
+              </a:ext>
+            </a:extLst>
+          </p:cNvPr>
+          <p:cNvSpPr>
+            <a:spLocks xmlns:a="http://schemas.openxmlformats.org/drawingml/2006/main" noGrp="1"/>
+          </p:cNvSpPr>
+          <p:nvPr/>
+        </p:nvSpPr>
+        <p:spPr>
+          <a:xfrm xmlns:a="http://schemas.openxmlformats.org/drawingml/2006/main">
+            <a:off x="11763375" y="7905750"/>
+            <a:ext cx="5524500" cy="1200150"/>
           </a:xfrm>
           <a:prstGeom xmlns:a="http://schemas.openxmlformats.org/drawingml/2006/main" prst="rect">
             <a:avLst/>
@@ -11535,382 +12066,6 @@
                 <a:ea typeface="Arial"/>
                 <a:cs typeface="Arial"/>
               </a:rPr>
-              <a:t>No account, wallet or model is needed for this local example.</a:t>
-            </a:r>
-          </a:p>
-        </p:txBody>
-      </p:sp>
-      <p:sp>
-        <p:nvSpPr>
-          <p:cNvPr id="13" name="">
-            <a:extLst xmlns:a="http://schemas.openxmlformats.org/drawingml/2006/main">
-              <a:ext uri="{FF2B5EF4-FFF2-40B4-BE49-F238E27FC236}">
-                <a16:creationId xmlns:a16="http://schemas.microsoft.com/office/drawing/2014/main" id="{E4929A03-630E-4267-A4E3-309B15A8730D}"/>
-              </a:ext>
-            </a:extLst>
-          </p:cNvPr>
-          <p:cNvSpPr>
-            <a:spLocks xmlns:a="http://schemas.openxmlformats.org/drawingml/2006/main" noGrp="1"/>
-          </p:cNvSpPr>
-          <p:nvPr/>
-        </p:nvSpPr>
-        <p:spPr>
-          <a:xfrm xmlns:a="http://schemas.openxmlformats.org/drawingml/2006/main">
-            <a:off x="1000125" y="8810625"/>
-            <a:ext cx="9810750" cy="438150"/>
-          </a:xfrm>
-          <a:prstGeom xmlns:a="http://schemas.openxmlformats.org/drawingml/2006/main" prst="rect">
-            <a:avLst/>
-          </a:prstGeom>
-          <a:noFill xmlns:a="http://schemas.openxmlformats.org/drawingml/2006/main"/>
-          <a:ln xmlns:a="http://schemas.openxmlformats.org/drawingml/2006/main" w="0">
-            <a:noFill/>
-          </a:ln>
-        </p:spPr>
-        <p:txBody>
-          <a:bodyPr xmlns:a="http://schemas.openxmlformats.org/drawingml/2006/main" lIns="0" tIns="0" rIns="0" bIns="0"/>
-          <a:lstStyle xmlns:a="http://schemas.openxmlformats.org/drawingml/2006/main">
-            <a:defPPr>
-              <a:defRPr sz="2250" b="0">
-                <a:solidFill>
-                  <a:srgbClr val="F9F8F3"/>
-                </a:solidFill>
-                <a:latin typeface="Arial"/>
-                <a:ea typeface="Arial"/>
-                <a:cs typeface="Arial"/>
-              </a:defRPr>
-            </a:defPPr>
-          </a:lstStyle>
-          <a:p xmlns:a="http://schemas.openxmlformats.org/drawingml/2006/main">
-            <a:pPr>
-              <a:defRPr sz="2250" b="0">
-                <a:solidFill>
-                  <a:srgbClr val="F9F8F3"/>
-                </a:solidFill>
-                <a:latin typeface="Arial"/>
-                <a:ea typeface="Arial"/>
-                <a:cs typeface="Arial"/>
-              </a:defRPr>
-            </a:pPr>
-            <a:r>
-              <a:rPr sz="2250" b="0">
-                <a:solidFill>
-                  <a:srgbClr val="F9F8F3"/>
-                </a:solidFill>
-                <a:latin typeface="Arial"/>
-                <a:ea typeface="Arial"/>
-                <a:cs typeface="Arial"/>
-              </a:rPr>
-              <a:t>arkivgraph.ajnasnb.com/?view=sdk</a:t>
-            </a:r>
-          </a:p>
-        </p:txBody>
-      </p:sp>
-      <p:sp>
-        <p:nvSpPr>
-          <p:cNvPr id="14" name="">
-            <a:extLst xmlns:a="http://schemas.openxmlformats.org/drawingml/2006/main">
-              <a:ext uri="{FF2B5EF4-FFF2-40B4-BE49-F238E27FC236}">
-                <a16:creationId xmlns:a16="http://schemas.microsoft.com/office/drawing/2014/main" id="{6529D846-35EC-45F2-B7B8-E27504559774}"/>
-              </a:ext>
-            </a:extLst>
-          </p:cNvPr>
-          <p:cNvSpPr>
-            <a:spLocks xmlns:a="http://schemas.openxmlformats.org/drawingml/2006/main" noGrp="1"/>
-          </p:cNvSpPr>
-          <p:nvPr/>
-        </p:nvSpPr>
-        <p:spPr>
-          <a:xfrm xmlns:a="http://schemas.openxmlformats.org/drawingml/2006/main">
-            <a:off x="11763375" y="3295650"/>
-            <a:ext cx="5524500" cy="1047750"/>
-          </a:xfrm>
-          <a:prstGeom xmlns:a="http://schemas.openxmlformats.org/drawingml/2006/main" prst="rect">
-            <a:avLst/>
-          </a:prstGeom>
-          <a:noFill xmlns:a="http://schemas.openxmlformats.org/drawingml/2006/main"/>
-          <a:ln xmlns:a="http://schemas.openxmlformats.org/drawingml/2006/main" w="0">
-            <a:noFill/>
-          </a:ln>
-        </p:spPr>
-        <p:txBody>
-          <a:bodyPr xmlns:a="http://schemas.openxmlformats.org/drawingml/2006/main" lIns="0" tIns="0" rIns="0" bIns="0"/>
-          <a:lstStyle xmlns:a="http://schemas.openxmlformats.org/drawingml/2006/main">
-            <a:defPPr>
-              <a:defRPr sz="3075" b="0">
-                <a:solidFill>
-                  <a:srgbClr val="F9F8F3"/>
-                </a:solidFill>
-                <a:latin typeface="Georgia"/>
-                <a:ea typeface="Georgia"/>
-                <a:cs typeface="Georgia"/>
-              </a:defRPr>
-            </a:defPPr>
-          </a:lstStyle>
-          <a:p xmlns:a="http://schemas.openxmlformats.org/drawingml/2006/main">
-            <a:pPr>
-              <a:defRPr sz="3075" b="0">
-                <a:solidFill>
-                  <a:srgbClr val="F9F8F3"/>
-                </a:solidFill>
-                <a:latin typeface="Georgia"/>
-                <a:ea typeface="Georgia"/>
-                <a:cs typeface="Georgia"/>
-              </a:defRPr>
-            </a:pPr>
-            <a:r>
-              <a:rPr sz="3075" b="0">
-                <a:solidFill>
-                  <a:srgbClr val="F9F8F3"/>
-                </a:solidFill>
-                <a:latin typeface="Georgia"/>
-                <a:ea typeface="Georgia"/>
-                <a:cs typeface="Georgia"/>
-              </a:rPr>
-              <a:t>What I would validate next</a:t>
-            </a:r>
-          </a:p>
-        </p:txBody>
-      </p:sp>
-      <p:sp>
-        <p:nvSpPr>
-          <p:cNvPr id="15" name="">
-            <a:extLst xmlns:a="http://schemas.openxmlformats.org/drawingml/2006/main">
-              <a:ext uri="{FF2B5EF4-FFF2-40B4-BE49-F238E27FC236}">
-                <a16:creationId xmlns:a16="http://schemas.microsoft.com/office/drawing/2014/main" id="{1B5E9C84-1C12-4AAD-B1FA-4A7F43808ED0}"/>
-              </a:ext>
-            </a:extLst>
-          </p:cNvPr>
-          <p:cNvSpPr>
-            <a:spLocks xmlns:a="http://schemas.openxmlformats.org/drawingml/2006/main" noGrp="1"/>
-          </p:cNvSpPr>
-          <p:nvPr/>
-        </p:nvSpPr>
-        <p:spPr>
-          <a:xfrm xmlns:a="http://schemas.openxmlformats.org/drawingml/2006/main">
-            <a:off x="11763375" y="4791075"/>
-            <a:ext cx="5524500" cy="1857375"/>
-          </a:xfrm>
-          <a:prstGeom xmlns:a="http://schemas.openxmlformats.org/drawingml/2006/main" prst="rect">
-            <a:avLst/>
-          </a:prstGeom>
-          <a:noFill xmlns:a="http://schemas.openxmlformats.org/drawingml/2006/main"/>
-          <a:ln xmlns:a="http://schemas.openxmlformats.org/drawingml/2006/main" w="0">
-            <a:noFill/>
-          </a:ln>
-        </p:spPr>
-        <p:txBody>
-          <a:bodyPr xmlns:a="http://schemas.openxmlformats.org/drawingml/2006/main" lIns="0" tIns="0" rIns="0" bIns="0"/>
-          <a:lstStyle xmlns:a="http://schemas.openxmlformats.org/drawingml/2006/main">
-            <a:defPPr>
-              <a:defRPr sz="2400" b="0">
-                <a:solidFill>
-                  <a:srgbClr val="C4D8CD"/>
-                </a:solidFill>
-                <a:latin typeface="Arial"/>
-                <a:ea typeface="Arial"/>
-                <a:cs typeface="Arial"/>
-              </a:defRPr>
-            </a:defPPr>
-          </a:lstStyle>
-          <a:p xmlns:a="http://schemas.openxmlformats.org/drawingml/2006/main">
-            <a:pPr>
-              <a:defRPr sz="2400" b="0">
-                <a:solidFill>
-                  <a:srgbClr val="C4D8CD"/>
-                </a:solidFill>
-                <a:latin typeface="Arial"/>
-                <a:ea typeface="Arial"/>
-                <a:cs typeface="Arial"/>
-              </a:defRPr>
-            </a:pPr>
-            <a:r>
-              <a:rPr sz="2400" b="0">
-                <a:solidFill>
-                  <a:srgbClr val="C4D8CD"/>
-                </a:solidFill>
-                <a:latin typeface="Arial"/>
-                <a:ea typeface="Arial"/>
-                <a:cs typeface="Arial"/>
-              </a:rPr>
-              <a:t>An unaided outside integration</a:t>
-            </a:r>
-          </a:p>
-          <a:p xmlns:a="http://schemas.openxmlformats.org/drawingml/2006/main">
-            <a:pPr>
-              <a:defRPr sz="2400" b="0">
-                <a:solidFill>
-                  <a:srgbClr val="C4D8CD"/>
-                </a:solidFill>
-                <a:latin typeface="Arial"/>
-                <a:ea typeface="Arial"/>
-                <a:cs typeface="Arial"/>
-              </a:defRPr>
-            </a:pPr>
-            <a:r>
-              <a:rPr sz="2400" b="0">
-                <a:solidFill>
-                  <a:srgbClr val="C4D8CD"/>
-                </a:solidFill>
-                <a:latin typeface="Arial"/>
-                <a:ea typeface="Arial"/>
-                <a:cs typeface="Arial"/>
-              </a:rPr>
-              <a:t>A second-provider strategy</a:t>
-            </a:r>
-          </a:p>
-          <a:p xmlns:a="http://schemas.openxmlformats.org/drawingml/2006/main">
-            <a:pPr>
-              <a:defRPr sz="2400" b="0">
-                <a:solidFill>
-                  <a:srgbClr val="C4D8CD"/>
-                </a:solidFill>
-                <a:latin typeface="Arial"/>
-                <a:ea typeface="Arial"/>
-                <a:cs typeface="Arial"/>
-              </a:defRPr>
-            </a:pPr>
-            <a:r>
-              <a:rPr sz="2400" b="0">
-                <a:solidFill>
-                  <a:srgbClr val="C4D8CD"/>
-                </a:solidFill>
-                <a:latin typeface="Arial"/>
-                <a:ea typeface="Arial"/>
-                <a:cs typeface="Arial"/>
-              </a:rPr>
-              <a:t>Larger graphs and real phones</a:t>
-            </a:r>
-          </a:p>
-        </p:txBody>
-      </p:sp>
-      <p:sp>
-        <p:nvSpPr>
-          <p:cNvPr id="16" name="">
-            <a:extLst xmlns:a="http://schemas.openxmlformats.org/drawingml/2006/main">
-              <a:ext uri="{FF2B5EF4-FFF2-40B4-BE49-F238E27FC236}">
-                <a16:creationId xmlns:a16="http://schemas.microsoft.com/office/drawing/2014/main" id="{24BD9327-5E34-4585-BE49-1F1FE0BA99C4}"/>
-              </a:ext>
-            </a:extLst>
-          </p:cNvPr>
-          <p:cNvSpPr>
-            <a:spLocks xmlns:a="http://schemas.openxmlformats.org/drawingml/2006/main" noGrp="1"/>
-          </p:cNvSpPr>
-          <p:nvPr/>
-        </p:nvSpPr>
-        <p:spPr>
-          <a:xfrm xmlns:a="http://schemas.openxmlformats.org/drawingml/2006/main">
-            <a:off x="11763375" y="7267575"/>
-            <a:ext cx="5524500" cy="514350"/>
-          </a:xfrm>
-          <a:prstGeom xmlns:a="http://schemas.openxmlformats.org/drawingml/2006/main" prst="rect">
-            <a:avLst/>
-          </a:prstGeom>
-          <a:noFill xmlns:a="http://schemas.openxmlformats.org/drawingml/2006/main"/>
-          <a:ln xmlns:a="http://schemas.openxmlformats.org/drawingml/2006/main" w="0">
-            <a:noFill/>
-          </a:ln>
-        </p:spPr>
-        <p:txBody>
-          <a:bodyPr xmlns:a="http://schemas.openxmlformats.org/drawingml/2006/main" lIns="0" tIns="0" rIns="0" bIns="0"/>
-          <a:lstStyle xmlns:a="http://schemas.openxmlformats.org/drawingml/2006/main">
-            <a:defPPr>
-              <a:defRPr sz="2250" b="1">
-                <a:solidFill>
-                  <a:srgbClr val="F9F8F3"/>
-                </a:solidFill>
-                <a:latin typeface="Arial"/>
-                <a:ea typeface="Arial"/>
-                <a:cs typeface="Arial"/>
-              </a:defRPr>
-            </a:defPPr>
-          </a:lstStyle>
-          <a:p xmlns:a="http://schemas.openxmlformats.org/drawingml/2006/main">
-            <a:pPr>
-              <a:defRPr sz="2250" b="1">
-                <a:solidFill>
-                  <a:srgbClr val="F9F8F3"/>
-                </a:solidFill>
-                <a:latin typeface="Arial"/>
-                <a:ea typeface="Arial"/>
-                <a:cs typeface="Arial"/>
-              </a:defRPr>
-            </a:pPr>
-            <a:r>
-              <a:rPr sz="2250" b="1">
-                <a:solidFill>
-                  <a:srgbClr val="F9F8F3"/>
-                </a:solidFill>
-                <a:latin typeface="Arial"/>
-                <a:ea typeface="Arial"/>
-                <a:cs typeface="Arial"/>
-              </a:rPr>
-              <a:t>Current trust boundary</a:t>
-            </a:r>
-          </a:p>
-        </p:txBody>
-      </p:sp>
-      <p:sp>
-        <p:nvSpPr>
-          <p:cNvPr id="17" name="">
-            <a:extLst xmlns:a="http://schemas.openxmlformats.org/drawingml/2006/main">
-              <a:ext uri="{FF2B5EF4-FFF2-40B4-BE49-F238E27FC236}">
-                <a16:creationId xmlns:a16="http://schemas.microsoft.com/office/drawing/2014/main" id="{2B6F4A74-DD77-4505-A1C1-220EA778FA50}"/>
-              </a:ext>
-            </a:extLst>
-          </p:cNvPr>
-          <p:cNvSpPr>
-            <a:spLocks xmlns:a="http://schemas.openxmlformats.org/drawingml/2006/main" noGrp="1"/>
-          </p:cNvSpPr>
-          <p:nvPr/>
-        </p:nvSpPr>
-        <p:spPr>
-          <a:xfrm xmlns:a="http://schemas.openxmlformats.org/drawingml/2006/main">
-            <a:off x="11763375" y="7905750"/>
-            <a:ext cx="5524500" cy="1200150"/>
-          </a:xfrm>
-          <a:prstGeom xmlns:a="http://schemas.openxmlformats.org/drawingml/2006/main" prst="rect">
-            <a:avLst/>
-          </a:prstGeom>
-          <a:noFill xmlns:a="http://schemas.openxmlformats.org/drawingml/2006/main"/>
-          <a:ln xmlns:a="http://schemas.openxmlformats.org/drawingml/2006/main" w="0">
-            <a:noFill/>
-          </a:ln>
-        </p:spPr>
-        <p:txBody>
-          <a:bodyPr xmlns:a="http://schemas.openxmlformats.org/drawingml/2006/main" lIns="0" tIns="0" rIns="0" bIns="0"/>
-          <a:lstStyle xmlns:a="http://schemas.openxmlformats.org/drawingml/2006/main">
-            <a:defPPr>
-              <a:defRPr sz="2175" b="0">
-                <a:solidFill>
-                  <a:srgbClr val="C4D8CD"/>
-                </a:solidFill>
-                <a:latin typeface="Arial"/>
-                <a:ea typeface="Arial"/>
-                <a:cs typeface="Arial"/>
-              </a:defRPr>
-            </a:defPPr>
-          </a:lstStyle>
-          <a:p xmlns:a="http://schemas.openxmlformats.org/drawingml/2006/main">
-            <a:pPr>
-              <a:defRPr sz="2175" b="0">
-                <a:solidFill>
-                  <a:srgbClr val="C4D8CD"/>
-                </a:solidFill>
-                <a:latin typeface="Arial"/>
-                <a:ea typeface="Arial"/>
-                <a:cs typeface="Arial"/>
-              </a:defRPr>
-            </a:pPr>
-            <a:r>
-              <a:rPr sz="2175" b="0">
-                <a:solidFill>
-                  <a:srgbClr val="C4D8CD"/>
-                </a:solidFill>
-                <a:latin typeface="Arial"/>
-                <a:ea typeface="Arial"/>
-                <a:cs typeface="Arial"/>
-              </a:rPr>
               <a:t>Fresh readers still rely on RPC</a:t>
             </a:r>
           </a:p>
@@ -11965,7 +12120,7 @@
     </p:spTree>
     <p:extLst>
       <p:ext uri="{BB962C8B-B14F-4D97-AF65-F5344CB8AC3E}">
-        <p14:creationId xmlns:p14="http://schemas.microsoft.com/office/powerpoint/2010/main" val="1738783540"/>
+        <p14:creationId xmlns:p14="http://schemas.microsoft.com/office/powerpoint/2010/main" val="915463824"/>
       </p:ext>
     </p:extLst>
   </p:cSld>

</xml_diff>

<commit_message>
release: publish verified deck and minimal video refresh
</commit_message>
<xml_diff>
--- a/apps/web/public/downloads/arkiv-graph-pitch.pptx
+++ b/apps/web/public/downloads/arkiv-graph-pitch.pptx
@@ -2,20 +2,20 @@
 <file path=ppt/presentation.xml><?xml version="1.0" encoding="utf-8"?>
 <p:presentation xmlns:p="http://schemas.openxmlformats.org/presentationml/2006/main">
   <p:sldMasterIdLst>
-    <p:sldMasterId xmlns:r="http://schemas.openxmlformats.org/officeDocument/2006/relationships" id="2147483648" r:id="R4be02db97e5a4282"/>
+    <p:sldMasterId xmlns:r="http://schemas.openxmlformats.org/officeDocument/2006/relationships" id="2147483648" r:id="R6c4983b8acbd4d10"/>
   </p:sldMasterIdLst>
   <p:notesMasterIdLst>
-    <p:notesMasterId xmlns:r="http://schemas.openxmlformats.org/officeDocument/2006/relationships" r:id="R0c484a5c72be4548"/>
+    <p:notesMasterId xmlns:r="http://schemas.openxmlformats.org/officeDocument/2006/relationships" r:id="R0b2a240fe5124c84"/>
   </p:notesMasterIdLst>
   <p:sldIdLst>
-    <p:sldId xmlns:r="http://schemas.openxmlformats.org/officeDocument/2006/relationships" id="256" r:id="R0903433509974533"/>
-    <p:sldId xmlns:r="http://schemas.openxmlformats.org/officeDocument/2006/relationships" id="257" r:id="Rb401b1a88d984291"/>
-    <p:sldId xmlns:r="http://schemas.openxmlformats.org/officeDocument/2006/relationships" id="258" r:id="R41e637b62d35480e"/>
-    <p:sldId xmlns:r="http://schemas.openxmlformats.org/officeDocument/2006/relationships" id="259" r:id="R2cfd8074c14c4184"/>
-    <p:sldId xmlns:r="http://schemas.openxmlformats.org/officeDocument/2006/relationships" id="260" r:id="Rf35012de840f4dc0"/>
-    <p:sldId xmlns:r="http://schemas.openxmlformats.org/officeDocument/2006/relationships" id="261" r:id="R9de2d7d1520e4d6b"/>
-    <p:sldId xmlns:r="http://schemas.openxmlformats.org/officeDocument/2006/relationships" id="262" r:id="R83347c9252964738"/>
-    <p:sldId xmlns:r="http://schemas.openxmlformats.org/officeDocument/2006/relationships" id="263" r:id="R34ec6ca397e64b8f"/>
+    <p:sldId xmlns:r="http://schemas.openxmlformats.org/officeDocument/2006/relationships" id="256" r:id="Rc88e619b56ed4ad2"/>
+    <p:sldId xmlns:r="http://schemas.openxmlformats.org/officeDocument/2006/relationships" id="257" r:id="R42d1d306dd8e42d3"/>
+    <p:sldId xmlns:r="http://schemas.openxmlformats.org/officeDocument/2006/relationships" id="258" r:id="R1c304be33d2d48e5"/>
+    <p:sldId xmlns:r="http://schemas.openxmlformats.org/officeDocument/2006/relationships" id="259" r:id="R782f94d30cc8436a"/>
+    <p:sldId xmlns:r="http://schemas.openxmlformats.org/officeDocument/2006/relationships" id="260" r:id="Rc7cdc14c6bd8450a"/>
+    <p:sldId xmlns:r="http://schemas.openxmlformats.org/officeDocument/2006/relationships" id="261" r:id="R8a4c0b8f464e49ca"/>
+    <p:sldId xmlns:r="http://schemas.openxmlformats.org/officeDocument/2006/relationships" id="262" r:id="Rb9157595a0fa4c66"/>
+    <p:sldId xmlns:r="http://schemas.openxmlformats.org/officeDocument/2006/relationships" id="263" r:id="R234b305c9dc94c47"/>
   </p:sldIdLst>
   <p:sldSz cx="18288000" cy="10287000"/>
   <p:notesSz cx="6858000" cy="9144000"/>
@@ -869,7 +869,7 @@
           <a:lstStyle xmlns:a="http://schemas.openxmlformats.org/drawingml/2006/main"/>
           <a:p xmlns:a="http://schemas.openxmlformats.org/drawingml/2006/main">
             <a:r>
-              <a:t>All counts describe project-run checks. The current full suite passes 274 local tests. These and the 19 trust safeguards have different scopes. Graph 0.4.0 and AI Passport 0.6.0 were installed anonymously outside the workspace and matched reviewed release integrity. Graph 0.4.0's exact documented local example passes with 2 nodes and 1 edge with fetch disabled. The active patch versions shown here are Graph 0.4.1 and AI Passport 0.6.1, published. Historical clean-install evidence remains attributed to its recorded version until refreshed. Download statistics for 7-day and 30-day windows returned HTTP 404 at 2026-10-16T16:20:28.697Z. Unavailable does not mean zero users. The 18 historical Lighthouse 13.5 desktop-simulated mobile audits use 3 cold runs per route and phase. Before scores are 87/88/41 and after scores are 98/98/96. These scores do not grade later website changes, physical phones, field INP or this hackathon. https://arkivgraph.ajnasnb.com/data/mobile-performance.json ; https://arkivgraph.ajnasnb.com/data/npm-usage.json ; https://arkivgraph.ajnasnb.com/data/quickstart-proof.json ; https://arkivgraph.ajnasnb.com/data/security-evaluation.json.</a:t>
+              <a:t>All counts describe project-run checks. The current full suite passes 274 local tests. These and the 19 trust safeguards have different scopes. Graph 0.4.0 and AI Passport 0.6.0 were installed anonymously outside the workspace and matched reviewed release integrity. Graph 0.4.0's exact documented local example passes with 2 nodes and 1 edge with fetch disabled. The active patch versions shown here are Graph 0.4.1 and AI Passport 0.6.1, published. Historical clean-install evidence remains attributed to its recorded version until refreshed. Download statistics for 7-day and 30-day windows returned HTTP 404 at 2026-10-16T16:21:31.138Z. Unavailable does not mean zero users. The 18 historical Lighthouse 13.5 desktop-simulated mobile audits use 3 cold runs per route and phase. Before scores are 87/88/41 and after scores are 98/98/96. These scores do not grade later website changes, physical phones, field INP or this hackathon. https://arkivgraph.ajnasnb.com/data/mobile-performance.json ; https://arkivgraph.ajnasnb.com/data/npm-usage.json ; https://arkivgraph.ajnasnb.com/data/quickstart-proof.json ; https://arkivgraph.ajnasnb.com/data/security-evaluation.json.</a:t>
             </a:r>
           </a:p>
         </p:txBody>
@@ -986,7 +986,7 @@
           <p:cNvPr id="3" name="Title">
             <a:extLst xmlns:a="http://schemas.openxmlformats.org/drawingml/2006/main">
               <a:ext uri="{FF2B5EF4-FFF2-40B4-BE49-F238E27FC236}">
-                <a16:creationId xmlns:a16="http://schemas.microsoft.com/office/drawing/2014/main" id="{64172018-7738-4A31-9468-33FEE3D2F93D}"/>
+                <a16:creationId xmlns:a16="http://schemas.microsoft.com/office/drawing/2014/main" id="{0E2F14EE-D173-493A-B2AC-DF08D0E529B4}"/>
               </a:ext>
             </a:extLst>
           </p:cNvPr>
@@ -1143,7 +1143,7 @@
           <p:cNvPr id="2" name="Subtitle">
             <a:extLst xmlns:a="http://schemas.openxmlformats.org/drawingml/2006/main">
               <a:ext uri="{FF2B5EF4-FFF2-40B4-BE49-F238E27FC236}">
-                <a16:creationId xmlns:a16="http://schemas.microsoft.com/office/drawing/2014/main" id="{33EC97AE-ACB4-42A0-8CA7-7E29B5FDEEEF}"/>
+                <a16:creationId xmlns:a16="http://schemas.microsoft.com/office/drawing/2014/main" id="{A2FC2D3B-07F8-4388-AA2B-9FE4DBA9A573}"/>
               </a:ext>
             </a:extLst>
           </p:cNvPr>
@@ -1317,7 +1317,7 @@
           <p:cNvPr id="2" name="Section title">
             <a:extLst xmlns:a="http://schemas.openxmlformats.org/drawingml/2006/main">
               <a:ext uri="{FF2B5EF4-FFF2-40B4-BE49-F238E27FC236}">
-                <a16:creationId xmlns:a16="http://schemas.microsoft.com/office/drawing/2014/main" id="{F4A58D9F-253C-483B-BE55-D0B90F4A7AD7}"/>
+                <a16:creationId xmlns:a16="http://schemas.microsoft.com/office/drawing/2014/main" id="{D1E07AA8-672F-4510-A074-6DBE06A9B35C}"/>
               </a:ext>
             </a:extLst>
           </p:cNvPr>
@@ -1491,7 +1491,7 @@
           <p:cNvPr id="3" name="Title">
             <a:extLst xmlns:a="http://schemas.openxmlformats.org/drawingml/2006/main">
               <a:ext uri="{FF2B5EF4-FFF2-40B4-BE49-F238E27FC236}">
-                <a16:creationId xmlns:a16="http://schemas.microsoft.com/office/drawing/2014/main" id="{E7CAF89D-07B9-4C5F-A918-04C43B564A07}"/>
+                <a16:creationId xmlns:a16="http://schemas.microsoft.com/office/drawing/2014/main" id="{A0598909-0F26-4009-9C78-51141DCC3132}"/>
               </a:ext>
             </a:extLst>
           </p:cNvPr>
@@ -1648,7 +1648,7 @@
           <p:cNvPr id="2" name="Body">
             <a:extLst xmlns:a="http://schemas.openxmlformats.org/drawingml/2006/main">
               <a:ext uri="{FF2B5EF4-FFF2-40B4-BE49-F238E27FC236}">
-                <a16:creationId xmlns:a16="http://schemas.microsoft.com/office/drawing/2014/main" id="{B78FAB2D-F3A7-48A7-9570-32A47B4FFB6C}"/>
+                <a16:creationId xmlns:a16="http://schemas.microsoft.com/office/drawing/2014/main" id="{A0C6102B-657F-40E7-A0D9-C987106781E8}"/>
               </a:ext>
             </a:extLst>
           </p:cNvPr>
@@ -1822,7 +1822,7 @@
           <p:cNvPr id="4" name="Title">
             <a:extLst xmlns:a="http://schemas.openxmlformats.org/drawingml/2006/main">
               <a:ext uri="{FF2B5EF4-FFF2-40B4-BE49-F238E27FC236}">
-                <a16:creationId xmlns:a16="http://schemas.microsoft.com/office/drawing/2014/main" id="{24A5C065-FBCA-48BE-B48F-246E5D9884AE}"/>
+                <a16:creationId xmlns:a16="http://schemas.microsoft.com/office/drawing/2014/main" id="{97196F20-29F7-4E6D-9D2A-573A273DF9D6}"/>
               </a:ext>
             </a:extLst>
           </p:cNvPr>
@@ -1979,7 +1979,7 @@
           <p:cNvPr id="2" name="Left column">
             <a:extLst xmlns:a="http://schemas.openxmlformats.org/drawingml/2006/main">
               <a:ext uri="{FF2B5EF4-FFF2-40B4-BE49-F238E27FC236}">
-                <a16:creationId xmlns:a16="http://schemas.microsoft.com/office/drawing/2014/main" id="{993164F2-242F-4D8B-9D84-C47B5CC5A0CB}"/>
+                <a16:creationId xmlns:a16="http://schemas.microsoft.com/office/drawing/2014/main" id="{2E70115B-0493-4B7E-991D-008FF69C55A7}"/>
               </a:ext>
             </a:extLst>
           </p:cNvPr>
@@ -2136,7 +2136,7 @@
           <p:cNvPr id="3" name="Right column">
             <a:extLst xmlns:a="http://schemas.openxmlformats.org/drawingml/2006/main">
               <a:ext uri="{FF2B5EF4-FFF2-40B4-BE49-F238E27FC236}">
-                <a16:creationId xmlns:a16="http://schemas.microsoft.com/office/drawing/2014/main" id="{E6A3B6EA-BA30-4ACC-97B0-C3F43148DEDE}"/>
+                <a16:creationId xmlns:a16="http://schemas.microsoft.com/office/drawing/2014/main" id="{9111B0F4-983A-49DB-8666-A90C004F2ED1}"/>
               </a:ext>
             </a:extLst>
           </p:cNvPr>
@@ -2310,7 +2310,7 @@
           <p:cNvPr id="3" name="Title">
             <a:extLst xmlns:a="http://schemas.openxmlformats.org/drawingml/2006/main">
               <a:ext uri="{FF2B5EF4-FFF2-40B4-BE49-F238E27FC236}">
-                <a16:creationId xmlns:a16="http://schemas.microsoft.com/office/drawing/2014/main" id="{3B7C8AC1-57BB-4C60-B210-C37686D4C404}"/>
+                <a16:creationId xmlns:a16="http://schemas.microsoft.com/office/drawing/2014/main" id="{721CFC35-8B52-4DAC-83B9-1D0340E79BD5}"/>
               </a:ext>
             </a:extLst>
           </p:cNvPr>
@@ -2467,7 +2467,7 @@
           <p:cNvPr id="2" name="Left column">
             <a:extLst xmlns:a="http://schemas.openxmlformats.org/drawingml/2006/main">
               <a:ext uri="{FF2B5EF4-FFF2-40B4-BE49-F238E27FC236}">
-                <a16:creationId xmlns:a16="http://schemas.microsoft.com/office/drawing/2014/main" id="{5C915635-6291-42BE-A0BF-539A92DC57F3}"/>
+                <a16:creationId xmlns:a16="http://schemas.microsoft.com/office/drawing/2014/main" id="{05B718D6-A31C-4B7A-8AE9-3965B7712DE5}"/>
               </a:ext>
             </a:extLst>
           </p:cNvPr>
@@ -2662,12 +2662,12 @@
   </p:cSld>
   <p:clrMap bg1="lt1" tx1="dk1" bg2="lt2" tx2="dk2" accent1="accent1" accent2="accent2" accent3="accent3" accent4="accent4" accent5="accent5" accent6="accent6" hlink="hlink" folHlink="folHlink"/>
   <p:sldLayoutIdLst>
-    <p:sldLayoutId xmlns:r="http://schemas.openxmlformats.org/officeDocument/2006/relationships" id="2147483649" r:id="R62d0f7ef0bee4ea9"/>
-    <p:sldLayoutId xmlns:r="http://schemas.openxmlformats.org/officeDocument/2006/relationships" id="2147483650" r:id="R498334d1a2af40c9"/>
-    <p:sldLayoutId xmlns:r="http://schemas.openxmlformats.org/officeDocument/2006/relationships" id="2147483651" r:id="Rafe44591c0e94e7a"/>
-    <p:sldLayoutId xmlns:r="http://schemas.openxmlformats.org/officeDocument/2006/relationships" id="2147483652" r:id="R1eba727621ac40fd"/>
-    <p:sldLayoutId xmlns:r="http://schemas.openxmlformats.org/officeDocument/2006/relationships" id="2147483653" r:id="R6b199df99d2045d1"/>
-    <p:sldLayoutId xmlns:r="http://schemas.openxmlformats.org/officeDocument/2006/relationships" id="2147483654" r:id="Raf805a8f8bdd4814"/>
+    <p:sldLayoutId xmlns:r="http://schemas.openxmlformats.org/officeDocument/2006/relationships" id="2147483649" r:id="R9aeeecc693434ff3"/>
+    <p:sldLayoutId xmlns:r="http://schemas.openxmlformats.org/officeDocument/2006/relationships" id="2147483650" r:id="R73eaed738f444286"/>
+    <p:sldLayoutId xmlns:r="http://schemas.openxmlformats.org/officeDocument/2006/relationships" id="2147483651" r:id="R7b430e869b654606"/>
+    <p:sldLayoutId xmlns:r="http://schemas.openxmlformats.org/officeDocument/2006/relationships" id="2147483652" r:id="R88209a8616ff4dd1"/>
+    <p:sldLayoutId xmlns:r="http://schemas.openxmlformats.org/officeDocument/2006/relationships" id="2147483653" r:id="Red103489e9dc4559"/>
+    <p:sldLayoutId xmlns:r="http://schemas.openxmlformats.org/officeDocument/2006/relationships" id="2147483654" r:id="R7a017018e7104d24"/>
   </p:sldLayoutIdLst>
   <p:txStyles>
     <p:titleStyle>
@@ -3480,7 +3480,7 @@
           <p:cNvPr id="12" name="">
             <a:extLst xmlns:a="http://schemas.openxmlformats.org/drawingml/2006/main">
               <a:ext uri="{FF2B5EF4-FFF2-40B4-BE49-F238E27FC236}">
-                <a16:creationId xmlns:a16="http://schemas.microsoft.com/office/drawing/2014/main" id="{0A6A26D2-DD4E-4871-B86A-33D6E5A9ECA0}"/>
+                <a16:creationId xmlns:a16="http://schemas.microsoft.com/office/drawing/2014/main" id="{B6EEDA6D-B83C-48E6-BFA6-20FD09DB0454}"/>
               </a:ext>
             </a:extLst>
           </p:cNvPr>
@@ -3546,7 +3546,7 @@
           <p:cNvPr id="2" name="">
             <a:extLst xmlns:a="http://schemas.openxmlformats.org/drawingml/2006/main">
               <a:ext uri="{FF2B5EF4-FFF2-40B4-BE49-F238E27FC236}">
-                <a16:creationId xmlns:a16="http://schemas.microsoft.com/office/drawing/2014/main" id="{D66E2E23-E2AF-4044-9060-8178A71CF789}"/>
+                <a16:creationId xmlns:a16="http://schemas.microsoft.com/office/drawing/2014/main" id="{4EA9C8E7-EC0E-4D83-A1E9-A64E7933D0F2}"/>
               </a:ext>
             </a:extLst>
           </p:cNvPr>
@@ -3612,7 +3612,7 @@
           <p:cNvPr id="3" name="">
             <a:extLst xmlns:a="http://schemas.openxmlformats.org/drawingml/2006/main">
               <a:ext uri="{FF2B5EF4-FFF2-40B4-BE49-F238E27FC236}">
-                <a16:creationId xmlns:a16="http://schemas.microsoft.com/office/drawing/2014/main" id="{20507DB1-AA17-401C-8D0F-21FC31868D93}"/>
+                <a16:creationId xmlns:a16="http://schemas.microsoft.com/office/drawing/2014/main" id="{985FE845-10A7-4A4B-AF20-0E1813BE8EF8}"/>
               </a:ext>
             </a:extLst>
           </p:cNvPr>
@@ -3642,7 +3642,7 @@
           <p:cNvPr id="4" name="">
             <a:extLst xmlns:a="http://schemas.openxmlformats.org/drawingml/2006/main">
               <a:ext uri="{FF2B5EF4-FFF2-40B4-BE49-F238E27FC236}">
-                <a16:creationId xmlns:a16="http://schemas.microsoft.com/office/drawing/2014/main" id="{4FAB199E-FA5A-41CF-8E76-A1140BA77E3A}"/>
+                <a16:creationId xmlns:a16="http://schemas.microsoft.com/office/drawing/2014/main" id="{BD67095A-87B3-4144-88B1-F3F1EC16A98B}"/>
               </a:ext>
             </a:extLst>
           </p:cNvPr>
@@ -3708,7 +3708,7 @@
           <p:cNvPr id="5" name="">
             <a:extLst xmlns:a="http://schemas.openxmlformats.org/drawingml/2006/main">
               <a:ext uri="{FF2B5EF4-FFF2-40B4-BE49-F238E27FC236}">
-                <a16:creationId xmlns:a16="http://schemas.microsoft.com/office/drawing/2014/main" id="{334C0271-DC9E-4EF4-BF83-1254818C45DA}"/>
+                <a16:creationId xmlns:a16="http://schemas.microsoft.com/office/drawing/2014/main" id="{7BBBBE68-31D3-4E42-B260-43D96D16C625}"/>
               </a:ext>
             </a:extLst>
           </p:cNvPr>
@@ -3774,7 +3774,7 @@
           <p:cNvPr id="6" name="">
             <a:extLst xmlns:a="http://schemas.openxmlformats.org/drawingml/2006/main">
               <a:ext uri="{FF2B5EF4-FFF2-40B4-BE49-F238E27FC236}">
-                <a16:creationId xmlns:a16="http://schemas.microsoft.com/office/drawing/2014/main" id="{C667A47F-955B-4AA1-AABD-7F5A97895671}"/>
+                <a16:creationId xmlns:a16="http://schemas.microsoft.com/office/drawing/2014/main" id="{8853AD88-32E2-4D54-B0F1-1149679AF364}"/>
               </a:ext>
             </a:extLst>
           </p:cNvPr>
@@ -3840,7 +3840,7 @@
           <p:cNvPr id="7" name="">
             <a:extLst xmlns:a="http://schemas.openxmlformats.org/drawingml/2006/main">
               <a:ext uri="{FF2B5EF4-FFF2-40B4-BE49-F238E27FC236}">
-                <a16:creationId xmlns:a16="http://schemas.microsoft.com/office/drawing/2014/main" id="{B99D729B-810F-47AD-AEB8-0A0888144B3A}"/>
+                <a16:creationId xmlns:a16="http://schemas.microsoft.com/office/drawing/2014/main" id="{448294B1-982A-4EF9-A1BC-8C412B7E65FC}"/>
               </a:ext>
             </a:extLst>
           </p:cNvPr>
@@ -3929,7 +3929,7 @@
           <p:cNvPr id="8" name="">
             <a:extLst xmlns:a="http://schemas.openxmlformats.org/drawingml/2006/main">
               <a:ext uri="{FF2B5EF4-FFF2-40B4-BE49-F238E27FC236}">
-                <a16:creationId xmlns:a16="http://schemas.microsoft.com/office/drawing/2014/main" id="{BAC982E9-68BA-4765-9E41-4D479C992989}"/>
+                <a16:creationId xmlns:a16="http://schemas.microsoft.com/office/drawing/2014/main" id="{073BC725-9329-41C5-BFE6-9046D8D568E4}"/>
               </a:ext>
             </a:extLst>
           </p:cNvPr>
@@ -3985,7 +3985,7 @@
                 <a:ea typeface="Arial"/>
                 <a:cs typeface="Arial"/>
               </a:rPr>
-              <a:t>A reusable SDK on Arkiv.</a:t>
+              <a:t>Shared evidence across tools.</a:t>
             </a:r>
           </a:p>
           <a:p xmlns:a="http://schemas.openxmlformats.org/drawingml/2006/main">
@@ -4008,7 +4008,7 @@
                 <a:ea typeface="Arial"/>
                 <a:cs typeface="Arial"/>
               </a:rPr>
-              <a:t>AI Passport is the reference app.</a:t>
+              <a:t>AI Passport shows it in use.</a:t>
             </a:r>
           </a:p>
         </p:txBody>
@@ -4018,7 +4018,7 @@
           <p:cNvPr id="9" name="">
             <a:extLst xmlns:a="http://schemas.openxmlformats.org/drawingml/2006/main">
               <a:ext uri="{FF2B5EF4-FFF2-40B4-BE49-F238E27FC236}">
-                <a16:creationId xmlns:a16="http://schemas.microsoft.com/office/drawing/2014/main" id="{3880B861-00BB-495B-A8AD-7130EF4ACA13}"/>
+                <a16:creationId xmlns:a16="http://schemas.microsoft.com/office/drawing/2014/main" id="{F13A85C4-2437-4F97-AB15-3FC95683A34E}"/>
               </a:ext>
             </a:extLst>
           </p:cNvPr>
@@ -4107,7 +4107,7 @@
           <p:cNvPr id="10" name="">
             <a:extLst xmlns:a="http://schemas.openxmlformats.org/drawingml/2006/main">
               <a:ext uri="{FF2B5EF4-FFF2-40B4-BE49-F238E27FC236}">
-                <a16:creationId xmlns:a16="http://schemas.microsoft.com/office/drawing/2014/main" id="{5EEB7328-9747-41FD-8A6E-1CC7A0DDBC3C}"/>
+                <a16:creationId xmlns:a16="http://schemas.microsoft.com/office/drawing/2014/main" id="{6ADC382F-FB1A-46CC-BA8A-A5DFF71704EE}"/>
               </a:ext>
             </a:extLst>
           </p:cNvPr>
@@ -4117,7 +4117,7 @@
           <p:nvPr/>
         </p:nvPicPr>
         <p:blipFill>
-          <a:blip xmlns:r="http://schemas.openxmlformats.org/officeDocument/2006/relationships" xmlns:a="http://schemas.openxmlformats.org/drawingml/2006/main" r:embed="Ra8a4e1dde4b74876"/>
+          <a:blip xmlns:r="http://schemas.openxmlformats.org/officeDocument/2006/relationships" xmlns:a="http://schemas.openxmlformats.org/drawingml/2006/main" r:embed="R5515b7a1bc7d495c"/>
           <a:stretch xmlns:a="http://schemas.openxmlformats.org/drawingml/2006/main"/>
         </p:blipFill>
         <p:spPr>
@@ -4135,7 +4135,7 @@
           <p:cNvPr id="11" name="">
             <a:extLst xmlns:a="http://schemas.openxmlformats.org/drawingml/2006/main">
               <a:ext uri="{FF2B5EF4-FFF2-40B4-BE49-F238E27FC236}">
-                <a16:creationId xmlns:a16="http://schemas.microsoft.com/office/drawing/2014/main" id="{8FD6FF77-97BB-4B33-94EB-5BC8F3C80295}"/>
+                <a16:creationId xmlns:a16="http://schemas.microsoft.com/office/drawing/2014/main" id="{4F4E1B62-1040-4708-AFFD-7B232B4A4AC1}"/>
               </a:ext>
             </a:extLst>
           </p:cNvPr>
@@ -4199,7 +4199,7 @@
     </p:spTree>
     <p:extLst>
       <p:ext uri="{BB962C8B-B14F-4D97-AF65-F5344CB8AC3E}">
-        <p14:creationId xmlns:p14="http://schemas.microsoft.com/office/powerpoint/2010/main" val="642558421"/>
+        <p14:creationId xmlns:p14="http://schemas.microsoft.com/office/powerpoint/2010/main" val="141325320"/>
       </p:ext>
     </p:extLst>
   </p:cSld>
@@ -4230,7 +4230,7 @@
           <p:cNvPr id="17" name="">
             <a:extLst xmlns:a="http://schemas.openxmlformats.org/drawingml/2006/main">
               <a:ext uri="{FF2B5EF4-FFF2-40B4-BE49-F238E27FC236}">
-                <a16:creationId xmlns:a16="http://schemas.microsoft.com/office/drawing/2014/main" id="{84DD1D04-6610-4E21-ABF1-CCDF7FF698B4}"/>
+                <a16:creationId xmlns:a16="http://schemas.microsoft.com/office/drawing/2014/main" id="{24E0CB1F-6D56-4078-BC0D-72446449A52D}"/>
               </a:ext>
             </a:extLst>
           </p:cNvPr>
@@ -4296,7 +4296,7 @@
           <p:cNvPr id="2" name="">
             <a:extLst xmlns:a="http://schemas.openxmlformats.org/drawingml/2006/main">
               <a:ext uri="{FF2B5EF4-FFF2-40B4-BE49-F238E27FC236}">
-                <a16:creationId xmlns:a16="http://schemas.microsoft.com/office/drawing/2014/main" id="{E4A4E097-F73D-44EA-B9E5-6818AD16F7C0}"/>
+                <a16:creationId xmlns:a16="http://schemas.microsoft.com/office/drawing/2014/main" id="{19889E29-D445-4DB5-8A66-8DECC6A1CB99}"/>
               </a:ext>
             </a:extLst>
           </p:cNvPr>
@@ -4362,7 +4362,7 @@
           <p:cNvPr id="3" name="">
             <a:extLst xmlns:a="http://schemas.openxmlformats.org/drawingml/2006/main">
               <a:ext uri="{FF2B5EF4-FFF2-40B4-BE49-F238E27FC236}">
-                <a16:creationId xmlns:a16="http://schemas.microsoft.com/office/drawing/2014/main" id="{967CC1EA-3DC8-4E1A-BB6E-D4C9E59A4B9B}"/>
+                <a16:creationId xmlns:a16="http://schemas.microsoft.com/office/drawing/2014/main" id="{85CAB828-341A-4989-8257-23D43D6667A1}"/>
               </a:ext>
             </a:extLst>
           </p:cNvPr>
@@ -4392,7 +4392,7 @@
           <p:cNvPr id="4" name="">
             <a:extLst xmlns:a="http://schemas.openxmlformats.org/drawingml/2006/main">
               <a:ext uri="{FF2B5EF4-FFF2-40B4-BE49-F238E27FC236}">
-                <a16:creationId xmlns:a16="http://schemas.microsoft.com/office/drawing/2014/main" id="{562D1634-750E-49EB-8C7D-3070832A1F1B}"/>
+                <a16:creationId xmlns:a16="http://schemas.microsoft.com/office/drawing/2014/main" id="{7328B0EF-D4BF-4FCD-8E71-FA819EF92C2A}"/>
               </a:ext>
             </a:extLst>
           </p:cNvPr>
@@ -4458,7 +4458,7 @@
           <p:cNvPr id="5" name="">
             <a:extLst xmlns:a="http://schemas.openxmlformats.org/drawingml/2006/main">
               <a:ext uri="{FF2B5EF4-FFF2-40B4-BE49-F238E27FC236}">
-                <a16:creationId xmlns:a16="http://schemas.microsoft.com/office/drawing/2014/main" id="{91FC4439-0AF5-4A42-B020-C0ED9A97D31F}"/>
+                <a16:creationId xmlns:a16="http://schemas.microsoft.com/office/drawing/2014/main" id="{A49606EF-3E85-406D-8393-B4E063C63913}"/>
               </a:ext>
             </a:extLst>
           </p:cNvPr>
@@ -4524,7 +4524,7 @@
           <p:cNvPr id="6" name="">
             <a:extLst xmlns:a="http://schemas.openxmlformats.org/drawingml/2006/main">
               <a:ext uri="{FF2B5EF4-FFF2-40B4-BE49-F238E27FC236}">
-                <a16:creationId xmlns:a16="http://schemas.microsoft.com/office/drawing/2014/main" id="{856343D1-86DB-4E3A-B274-CF96226A5911}"/>
+                <a16:creationId xmlns:a16="http://schemas.microsoft.com/office/drawing/2014/main" id="{70DF45E9-B212-4372-B08C-10D7C8D02D43}"/>
               </a:ext>
             </a:extLst>
           </p:cNvPr>
@@ -4613,7 +4613,7 @@
           <p:cNvPr id="7" name="">
             <a:extLst xmlns:a="http://schemas.openxmlformats.org/drawingml/2006/main">
               <a:ext uri="{FF2B5EF4-FFF2-40B4-BE49-F238E27FC236}">
-                <a16:creationId xmlns:a16="http://schemas.microsoft.com/office/drawing/2014/main" id="{FA8E0C72-6640-49D8-82B5-554F390B04BC}"/>
+                <a16:creationId xmlns:a16="http://schemas.microsoft.com/office/drawing/2014/main" id="{C65F7D1F-7F26-4EFB-8805-1014E50505C0}"/>
               </a:ext>
             </a:extLst>
           </p:cNvPr>
@@ -4679,7 +4679,7 @@
           <p:cNvPr id="8" name="">
             <a:extLst xmlns:a="http://schemas.openxmlformats.org/drawingml/2006/main">
               <a:ext uri="{FF2B5EF4-FFF2-40B4-BE49-F238E27FC236}">
-                <a16:creationId xmlns:a16="http://schemas.microsoft.com/office/drawing/2014/main" id="{4CBFC348-FC77-46D8-A45B-B95A31F7E345}"/>
+                <a16:creationId xmlns:a16="http://schemas.microsoft.com/office/drawing/2014/main" id="{31664819-EF34-45C2-AEA7-FD857BB46A53}"/>
               </a:ext>
             </a:extLst>
           </p:cNvPr>
@@ -4745,7 +4745,7 @@
           <p:cNvPr id="9" name="">
             <a:extLst xmlns:a="http://schemas.openxmlformats.org/drawingml/2006/main">
               <a:ext uri="{FF2B5EF4-FFF2-40B4-BE49-F238E27FC236}">
-                <a16:creationId xmlns:a16="http://schemas.microsoft.com/office/drawing/2014/main" id="{1D2D980B-4010-45AD-9BE2-798C409F5E58}"/>
+                <a16:creationId xmlns:a16="http://schemas.microsoft.com/office/drawing/2014/main" id="{924C2997-59D3-4477-B12B-33754E98D565}"/>
               </a:ext>
             </a:extLst>
           </p:cNvPr>
@@ -4811,7 +4811,7 @@
           <p:cNvPr id="10" name="">
             <a:extLst xmlns:a="http://schemas.openxmlformats.org/drawingml/2006/main">
               <a:ext uri="{FF2B5EF4-FFF2-40B4-BE49-F238E27FC236}">
-                <a16:creationId xmlns:a16="http://schemas.microsoft.com/office/drawing/2014/main" id="{4C9F3D91-8E5E-4729-919A-FB4F60062C28}"/>
+                <a16:creationId xmlns:a16="http://schemas.microsoft.com/office/drawing/2014/main" id="{E831E3EA-64BC-45A3-8F25-DD5FC2A29C6D}"/>
               </a:ext>
             </a:extLst>
           </p:cNvPr>
@@ -4841,7 +4841,7 @@
           <p:cNvPr id="11" name="">
             <a:extLst xmlns:a="http://schemas.openxmlformats.org/drawingml/2006/main">
               <a:ext uri="{FF2B5EF4-FFF2-40B4-BE49-F238E27FC236}">
-                <a16:creationId xmlns:a16="http://schemas.microsoft.com/office/drawing/2014/main" id="{F213EC8B-01C9-45B7-AAF4-EDE75AA81B51}"/>
+                <a16:creationId xmlns:a16="http://schemas.microsoft.com/office/drawing/2014/main" id="{DB0A295B-0E0E-4C69-8A84-69870470E8C2}"/>
               </a:ext>
             </a:extLst>
           </p:cNvPr>
@@ -4907,7 +4907,7 @@
           <p:cNvPr id="12" name="">
             <a:extLst xmlns:a="http://schemas.openxmlformats.org/drawingml/2006/main">
               <a:ext uri="{FF2B5EF4-FFF2-40B4-BE49-F238E27FC236}">
-                <a16:creationId xmlns:a16="http://schemas.microsoft.com/office/drawing/2014/main" id="{4BDEE575-2174-4CC9-9F81-998E23766262}"/>
+                <a16:creationId xmlns:a16="http://schemas.microsoft.com/office/drawing/2014/main" id="{CB54FD37-22B9-4C67-BEE4-E1E02FCD666B}"/>
               </a:ext>
             </a:extLst>
           </p:cNvPr>
@@ -4996,7 +4996,7 @@
           <p:cNvPr id="13" name="">
             <a:extLst xmlns:a="http://schemas.openxmlformats.org/drawingml/2006/main">
               <a:ext uri="{FF2B5EF4-FFF2-40B4-BE49-F238E27FC236}">
-                <a16:creationId xmlns:a16="http://schemas.microsoft.com/office/drawing/2014/main" id="{EF5E4158-AF33-44FF-B679-6D4CD7B35E9A}"/>
+                <a16:creationId xmlns:a16="http://schemas.microsoft.com/office/drawing/2014/main" id="{D3C1AE2C-7326-4B16-8ADD-BAC3283BC80B}"/>
               </a:ext>
             </a:extLst>
           </p:cNvPr>
@@ -5062,7 +5062,7 @@
           <p:cNvPr id="14" name="">
             <a:extLst xmlns:a="http://schemas.openxmlformats.org/drawingml/2006/main">
               <a:ext uri="{FF2B5EF4-FFF2-40B4-BE49-F238E27FC236}">
-                <a16:creationId xmlns:a16="http://schemas.microsoft.com/office/drawing/2014/main" id="{33EF0DBD-1E31-4A02-BAC7-77CEA7F52180}"/>
+                <a16:creationId xmlns:a16="http://schemas.microsoft.com/office/drawing/2014/main" id="{A5CBBC54-9E90-459B-A597-564D22C0AFF6}"/>
               </a:ext>
             </a:extLst>
           </p:cNvPr>
@@ -5151,7 +5151,7 @@
           <p:cNvPr id="15" name="">
             <a:extLst xmlns:a="http://schemas.openxmlformats.org/drawingml/2006/main">
               <a:ext uri="{FF2B5EF4-FFF2-40B4-BE49-F238E27FC236}">
-                <a16:creationId xmlns:a16="http://schemas.microsoft.com/office/drawing/2014/main" id="{B7D68905-3CB2-42DE-B089-425E59621B54}"/>
+                <a16:creationId xmlns:a16="http://schemas.microsoft.com/office/drawing/2014/main" id="{2624CF92-0E08-4AE8-BAAF-EFAE01CF7689}"/>
               </a:ext>
             </a:extLst>
           </p:cNvPr>
@@ -5217,7 +5217,7 @@
           <p:cNvPr id="16" name="">
             <a:extLst xmlns:a="http://schemas.openxmlformats.org/drawingml/2006/main">
               <a:ext uri="{FF2B5EF4-FFF2-40B4-BE49-F238E27FC236}">
-                <a16:creationId xmlns:a16="http://schemas.microsoft.com/office/drawing/2014/main" id="{E7B20D8F-7F66-424F-A4E9-4F4FC271D49B}"/>
+                <a16:creationId xmlns:a16="http://schemas.microsoft.com/office/drawing/2014/main" id="{EDBD5E08-D29F-42CC-9005-11F9039C46EE}"/>
               </a:ext>
             </a:extLst>
           </p:cNvPr>
@@ -5304,7 +5304,7 @@
     </p:spTree>
     <p:extLst>
       <p:ext uri="{BB962C8B-B14F-4D97-AF65-F5344CB8AC3E}">
-        <p14:creationId xmlns:p14="http://schemas.microsoft.com/office/powerpoint/2010/main" val="453027141"/>
+        <p14:creationId xmlns:p14="http://schemas.microsoft.com/office/powerpoint/2010/main" val="419660759"/>
       </p:ext>
     </p:extLst>
   </p:cSld>
@@ -5335,7 +5335,7 @@
           <p:cNvPr id="23" name="">
             <a:extLst xmlns:a="http://schemas.openxmlformats.org/drawingml/2006/main">
               <a:ext uri="{FF2B5EF4-FFF2-40B4-BE49-F238E27FC236}">
-                <a16:creationId xmlns:a16="http://schemas.microsoft.com/office/drawing/2014/main" id="{C5800D60-DEFE-4029-9FCA-3FC48DE19A1E}"/>
+                <a16:creationId xmlns:a16="http://schemas.microsoft.com/office/drawing/2014/main" id="{15E16BCC-DA0F-4489-BAAD-12605750DCF5}"/>
               </a:ext>
             </a:extLst>
           </p:cNvPr>
@@ -5401,7 +5401,7 @@
           <p:cNvPr id="2" name="">
             <a:extLst xmlns:a="http://schemas.openxmlformats.org/drawingml/2006/main">
               <a:ext uri="{FF2B5EF4-FFF2-40B4-BE49-F238E27FC236}">
-                <a16:creationId xmlns:a16="http://schemas.microsoft.com/office/drawing/2014/main" id="{BBE8B874-D22C-4E1E-A5CD-B0293B72482C}"/>
+                <a16:creationId xmlns:a16="http://schemas.microsoft.com/office/drawing/2014/main" id="{8EA5289E-8B26-48E9-8582-2D233618870B}"/>
               </a:ext>
             </a:extLst>
           </p:cNvPr>
@@ -5467,7 +5467,7 @@
           <p:cNvPr id="3" name="">
             <a:extLst xmlns:a="http://schemas.openxmlformats.org/drawingml/2006/main">
               <a:ext uri="{FF2B5EF4-FFF2-40B4-BE49-F238E27FC236}">
-                <a16:creationId xmlns:a16="http://schemas.microsoft.com/office/drawing/2014/main" id="{8A3B376E-4456-4C8C-9BDC-103A87711EAC}"/>
+                <a16:creationId xmlns:a16="http://schemas.microsoft.com/office/drawing/2014/main" id="{9D7DCC7F-4CE4-4CCD-B294-E454083C7120}"/>
               </a:ext>
             </a:extLst>
           </p:cNvPr>
@@ -5497,7 +5497,7 @@
           <p:cNvPr id="4" name="">
             <a:extLst xmlns:a="http://schemas.openxmlformats.org/drawingml/2006/main">
               <a:ext uri="{FF2B5EF4-FFF2-40B4-BE49-F238E27FC236}">
-                <a16:creationId xmlns:a16="http://schemas.microsoft.com/office/drawing/2014/main" id="{63BA8172-3D54-4979-B63F-EECB307A43B0}"/>
+                <a16:creationId xmlns:a16="http://schemas.microsoft.com/office/drawing/2014/main" id="{89D48D0C-476A-4C80-AF97-621EC8519855}"/>
               </a:ext>
             </a:extLst>
           </p:cNvPr>
@@ -5563,7 +5563,7 @@
           <p:cNvPr id="5" name="">
             <a:extLst xmlns:a="http://schemas.openxmlformats.org/drawingml/2006/main">
               <a:ext uri="{FF2B5EF4-FFF2-40B4-BE49-F238E27FC236}">
-                <a16:creationId xmlns:a16="http://schemas.microsoft.com/office/drawing/2014/main" id="{EAD0571B-C49C-430C-B1BB-770F02D4A3EE}"/>
+                <a16:creationId xmlns:a16="http://schemas.microsoft.com/office/drawing/2014/main" id="{51F8D98E-3831-44F3-BE3C-D3EF5CC764E4}"/>
               </a:ext>
             </a:extLst>
           </p:cNvPr>
@@ -5629,7 +5629,7 @@
           <p:cNvPr id="6" name="">
             <a:extLst xmlns:a="http://schemas.openxmlformats.org/drawingml/2006/main">
               <a:ext uri="{FF2B5EF4-FFF2-40B4-BE49-F238E27FC236}">
-                <a16:creationId xmlns:a16="http://schemas.microsoft.com/office/drawing/2014/main" id="{BE15A6D2-249A-4FC9-86FB-A4308C3DF2C4}"/>
+                <a16:creationId xmlns:a16="http://schemas.microsoft.com/office/drawing/2014/main" id="{3C1AD89C-65A3-45D9-9B92-4A3D44FAF546}"/>
               </a:ext>
             </a:extLst>
           </p:cNvPr>
@@ -5695,7 +5695,7 @@
           <p:cNvPr id="7" name="">
             <a:extLst xmlns:a="http://schemas.openxmlformats.org/drawingml/2006/main">
               <a:ext uri="{FF2B5EF4-FFF2-40B4-BE49-F238E27FC236}">
-                <a16:creationId xmlns:a16="http://schemas.microsoft.com/office/drawing/2014/main" id="{5F7F21F1-3C12-45BB-9FF8-E92408289576}"/>
+                <a16:creationId xmlns:a16="http://schemas.microsoft.com/office/drawing/2014/main" id="{AA426266-19FD-43A7-AE64-DB2889FB1CA5}"/>
               </a:ext>
             </a:extLst>
           </p:cNvPr>
@@ -5761,7 +5761,7 @@
           <p:cNvPr id="8" name="">
             <a:extLst xmlns:a="http://schemas.openxmlformats.org/drawingml/2006/main">
               <a:ext uri="{FF2B5EF4-FFF2-40B4-BE49-F238E27FC236}">
-                <a16:creationId xmlns:a16="http://schemas.microsoft.com/office/drawing/2014/main" id="{1A321CE2-12D2-49AD-AD93-749EA505BE5F}"/>
+                <a16:creationId xmlns:a16="http://schemas.microsoft.com/office/drawing/2014/main" id="{B1CD1538-5DF6-46F0-9060-A01A114A067A}"/>
               </a:ext>
             </a:extLst>
           </p:cNvPr>
@@ -5827,7 +5827,7 @@
           <p:cNvPr id="9" name="">
             <a:extLst xmlns:a="http://schemas.openxmlformats.org/drawingml/2006/main">
               <a:ext uri="{FF2B5EF4-FFF2-40B4-BE49-F238E27FC236}">
-                <a16:creationId xmlns:a16="http://schemas.microsoft.com/office/drawing/2014/main" id="{A7D8ED95-F71D-4872-B3BE-3B3A0E0DA3C2}"/>
+                <a16:creationId xmlns:a16="http://schemas.microsoft.com/office/drawing/2014/main" id="{697BA450-91C5-4296-AD7C-1826565011DD}"/>
               </a:ext>
             </a:extLst>
           </p:cNvPr>
@@ -5893,7 +5893,7 @@
           <p:cNvPr id="10" name="">
             <a:extLst xmlns:a="http://schemas.openxmlformats.org/drawingml/2006/main">
               <a:ext uri="{FF2B5EF4-FFF2-40B4-BE49-F238E27FC236}">
-                <a16:creationId xmlns:a16="http://schemas.microsoft.com/office/drawing/2014/main" id="{65FEF1A3-8D0A-438A-BA9D-2DDA965EA1AD}"/>
+                <a16:creationId xmlns:a16="http://schemas.microsoft.com/office/drawing/2014/main" id="{58F4F727-40A7-4A18-B802-57C05153EA95}"/>
               </a:ext>
             </a:extLst>
           </p:cNvPr>
@@ -5925,7 +5925,7 @@
           <p:cNvPr id="11" name="">
             <a:extLst xmlns:a="http://schemas.openxmlformats.org/drawingml/2006/main">
               <a:ext uri="{FF2B5EF4-FFF2-40B4-BE49-F238E27FC236}">
-                <a16:creationId xmlns:a16="http://schemas.microsoft.com/office/drawing/2014/main" id="{8945636B-BC3B-416E-9003-0A76B2219E99}"/>
+                <a16:creationId xmlns:a16="http://schemas.microsoft.com/office/drawing/2014/main" id="{B4D9E880-7AC0-4EF5-8517-0107B3A2F121}"/>
               </a:ext>
             </a:extLst>
           </p:cNvPr>
@@ -6037,7 +6037,7 @@
           <p:cNvPr id="12" name="">
             <a:extLst xmlns:a="http://schemas.openxmlformats.org/drawingml/2006/main">
               <a:ext uri="{FF2B5EF4-FFF2-40B4-BE49-F238E27FC236}">
-                <a16:creationId xmlns:a16="http://schemas.microsoft.com/office/drawing/2014/main" id="{5A6CBFAF-806A-4244-8D87-CF74389A973A}"/>
+                <a16:creationId xmlns:a16="http://schemas.microsoft.com/office/drawing/2014/main" id="{B8C15879-B5F3-4AAF-A560-EBC84986FDDF}"/>
               </a:ext>
             </a:extLst>
           </p:cNvPr>
@@ -6126,7 +6126,7 @@
           <p:cNvPr id="13" name="">
             <a:extLst xmlns:a="http://schemas.openxmlformats.org/drawingml/2006/main">
               <a:ext uri="{FF2B5EF4-FFF2-40B4-BE49-F238E27FC236}">
-                <a16:creationId xmlns:a16="http://schemas.microsoft.com/office/drawing/2014/main" id="{E898C7D9-DFB7-430A-9339-A4EF2AF77027}"/>
+                <a16:creationId xmlns:a16="http://schemas.microsoft.com/office/drawing/2014/main" id="{791532EE-965F-4D17-822C-331CCC127026}"/>
               </a:ext>
             </a:extLst>
           </p:cNvPr>
@@ -6192,7 +6192,7 @@
           <p:cNvPr id="14" name="">
             <a:extLst xmlns:a="http://schemas.openxmlformats.org/drawingml/2006/main">
               <a:ext uri="{FF2B5EF4-FFF2-40B4-BE49-F238E27FC236}">
-                <a16:creationId xmlns:a16="http://schemas.microsoft.com/office/drawing/2014/main" id="{796DA97F-885C-46A3-A192-1768B0B6CEA1}"/>
+                <a16:creationId xmlns:a16="http://schemas.microsoft.com/office/drawing/2014/main" id="{05450901-451B-4918-BF22-F49145269E35}"/>
               </a:ext>
             </a:extLst>
           </p:cNvPr>
@@ -6222,7 +6222,7 @@
           <p:cNvPr id="15" name="">
             <a:extLst xmlns:a="http://schemas.openxmlformats.org/drawingml/2006/main">
               <a:ext uri="{FF2B5EF4-FFF2-40B4-BE49-F238E27FC236}">
-                <a16:creationId xmlns:a16="http://schemas.microsoft.com/office/drawing/2014/main" id="{50FFA309-B0C8-4F53-AAFB-C7B867ACCC43}"/>
+                <a16:creationId xmlns:a16="http://schemas.microsoft.com/office/drawing/2014/main" id="{78D1192A-203F-4329-8C3B-2908C396EF3A}"/>
               </a:ext>
             </a:extLst>
           </p:cNvPr>
@@ -6334,7 +6334,7 @@
           <p:cNvPr id="16" name="">
             <a:extLst xmlns:a="http://schemas.openxmlformats.org/drawingml/2006/main">
               <a:ext uri="{FF2B5EF4-FFF2-40B4-BE49-F238E27FC236}">
-                <a16:creationId xmlns:a16="http://schemas.microsoft.com/office/drawing/2014/main" id="{69D70D6E-DD37-4C9C-BC77-80F9760DDE6D}"/>
+                <a16:creationId xmlns:a16="http://schemas.microsoft.com/office/drawing/2014/main" id="{4C966359-FE1B-4148-AAC0-AFBE0E4E3670}"/>
               </a:ext>
             </a:extLst>
           </p:cNvPr>
@@ -6423,7 +6423,7 @@
           <p:cNvPr id="17" name="">
             <a:extLst xmlns:a="http://schemas.openxmlformats.org/drawingml/2006/main">
               <a:ext uri="{FF2B5EF4-FFF2-40B4-BE49-F238E27FC236}">
-                <a16:creationId xmlns:a16="http://schemas.microsoft.com/office/drawing/2014/main" id="{40B86D99-1545-4AE5-9DAC-B657260BD696}"/>
+                <a16:creationId xmlns:a16="http://schemas.microsoft.com/office/drawing/2014/main" id="{BFEFD6BE-B4FA-4653-8E5F-34AE6D8BF7D5}"/>
               </a:ext>
             </a:extLst>
           </p:cNvPr>
@@ -6489,7 +6489,7 @@
           <p:cNvPr id="18" name="">
             <a:extLst xmlns:a="http://schemas.openxmlformats.org/drawingml/2006/main">
               <a:ext uri="{FF2B5EF4-FFF2-40B4-BE49-F238E27FC236}">
-                <a16:creationId xmlns:a16="http://schemas.microsoft.com/office/drawing/2014/main" id="{C9734AD2-8ECE-4BDA-ACAA-820175D8BA22}"/>
+                <a16:creationId xmlns:a16="http://schemas.microsoft.com/office/drawing/2014/main" id="{F5FE77BF-E1A6-46BF-987F-1D1258206FBA}"/>
               </a:ext>
             </a:extLst>
           </p:cNvPr>
@@ -6521,7 +6521,7 @@
           <p:cNvPr id="19" name="">
             <a:extLst xmlns:a="http://schemas.openxmlformats.org/drawingml/2006/main">
               <a:ext uri="{FF2B5EF4-FFF2-40B4-BE49-F238E27FC236}">
-                <a16:creationId xmlns:a16="http://schemas.microsoft.com/office/drawing/2014/main" id="{A476CEEB-DE1E-4F2E-8B28-D7AF98382E8F}"/>
+                <a16:creationId xmlns:a16="http://schemas.microsoft.com/office/drawing/2014/main" id="{DBC95E62-C373-4A2D-84D3-42786748A359}"/>
               </a:ext>
             </a:extLst>
           </p:cNvPr>
@@ -6633,7 +6633,7 @@
           <p:cNvPr id="20" name="">
             <a:extLst xmlns:a="http://schemas.openxmlformats.org/drawingml/2006/main">
               <a:ext uri="{FF2B5EF4-FFF2-40B4-BE49-F238E27FC236}">
-                <a16:creationId xmlns:a16="http://schemas.microsoft.com/office/drawing/2014/main" id="{C1959DB8-128B-43CD-8AFA-40F2B605D9EA}"/>
+                <a16:creationId xmlns:a16="http://schemas.microsoft.com/office/drawing/2014/main" id="{AA9C69C6-2C09-475F-9030-B89CE8E5B192}"/>
               </a:ext>
             </a:extLst>
           </p:cNvPr>
@@ -6722,7 +6722,7 @@
           <p:cNvPr id="21" name="">
             <a:extLst xmlns:a="http://schemas.openxmlformats.org/drawingml/2006/main">
               <a:ext uri="{FF2B5EF4-FFF2-40B4-BE49-F238E27FC236}">
-                <a16:creationId xmlns:a16="http://schemas.microsoft.com/office/drawing/2014/main" id="{79A0A406-EEF0-48CA-A9DC-1093EA4DB124}"/>
+                <a16:creationId xmlns:a16="http://schemas.microsoft.com/office/drawing/2014/main" id="{8AA74BFA-E24F-4182-B464-FC6D8492DE6D}"/>
               </a:ext>
             </a:extLst>
           </p:cNvPr>
@@ -6752,7 +6752,7 @@
           <p:cNvPr id="22" name="">
             <a:extLst xmlns:a="http://schemas.openxmlformats.org/drawingml/2006/main">
               <a:ext uri="{FF2B5EF4-FFF2-40B4-BE49-F238E27FC236}">
-                <a16:creationId xmlns:a16="http://schemas.microsoft.com/office/drawing/2014/main" id="{F654DB11-1A8D-4A81-B024-3A3B390CB74B}"/>
+                <a16:creationId xmlns:a16="http://schemas.microsoft.com/office/drawing/2014/main" id="{B5C8A712-7701-421E-B262-57E82DDDDAF6}"/>
               </a:ext>
             </a:extLst>
           </p:cNvPr>
@@ -6816,7 +6816,7 @@
     </p:spTree>
     <p:extLst>
       <p:ext uri="{BB962C8B-B14F-4D97-AF65-F5344CB8AC3E}">
-        <p14:creationId xmlns:p14="http://schemas.microsoft.com/office/powerpoint/2010/main" val="846705950"/>
+        <p14:creationId xmlns:p14="http://schemas.microsoft.com/office/powerpoint/2010/main" val="1733264363"/>
       </p:ext>
     </p:extLst>
   </p:cSld>
@@ -6847,7 +6847,7 @@
           <p:cNvPr id="16" name="">
             <a:extLst xmlns:a="http://schemas.openxmlformats.org/drawingml/2006/main">
               <a:ext uri="{FF2B5EF4-FFF2-40B4-BE49-F238E27FC236}">
-                <a16:creationId xmlns:a16="http://schemas.microsoft.com/office/drawing/2014/main" id="{B8C35576-D86D-4077-AB96-110DE02D4E47}"/>
+                <a16:creationId xmlns:a16="http://schemas.microsoft.com/office/drawing/2014/main" id="{42234A26-5004-4742-9ECB-D9DA43788DAB}"/>
               </a:ext>
             </a:extLst>
           </p:cNvPr>
@@ -6913,7 +6913,7 @@
           <p:cNvPr id="2" name="">
             <a:extLst xmlns:a="http://schemas.openxmlformats.org/drawingml/2006/main">
               <a:ext uri="{FF2B5EF4-FFF2-40B4-BE49-F238E27FC236}">
-                <a16:creationId xmlns:a16="http://schemas.microsoft.com/office/drawing/2014/main" id="{E98A9D17-C72A-4F6C-881B-8D483E657F67}"/>
+                <a16:creationId xmlns:a16="http://schemas.microsoft.com/office/drawing/2014/main" id="{1CABB2E6-DB7B-49E4-8112-39F5DAF243BF}"/>
               </a:ext>
             </a:extLst>
           </p:cNvPr>
@@ -6979,7 +6979,7 @@
           <p:cNvPr id="3" name="">
             <a:extLst xmlns:a="http://schemas.openxmlformats.org/drawingml/2006/main">
               <a:ext uri="{FF2B5EF4-FFF2-40B4-BE49-F238E27FC236}">
-                <a16:creationId xmlns:a16="http://schemas.microsoft.com/office/drawing/2014/main" id="{E127F9B0-1C66-4CDA-B721-E124B863E732}"/>
+                <a16:creationId xmlns:a16="http://schemas.microsoft.com/office/drawing/2014/main" id="{4531F4A9-BEB8-4E12-9D38-4B3C9E68F523}"/>
               </a:ext>
             </a:extLst>
           </p:cNvPr>
@@ -7009,7 +7009,7 @@
           <p:cNvPr id="4" name="">
             <a:extLst xmlns:a="http://schemas.openxmlformats.org/drawingml/2006/main">
               <a:ext uri="{FF2B5EF4-FFF2-40B4-BE49-F238E27FC236}">
-                <a16:creationId xmlns:a16="http://schemas.microsoft.com/office/drawing/2014/main" id="{01E543E6-3BE1-426A-B93C-D8942E1C133D}"/>
+                <a16:creationId xmlns:a16="http://schemas.microsoft.com/office/drawing/2014/main" id="{CB10EE3C-0329-4974-AC81-9E543A4F1B77}"/>
               </a:ext>
             </a:extLst>
           </p:cNvPr>
@@ -7075,7 +7075,7 @@
           <p:cNvPr id="5" name="">
             <a:extLst xmlns:a="http://schemas.openxmlformats.org/drawingml/2006/main">
               <a:ext uri="{FF2B5EF4-FFF2-40B4-BE49-F238E27FC236}">
-                <a16:creationId xmlns:a16="http://schemas.microsoft.com/office/drawing/2014/main" id="{FF13C53A-A855-48FC-A16E-F8D015E9A5BC}"/>
+                <a16:creationId xmlns:a16="http://schemas.microsoft.com/office/drawing/2014/main" id="{568ECC2F-8388-40E2-9AF2-A3F5788D36AF}"/>
               </a:ext>
             </a:extLst>
           </p:cNvPr>
@@ -7141,7 +7141,7 @@
           <p:cNvPr id="6" name="">
             <a:extLst xmlns:a="http://schemas.openxmlformats.org/drawingml/2006/main">
               <a:ext uri="{FF2B5EF4-FFF2-40B4-BE49-F238E27FC236}">
-                <a16:creationId xmlns:a16="http://schemas.microsoft.com/office/drawing/2014/main" id="{4E14E52A-5F95-43BF-800D-040069D53CE3}"/>
+                <a16:creationId xmlns:a16="http://schemas.microsoft.com/office/drawing/2014/main" id="{6FF63971-F5B2-4CEF-A6B4-9F7FDE7DCFD1}"/>
               </a:ext>
             </a:extLst>
           </p:cNvPr>
@@ -7207,7 +7207,7 @@
           <p:cNvPr id="7" name="">
             <a:extLst xmlns:a="http://schemas.openxmlformats.org/drawingml/2006/main">
               <a:ext uri="{FF2B5EF4-FFF2-40B4-BE49-F238E27FC236}">
-                <a16:creationId xmlns:a16="http://schemas.microsoft.com/office/drawing/2014/main" id="{03855383-883B-434E-BCC0-A5E9C94C9D10}"/>
+                <a16:creationId xmlns:a16="http://schemas.microsoft.com/office/drawing/2014/main" id="{06292E86-722C-4387-A912-11C2647B6E34}"/>
               </a:ext>
             </a:extLst>
           </p:cNvPr>
@@ -7273,7 +7273,7 @@
           <p:cNvPr id="8" name="">
             <a:extLst xmlns:a="http://schemas.openxmlformats.org/drawingml/2006/main">
               <a:ext uri="{FF2B5EF4-FFF2-40B4-BE49-F238E27FC236}">
-                <a16:creationId xmlns:a16="http://schemas.microsoft.com/office/drawing/2014/main" id="{07873491-F47D-4926-9712-7C17671589C0}"/>
+                <a16:creationId xmlns:a16="http://schemas.microsoft.com/office/drawing/2014/main" id="{0E2EA8BB-F1EB-4017-8BFE-8A3803968910}"/>
               </a:ext>
             </a:extLst>
           </p:cNvPr>
@@ -7362,7 +7362,7 @@
           <p:cNvPr id="9" name="">
             <a:extLst xmlns:a="http://schemas.openxmlformats.org/drawingml/2006/main">
               <a:ext uri="{FF2B5EF4-FFF2-40B4-BE49-F238E27FC236}">
-                <a16:creationId xmlns:a16="http://schemas.microsoft.com/office/drawing/2014/main" id="{5164745A-AA12-48D6-B0C2-4869B61ABD47}"/>
+                <a16:creationId xmlns:a16="http://schemas.microsoft.com/office/drawing/2014/main" id="{66DF210D-DF23-4B3C-8837-426B6873542A}"/>
               </a:ext>
             </a:extLst>
           </p:cNvPr>
@@ -7451,7 +7451,7 @@
           <p:cNvPr id="10" name="">
             <a:extLst xmlns:a="http://schemas.openxmlformats.org/drawingml/2006/main">
               <a:ext uri="{FF2B5EF4-FFF2-40B4-BE49-F238E27FC236}">
-                <a16:creationId xmlns:a16="http://schemas.microsoft.com/office/drawing/2014/main" id="{3F24984F-FEA9-4A06-8DA7-109B247C0321}"/>
+                <a16:creationId xmlns:a16="http://schemas.microsoft.com/office/drawing/2014/main" id="{BF87E557-75CC-4808-B766-DBC41FC917E7}"/>
               </a:ext>
             </a:extLst>
           </p:cNvPr>
@@ -7540,7 +7540,7 @@
           <p:cNvPr id="11" name="">
             <a:extLst xmlns:a="http://schemas.openxmlformats.org/drawingml/2006/main">
               <a:ext uri="{FF2B5EF4-FFF2-40B4-BE49-F238E27FC236}">
-                <a16:creationId xmlns:a16="http://schemas.microsoft.com/office/drawing/2014/main" id="{D7F5551C-A45A-4A39-A373-5188A6EAF2D9}"/>
+                <a16:creationId xmlns:a16="http://schemas.microsoft.com/office/drawing/2014/main" id="{A03F887D-44ED-4B63-BFD8-6203B6717811}"/>
               </a:ext>
             </a:extLst>
           </p:cNvPr>
@@ -7570,7 +7570,7 @@
           <p:cNvPr id="12" name="">
             <a:extLst xmlns:a="http://schemas.openxmlformats.org/drawingml/2006/main">
               <a:ext uri="{FF2B5EF4-FFF2-40B4-BE49-F238E27FC236}">
-                <a16:creationId xmlns:a16="http://schemas.microsoft.com/office/drawing/2014/main" id="{731EF9CF-8E42-4163-BD23-79FBF5C49A87}"/>
+                <a16:creationId xmlns:a16="http://schemas.microsoft.com/office/drawing/2014/main" id="{AE3E83E0-7F84-4D00-9891-B79FB422FE2A}"/>
               </a:ext>
             </a:extLst>
           </p:cNvPr>
@@ -7580,7 +7580,7 @@
           <p:nvPr/>
         </p:nvPicPr>
         <p:blipFill>
-          <a:blip xmlns:r="http://schemas.openxmlformats.org/officeDocument/2006/relationships" xmlns:a="http://schemas.openxmlformats.org/drawingml/2006/main" r:embed="R6803e51d3ed14737"/>
+          <a:blip xmlns:r="http://schemas.openxmlformats.org/officeDocument/2006/relationships" xmlns:a="http://schemas.openxmlformats.org/drawingml/2006/main" r:embed="R9e3acee8b1a746e9"/>
           <a:stretch xmlns:a="http://schemas.openxmlformats.org/drawingml/2006/main"/>
         </p:blipFill>
         <p:spPr>
@@ -7598,7 +7598,7 @@
           <p:cNvPr id="13" name="">
             <a:extLst xmlns:a="http://schemas.openxmlformats.org/drawingml/2006/main">
               <a:ext uri="{FF2B5EF4-FFF2-40B4-BE49-F238E27FC236}">
-                <a16:creationId xmlns:a16="http://schemas.microsoft.com/office/drawing/2014/main" id="{17D20E9E-E6EA-47AC-9C69-00A6B5929B55}"/>
+                <a16:creationId xmlns:a16="http://schemas.microsoft.com/office/drawing/2014/main" id="{9BEBAD49-09DA-4952-83EB-72F6EDDDBE86}"/>
               </a:ext>
             </a:extLst>
           </p:cNvPr>
@@ -7608,7 +7608,7 @@
           <p:nvPr/>
         </p:nvPicPr>
         <p:blipFill>
-          <a:blip xmlns:r="http://schemas.openxmlformats.org/officeDocument/2006/relationships" xmlns:a="http://schemas.openxmlformats.org/drawingml/2006/main" r:embed="Re70a9c4dd7dc43db"/>
+          <a:blip xmlns:r="http://schemas.openxmlformats.org/officeDocument/2006/relationships" xmlns:a="http://schemas.openxmlformats.org/drawingml/2006/main" r:embed="R5de48b66c15143c6"/>
           <a:stretch xmlns:a="http://schemas.openxmlformats.org/drawingml/2006/main"/>
         </p:blipFill>
         <p:spPr>
@@ -7626,7 +7626,7 @@
           <p:cNvPr id="14" name="">
             <a:extLst xmlns:a="http://schemas.openxmlformats.org/drawingml/2006/main">
               <a:ext uri="{FF2B5EF4-FFF2-40B4-BE49-F238E27FC236}">
-                <a16:creationId xmlns:a16="http://schemas.microsoft.com/office/drawing/2014/main" id="{25C5DF18-5899-4AE0-AE2F-2969A3829E3A}"/>
+                <a16:creationId xmlns:a16="http://schemas.microsoft.com/office/drawing/2014/main" id="{A3A55910-90C7-4860-ACEC-3B22A7665DF3}"/>
               </a:ext>
             </a:extLst>
           </p:cNvPr>
@@ -7692,7 +7692,7 @@
           <p:cNvPr id="15" name="">
             <a:extLst xmlns:a="http://schemas.openxmlformats.org/drawingml/2006/main">
               <a:ext uri="{FF2B5EF4-FFF2-40B4-BE49-F238E27FC236}">
-                <a16:creationId xmlns:a16="http://schemas.microsoft.com/office/drawing/2014/main" id="{EDCAC2F4-76EC-4A29-B3C1-0FFB865643E4}"/>
+                <a16:creationId xmlns:a16="http://schemas.microsoft.com/office/drawing/2014/main" id="{502D3843-1C6A-4D38-8E72-E7DED2093F5A}"/>
               </a:ext>
             </a:extLst>
           </p:cNvPr>
@@ -7756,7 +7756,7 @@
     </p:spTree>
     <p:extLst>
       <p:ext uri="{BB962C8B-B14F-4D97-AF65-F5344CB8AC3E}">
-        <p14:creationId xmlns:p14="http://schemas.microsoft.com/office/powerpoint/2010/main" val="1072904236"/>
+        <p14:creationId xmlns:p14="http://schemas.microsoft.com/office/powerpoint/2010/main" val="46059513"/>
       </p:ext>
     </p:extLst>
   </p:cSld>
@@ -7787,7 +7787,7 @@
           <p:cNvPr id="13" name="">
             <a:extLst xmlns:a="http://schemas.openxmlformats.org/drawingml/2006/main">
               <a:ext uri="{FF2B5EF4-FFF2-40B4-BE49-F238E27FC236}">
-                <a16:creationId xmlns:a16="http://schemas.microsoft.com/office/drawing/2014/main" id="{F8B634C7-AF18-40CF-8BC5-798ACCFA871B}"/>
+                <a16:creationId xmlns:a16="http://schemas.microsoft.com/office/drawing/2014/main" id="{1E0BE11A-5A59-4953-AAB0-7B53992EE8B2}"/>
               </a:ext>
             </a:extLst>
           </p:cNvPr>
@@ -7853,7 +7853,7 @@
           <p:cNvPr id="2" name="">
             <a:extLst xmlns:a="http://schemas.openxmlformats.org/drawingml/2006/main">
               <a:ext uri="{FF2B5EF4-FFF2-40B4-BE49-F238E27FC236}">
-                <a16:creationId xmlns:a16="http://schemas.microsoft.com/office/drawing/2014/main" id="{804C5A97-DCF9-4E2C-A805-4A9F05B0C3DB}"/>
+                <a16:creationId xmlns:a16="http://schemas.microsoft.com/office/drawing/2014/main" id="{12F0E034-91BD-4523-A529-3F5165B254A5}"/>
               </a:ext>
             </a:extLst>
           </p:cNvPr>
@@ -7919,7 +7919,7 @@
           <p:cNvPr id="3" name="">
             <a:extLst xmlns:a="http://schemas.openxmlformats.org/drawingml/2006/main">
               <a:ext uri="{FF2B5EF4-FFF2-40B4-BE49-F238E27FC236}">
-                <a16:creationId xmlns:a16="http://schemas.microsoft.com/office/drawing/2014/main" id="{8A803BB9-3075-4766-9432-D5546834607D}"/>
+                <a16:creationId xmlns:a16="http://schemas.microsoft.com/office/drawing/2014/main" id="{CEF46F67-2383-4393-A6CD-B1C68EF20D22}"/>
               </a:ext>
             </a:extLst>
           </p:cNvPr>
@@ -7949,7 +7949,7 @@
           <p:cNvPr id="4" name="">
             <a:extLst xmlns:a="http://schemas.openxmlformats.org/drawingml/2006/main">
               <a:ext uri="{FF2B5EF4-FFF2-40B4-BE49-F238E27FC236}">
-                <a16:creationId xmlns:a16="http://schemas.microsoft.com/office/drawing/2014/main" id="{DBBDA135-DDF0-407F-A883-0BEBBC788549}"/>
+                <a16:creationId xmlns:a16="http://schemas.microsoft.com/office/drawing/2014/main" id="{237F2DAD-8502-419E-BBF0-F7E709198A7D}"/>
               </a:ext>
             </a:extLst>
           </p:cNvPr>
@@ -8015,7 +8015,7 @@
           <p:cNvPr id="5" name="">
             <a:extLst xmlns:a="http://schemas.openxmlformats.org/drawingml/2006/main">
               <a:ext uri="{FF2B5EF4-FFF2-40B4-BE49-F238E27FC236}">
-                <a16:creationId xmlns:a16="http://schemas.microsoft.com/office/drawing/2014/main" id="{7CD358B3-526A-442E-8ACA-EBC9DA409200}"/>
+                <a16:creationId xmlns:a16="http://schemas.microsoft.com/office/drawing/2014/main" id="{4319556D-7BD0-43A5-8DA2-E2FE18635E12}"/>
               </a:ext>
             </a:extLst>
           </p:cNvPr>
@@ -8081,7 +8081,7 @@
           <p:cNvPr id="6" name="">
             <a:extLst xmlns:a="http://schemas.openxmlformats.org/drawingml/2006/main">
               <a:ext uri="{FF2B5EF4-FFF2-40B4-BE49-F238E27FC236}">
-                <a16:creationId xmlns:a16="http://schemas.microsoft.com/office/drawing/2014/main" id="{85C0A6CE-99BA-401F-9D66-492C9460581D}"/>
+                <a16:creationId xmlns:a16="http://schemas.microsoft.com/office/drawing/2014/main" id="{0FFB451A-CC74-4370-AE4B-DC1CF91C65BE}"/>
               </a:ext>
             </a:extLst>
           </p:cNvPr>
@@ -8147,7 +8147,7 @@
           <p:cNvPr id="7" name="">
             <a:extLst xmlns:a="http://schemas.openxmlformats.org/drawingml/2006/main">
               <a:ext uri="{FF2B5EF4-FFF2-40B4-BE49-F238E27FC236}">
-                <a16:creationId xmlns:a16="http://schemas.microsoft.com/office/drawing/2014/main" id="{B24FBA1F-8832-4E24-AA9B-A178A81BDE83}"/>
+                <a16:creationId xmlns:a16="http://schemas.microsoft.com/office/drawing/2014/main" id="{B67C72C7-D3A1-4D86-893F-E5DD25AB1868}"/>
               </a:ext>
             </a:extLst>
           </p:cNvPr>
@@ -8213,7 +8213,7 @@
           <p:cNvPr id="8" name="">
             <a:extLst xmlns:a="http://schemas.openxmlformats.org/drawingml/2006/main">
               <a:ext uri="{FF2B5EF4-FFF2-40B4-BE49-F238E27FC236}">
-                <a16:creationId xmlns:a16="http://schemas.microsoft.com/office/drawing/2014/main" id="{153B9007-E1A2-4E5F-8244-5254A0E9DB2C}"/>
+                <a16:creationId xmlns:a16="http://schemas.microsoft.com/office/drawing/2014/main" id="{FF426809-6225-4804-98C8-9EE6ED4BDAFC}"/>
               </a:ext>
             </a:extLst>
           </p:cNvPr>
@@ -8325,7 +8325,7 @@
           <p:cNvPr id="9" name="">
             <a:extLst xmlns:a="http://schemas.openxmlformats.org/drawingml/2006/main">
               <a:ext uri="{FF2B5EF4-FFF2-40B4-BE49-F238E27FC236}">
-                <a16:creationId xmlns:a16="http://schemas.microsoft.com/office/drawing/2014/main" id="{DEEE2F4B-D072-4CEB-85CD-32E2E22E0F1C}"/>
+                <a16:creationId xmlns:a16="http://schemas.microsoft.com/office/drawing/2014/main" id="{14FF0CDF-EC47-43F7-8939-97461199C887}"/>
               </a:ext>
             </a:extLst>
           </p:cNvPr>
@@ -8391,7 +8391,7 @@
           <p:cNvPr id="10" name="">
             <a:extLst xmlns:a="http://schemas.openxmlformats.org/drawingml/2006/main">
               <a:ext uri="{FF2B5EF4-FFF2-40B4-BE49-F238E27FC236}">
-                <a16:creationId xmlns:a16="http://schemas.microsoft.com/office/drawing/2014/main" id="{29EC7BE4-5BAA-44C7-BEB2-0A46FDB270EA}"/>
+                <a16:creationId xmlns:a16="http://schemas.microsoft.com/office/drawing/2014/main" id="{572303C5-BF6E-4351-85D3-1A839AEF1141}"/>
               </a:ext>
             </a:extLst>
           </p:cNvPr>
@@ -8503,7 +8503,7 @@
           <p:cNvPr id="11" name="">
             <a:extLst xmlns:a="http://schemas.openxmlformats.org/drawingml/2006/main">
               <a:ext uri="{FF2B5EF4-FFF2-40B4-BE49-F238E27FC236}">
-                <a16:creationId xmlns:a16="http://schemas.microsoft.com/office/drawing/2014/main" id="{EE0A22D3-1EA6-43DF-A861-D8115D71AF80}"/>
+                <a16:creationId xmlns:a16="http://schemas.microsoft.com/office/drawing/2014/main" id="{0DEFFCC5-804B-42BC-BF9D-AA493C6BD4E7}"/>
               </a:ext>
             </a:extLst>
           </p:cNvPr>
@@ -8513,7 +8513,7 @@
           <p:nvPr/>
         </p:nvPicPr>
         <p:blipFill>
-          <a:blip xmlns:r="http://schemas.openxmlformats.org/officeDocument/2006/relationships" xmlns:a="http://schemas.openxmlformats.org/drawingml/2006/main" r:embed="Rf0c9e443919d4d66"/>
+          <a:blip xmlns:r="http://schemas.openxmlformats.org/officeDocument/2006/relationships" xmlns:a="http://schemas.openxmlformats.org/drawingml/2006/main" r:embed="R24eef52ac5f644b5"/>
           <a:srcRect xmlns:a="http://schemas.openxmlformats.org/drawingml/2006/main" l="48000" t="0" r="0" b="10500"/>
           <a:stretch xmlns:a="http://schemas.openxmlformats.org/drawingml/2006/main"/>
         </p:blipFill>
@@ -8532,7 +8532,7 @@
           <p:cNvPr id="12" name="">
             <a:extLst xmlns:a="http://schemas.openxmlformats.org/drawingml/2006/main">
               <a:ext uri="{FF2B5EF4-FFF2-40B4-BE49-F238E27FC236}">
-                <a16:creationId xmlns:a16="http://schemas.microsoft.com/office/drawing/2014/main" id="{6E56B914-C9D4-4058-B800-A205E50C788B}"/>
+                <a16:creationId xmlns:a16="http://schemas.microsoft.com/office/drawing/2014/main" id="{9B3125E8-91D0-42BB-B200-915A3EC37228}"/>
               </a:ext>
             </a:extLst>
           </p:cNvPr>
@@ -8596,7 +8596,7 @@
     </p:spTree>
     <p:extLst>
       <p:ext uri="{BB962C8B-B14F-4D97-AF65-F5344CB8AC3E}">
-        <p14:creationId xmlns:p14="http://schemas.microsoft.com/office/powerpoint/2010/main" val="1596385444"/>
+        <p14:creationId xmlns:p14="http://schemas.microsoft.com/office/powerpoint/2010/main" val="1705439231"/>
       </p:ext>
     </p:extLst>
   </p:cSld>
@@ -8627,7 +8627,7 @@
           <p:cNvPr id="13" name="">
             <a:extLst xmlns:a="http://schemas.openxmlformats.org/drawingml/2006/main">
               <a:ext uri="{FF2B5EF4-FFF2-40B4-BE49-F238E27FC236}">
-                <a16:creationId xmlns:a16="http://schemas.microsoft.com/office/drawing/2014/main" id="{10104FAE-6770-416D-ABE6-B16C82813830}"/>
+                <a16:creationId xmlns:a16="http://schemas.microsoft.com/office/drawing/2014/main" id="{415162EE-26E8-4F99-9BA4-AD5B7903437C}"/>
               </a:ext>
             </a:extLst>
           </p:cNvPr>
@@ -8693,7 +8693,7 @@
           <p:cNvPr id="2" name="">
             <a:extLst xmlns:a="http://schemas.openxmlformats.org/drawingml/2006/main">
               <a:ext uri="{FF2B5EF4-FFF2-40B4-BE49-F238E27FC236}">
-                <a16:creationId xmlns:a16="http://schemas.microsoft.com/office/drawing/2014/main" id="{8A23B7A8-77D4-46FE-B4B6-52C9116FCE16}"/>
+                <a16:creationId xmlns:a16="http://schemas.microsoft.com/office/drawing/2014/main" id="{D3E2F58C-3C43-4D7F-B6A2-590411185BC4}"/>
               </a:ext>
             </a:extLst>
           </p:cNvPr>
@@ -8759,7 +8759,7 @@
           <p:cNvPr id="3" name="">
             <a:extLst xmlns:a="http://schemas.openxmlformats.org/drawingml/2006/main">
               <a:ext uri="{FF2B5EF4-FFF2-40B4-BE49-F238E27FC236}">
-                <a16:creationId xmlns:a16="http://schemas.microsoft.com/office/drawing/2014/main" id="{6D79A7A5-ACDF-4FB0-B1AD-4FFD3203CFD1}"/>
+                <a16:creationId xmlns:a16="http://schemas.microsoft.com/office/drawing/2014/main" id="{F041727C-B7A5-4120-B852-92FB533B8604}"/>
               </a:ext>
             </a:extLst>
           </p:cNvPr>
@@ -8789,7 +8789,7 @@
           <p:cNvPr id="4" name="">
             <a:extLst xmlns:a="http://schemas.openxmlformats.org/drawingml/2006/main">
               <a:ext uri="{FF2B5EF4-FFF2-40B4-BE49-F238E27FC236}">
-                <a16:creationId xmlns:a16="http://schemas.microsoft.com/office/drawing/2014/main" id="{E28B94BD-AEF7-418B-AC98-2912ACEA7FFB}"/>
+                <a16:creationId xmlns:a16="http://schemas.microsoft.com/office/drawing/2014/main" id="{A9465E80-911F-4F82-91D0-E3CD1BFA98E9}"/>
               </a:ext>
             </a:extLst>
           </p:cNvPr>
@@ -8855,7 +8855,7 @@
           <p:cNvPr id="5" name="">
             <a:extLst xmlns:a="http://schemas.openxmlformats.org/drawingml/2006/main">
               <a:ext uri="{FF2B5EF4-FFF2-40B4-BE49-F238E27FC236}">
-                <a16:creationId xmlns:a16="http://schemas.microsoft.com/office/drawing/2014/main" id="{788D2D3A-5C68-42E5-B62D-F0671257D022}"/>
+                <a16:creationId xmlns:a16="http://schemas.microsoft.com/office/drawing/2014/main" id="{AAB07E65-EFC4-4318-9425-ED4BEFCAE224}"/>
               </a:ext>
             </a:extLst>
           </p:cNvPr>
@@ -8921,7 +8921,7 @@
           <p:cNvPr id="6" name="">
             <a:extLst xmlns:a="http://schemas.openxmlformats.org/drawingml/2006/main">
               <a:ext uri="{FF2B5EF4-FFF2-40B4-BE49-F238E27FC236}">
-                <a16:creationId xmlns:a16="http://schemas.microsoft.com/office/drawing/2014/main" id="{D5B83B41-2B3A-48E1-86A0-6F236E4261A6}"/>
+                <a16:creationId xmlns:a16="http://schemas.microsoft.com/office/drawing/2014/main" id="{848F46DB-9FE5-4D4F-B5A5-727D2C779EB2}"/>
               </a:ext>
             </a:extLst>
           </p:cNvPr>
@@ -8987,7 +8987,7 @@
           <p:cNvPr id="7" name="">
             <a:extLst xmlns:a="http://schemas.openxmlformats.org/drawingml/2006/main">
               <a:ext uri="{FF2B5EF4-FFF2-40B4-BE49-F238E27FC236}">
-                <a16:creationId xmlns:a16="http://schemas.microsoft.com/office/drawing/2014/main" id="{D995C5CE-9052-4D5F-B738-60164F1CBC9D}"/>
+                <a16:creationId xmlns:a16="http://schemas.microsoft.com/office/drawing/2014/main" id="{227FA1E3-6D1F-493E-AEA2-54B25C80574A}"/>
               </a:ext>
             </a:extLst>
           </p:cNvPr>
@@ -9537,7 +9537,7 @@
           <p:cNvPr id="8" name="">
             <a:extLst xmlns:a="http://schemas.openxmlformats.org/drawingml/2006/main">
               <a:ext uri="{FF2B5EF4-FFF2-40B4-BE49-F238E27FC236}">
-                <a16:creationId xmlns:a16="http://schemas.microsoft.com/office/drawing/2014/main" id="{356BA9C2-18F1-43F0-9CB0-4E2BF1970BF3}"/>
+                <a16:creationId xmlns:a16="http://schemas.microsoft.com/office/drawing/2014/main" id="{11A22A9E-D273-4233-8590-46BBF680C18A}"/>
               </a:ext>
             </a:extLst>
           </p:cNvPr>
@@ -9603,7 +9603,7 @@
           <p:cNvPr id="9" name="">
             <a:extLst xmlns:a="http://schemas.openxmlformats.org/drawingml/2006/main">
               <a:ext uri="{FF2B5EF4-FFF2-40B4-BE49-F238E27FC236}">
-                <a16:creationId xmlns:a16="http://schemas.microsoft.com/office/drawing/2014/main" id="{621E3294-C521-48CE-9FCD-0DCD17BD1E81}"/>
+                <a16:creationId xmlns:a16="http://schemas.microsoft.com/office/drawing/2014/main" id="{0C0EDA8A-BF60-4131-ABC8-BDFAE96F775B}"/>
               </a:ext>
             </a:extLst>
           </p:cNvPr>
@@ -9692,7 +9692,7 @@
           <p:cNvPr id="10" name="">
             <a:extLst xmlns:a="http://schemas.openxmlformats.org/drawingml/2006/main">
               <a:ext uri="{FF2B5EF4-FFF2-40B4-BE49-F238E27FC236}">
-                <a16:creationId xmlns:a16="http://schemas.microsoft.com/office/drawing/2014/main" id="{D8AA8487-C5B6-49AF-9623-D139755DA742}"/>
+                <a16:creationId xmlns:a16="http://schemas.microsoft.com/office/drawing/2014/main" id="{95507A3F-E29C-41DA-A6EC-9ED2CF9421B6}"/>
               </a:ext>
             </a:extLst>
           </p:cNvPr>
@@ -9758,7 +9758,7 @@
           <p:cNvPr id="11" name="">
             <a:extLst xmlns:a="http://schemas.openxmlformats.org/drawingml/2006/main">
               <a:ext uri="{FF2B5EF4-FFF2-40B4-BE49-F238E27FC236}">
-                <a16:creationId xmlns:a16="http://schemas.microsoft.com/office/drawing/2014/main" id="{7B382292-DC26-4B00-8D2C-F8E9FA699027}"/>
+                <a16:creationId xmlns:a16="http://schemas.microsoft.com/office/drawing/2014/main" id="{6CC501F6-1D12-4571-8684-6AF8F7C57801}"/>
               </a:ext>
             </a:extLst>
           </p:cNvPr>
@@ -9824,7 +9824,7 @@
           <p:cNvPr id="12" name="">
             <a:extLst xmlns:a="http://schemas.openxmlformats.org/drawingml/2006/main">
               <a:ext uri="{FF2B5EF4-FFF2-40B4-BE49-F238E27FC236}">
-                <a16:creationId xmlns:a16="http://schemas.microsoft.com/office/drawing/2014/main" id="{B816DE86-B505-4B9D-9BAF-633E62196363}"/>
+                <a16:creationId xmlns:a16="http://schemas.microsoft.com/office/drawing/2014/main" id="{1DE07BF7-1AF5-4BB2-9FB6-42DDFA2E8502}"/>
               </a:ext>
             </a:extLst>
           </p:cNvPr>
@@ -9880,7 +9880,7 @@
                 <a:ea typeface="Arial"/>
                 <a:cs typeface="Arial"/>
               </a:rPr>
-              <a:t>Current differentiation comes from integration quality. Independent adoption is still to earn.</a:t>
+              <a:t>Reusable today: graph schema, signed revisions and SDK, CLI and MCP readers.</a:t>
             </a:r>
           </a:p>
         </p:txBody>
@@ -9888,7 +9888,7 @@
     </p:spTree>
     <p:extLst>
       <p:ext uri="{BB962C8B-B14F-4D97-AF65-F5344CB8AC3E}">
-        <p14:creationId xmlns:p14="http://schemas.microsoft.com/office/powerpoint/2010/main" val="1939341093"/>
+        <p14:creationId xmlns:p14="http://schemas.microsoft.com/office/powerpoint/2010/main" val="1573631860"/>
       </p:ext>
     </p:extLst>
   </p:cSld>
@@ -9919,7 +9919,7 @@
           <p:cNvPr id="17" name="">
             <a:extLst xmlns:a="http://schemas.openxmlformats.org/drawingml/2006/main">
               <a:ext uri="{FF2B5EF4-FFF2-40B4-BE49-F238E27FC236}">
-                <a16:creationId xmlns:a16="http://schemas.microsoft.com/office/drawing/2014/main" id="{8926EA9A-5570-4818-898B-687ABBEB9A91}"/>
+                <a16:creationId xmlns:a16="http://schemas.microsoft.com/office/drawing/2014/main" id="{365D2138-CD77-486B-93DC-5D740B49B1BD}"/>
               </a:ext>
             </a:extLst>
           </p:cNvPr>
@@ -9985,7 +9985,7 @@
           <p:cNvPr id="2" name="">
             <a:extLst xmlns:a="http://schemas.openxmlformats.org/drawingml/2006/main">
               <a:ext uri="{FF2B5EF4-FFF2-40B4-BE49-F238E27FC236}">
-                <a16:creationId xmlns:a16="http://schemas.microsoft.com/office/drawing/2014/main" id="{2A42438D-7C31-46CC-A8F3-45C57A46F563}"/>
+                <a16:creationId xmlns:a16="http://schemas.microsoft.com/office/drawing/2014/main" id="{0E27CC4D-3067-484D-A640-ABAB2909CB8E}"/>
               </a:ext>
             </a:extLst>
           </p:cNvPr>
@@ -10051,7 +10051,7 @@
           <p:cNvPr id="3" name="">
             <a:extLst xmlns:a="http://schemas.openxmlformats.org/drawingml/2006/main">
               <a:ext uri="{FF2B5EF4-FFF2-40B4-BE49-F238E27FC236}">
-                <a16:creationId xmlns:a16="http://schemas.microsoft.com/office/drawing/2014/main" id="{EEC0E259-8A97-4441-9622-ED959B477BBB}"/>
+                <a16:creationId xmlns:a16="http://schemas.microsoft.com/office/drawing/2014/main" id="{E1803C39-F960-4917-9FFB-4932C1A8C464}"/>
               </a:ext>
             </a:extLst>
           </p:cNvPr>
@@ -10081,7 +10081,7 @@
           <p:cNvPr id="4" name="">
             <a:extLst xmlns:a="http://schemas.openxmlformats.org/drawingml/2006/main">
               <a:ext uri="{FF2B5EF4-FFF2-40B4-BE49-F238E27FC236}">
-                <a16:creationId xmlns:a16="http://schemas.microsoft.com/office/drawing/2014/main" id="{62950DF8-38A4-48D9-8199-D7C684CBED94}"/>
+                <a16:creationId xmlns:a16="http://schemas.microsoft.com/office/drawing/2014/main" id="{6C44E84A-8CEF-440C-89EA-DA437D3FB840}"/>
               </a:ext>
             </a:extLst>
           </p:cNvPr>
@@ -10147,7 +10147,7 @@
           <p:cNvPr id="5" name="">
             <a:extLst xmlns:a="http://schemas.openxmlformats.org/drawingml/2006/main">
               <a:ext uri="{FF2B5EF4-FFF2-40B4-BE49-F238E27FC236}">
-                <a16:creationId xmlns:a16="http://schemas.microsoft.com/office/drawing/2014/main" id="{94694185-8EC8-4E45-BED5-C4EA177C7841}"/>
+                <a16:creationId xmlns:a16="http://schemas.microsoft.com/office/drawing/2014/main" id="{CE111719-5ED4-48BE-8AF3-A67523B69737}"/>
               </a:ext>
             </a:extLst>
           </p:cNvPr>
@@ -10213,7 +10213,7 @@
           <p:cNvPr id="6" name="">
             <a:extLst xmlns:a="http://schemas.openxmlformats.org/drawingml/2006/main">
               <a:ext uri="{FF2B5EF4-FFF2-40B4-BE49-F238E27FC236}">
-                <a16:creationId xmlns:a16="http://schemas.microsoft.com/office/drawing/2014/main" id="{98D0B19A-7CCF-4A16-88E6-02198D746DDA}"/>
+                <a16:creationId xmlns:a16="http://schemas.microsoft.com/office/drawing/2014/main" id="{01482E4F-0756-49D6-8E7C-D36217E07D76}"/>
               </a:ext>
             </a:extLst>
           </p:cNvPr>
@@ -10279,7 +10279,7 @@
           <p:cNvPr id="7" name="">
             <a:extLst xmlns:a="http://schemas.openxmlformats.org/drawingml/2006/main">
               <a:ext uri="{FF2B5EF4-FFF2-40B4-BE49-F238E27FC236}">
-                <a16:creationId xmlns:a16="http://schemas.microsoft.com/office/drawing/2014/main" id="{5D04D9C2-2AFD-42AA-8EE3-40D24788E5F8}"/>
+                <a16:creationId xmlns:a16="http://schemas.microsoft.com/office/drawing/2014/main" id="{44E9609A-7141-4FC7-9248-36910DFC81AB}"/>
               </a:ext>
             </a:extLst>
           </p:cNvPr>
@@ -10345,7 +10345,7 @@
           <p:cNvPr id="8" name="Chart">
             <a:extLst xmlns:a="http://schemas.openxmlformats.org/drawingml/2006/main">
               <a:ext uri="{FF2B5EF4-FFF2-40B4-BE49-F238E27FC236}">
-                <a16:creationId xmlns:a16="http://schemas.microsoft.com/office/drawing/2014/main" id="{E801544E-C197-40EE-9C32-6A8E13453B2F}"/>
+                <a16:creationId xmlns:a16="http://schemas.microsoft.com/office/drawing/2014/main" id="{F69F8EA2-9F66-4173-9578-F3A3D25017C0}"/>
               </a:ext>
             </a:extLst>
           </p:cNvPr>
@@ -10358,7 +10358,7 @@
         </p:xfrm>
         <a:graphic xmlns:a="http://schemas.openxmlformats.org/drawingml/2006/main">
           <a:graphicData uri="http://schemas.openxmlformats.org/drawingml/2006/chart">
-            <c:chart xmlns:r="http://schemas.openxmlformats.org/officeDocument/2006/relationships" xmlns:c="http://schemas.openxmlformats.org/drawingml/2006/chart" r:id="Rc4c86db34e744e65"/>
+            <c:chart xmlns:r="http://schemas.openxmlformats.org/officeDocument/2006/relationships" xmlns:c="http://schemas.openxmlformats.org/drawingml/2006/chart" r:id="R1ada30766c184f80"/>
           </a:graphicData>
         </a:graphic>
       </p:graphicFrame>
@@ -10367,7 +10367,7 @@
           <p:cNvPr id="9" name="">
             <a:extLst xmlns:a="http://schemas.openxmlformats.org/drawingml/2006/main">
               <a:ext uri="{FF2B5EF4-FFF2-40B4-BE49-F238E27FC236}">
-                <a16:creationId xmlns:a16="http://schemas.microsoft.com/office/drawing/2014/main" id="{43738BA7-5E26-41EE-A6F8-A9670FA72EA0}"/>
+                <a16:creationId xmlns:a16="http://schemas.microsoft.com/office/drawing/2014/main" id="{94A9B28A-E026-4B2D-BA44-164E9790CA7C}"/>
               </a:ext>
             </a:extLst>
           </p:cNvPr>
@@ -10456,7 +10456,7 @@
           <p:cNvPr id="10" name="">
             <a:extLst xmlns:a="http://schemas.openxmlformats.org/drawingml/2006/main">
               <a:ext uri="{FF2B5EF4-FFF2-40B4-BE49-F238E27FC236}">
-                <a16:creationId xmlns:a16="http://schemas.microsoft.com/office/drawing/2014/main" id="{5287F990-C53B-4EE0-B36C-4B3DF8BE30FA}"/>
+                <a16:creationId xmlns:a16="http://schemas.microsoft.com/office/drawing/2014/main" id="{F6386387-A0D5-410F-84B3-A2893474C779}"/>
               </a:ext>
             </a:extLst>
           </p:cNvPr>
@@ -10522,7 +10522,7 @@
           <p:cNvPr id="11" name="">
             <a:extLst xmlns:a="http://schemas.openxmlformats.org/drawingml/2006/main">
               <a:ext uri="{FF2B5EF4-FFF2-40B4-BE49-F238E27FC236}">
-                <a16:creationId xmlns:a16="http://schemas.microsoft.com/office/drawing/2014/main" id="{A94DF03A-06AB-4A7F-9C23-EBE9A79EFDB2}"/>
+                <a16:creationId xmlns:a16="http://schemas.microsoft.com/office/drawing/2014/main" id="{C0D4DC39-C875-46D2-9E48-D6E34E995276}"/>
               </a:ext>
             </a:extLst>
           </p:cNvPr>
@@ -10588,7 +10588,7 @@
           <p:cNvPr id="12" name="">
             <a:extLst xmlns:a="http://schemas.openxmlformats.org/drawingml/2006/main">
               <a:ext uri="{FF2B5EF4-FFF2-40B4-BE49-F238E27FC236}">
-                <a16:creationId xmlns:a16="http://schemas.microsoft.com/office/drawing/2014/main" id="{D0288833-88A4-4D23-9AC7-5015A010F936}"/>
+                <a16:creationId xmlns:a16="http://schemas.microsoft.com/office/drawing/2014/main" id="{D2DD7A85-983D-4494-A82E-B28BAB9328F0}"/>
               </a:ext>
             </a:extLst>
           </p:cNvPr>
@@ -10618,7 +10618,7 @@
           <p:cNvPr id="13" name="">
             <a:extLst xmlns:a="http://schemas.openxmlformats.org/drawingml/2006/main">
               <a:ext uri="{FF2B5EF4-FFF2-40B4-BE49-F238E27FC236}">
-                <a16:creationId xmlns:a16="http://schemas.microsoft.com/office/drawing/2014/main" id="{12219C17-4713-43F8-A622-652ACDC4FD41}"/>
+                <a16:creationId xmlns:a16="http://schemas.microsoft.com/office/drawing/2014/main" id="{24CCD843-D3D4-4564-BDC7-1E25515745A0}"/>
               </a:ext>
             </a:extLst>
           </p:cNvPr>
@@ -10684,7 +10684,7 @@
           <p:cNvPr id="14" name="">
             <a:extLst xmlns:a="http://schemas.openxmlformats.org/drawingml/2006/main">
               <a:ext uri="{FF2B5EF4-FFF2-40B4-BE49-F238E27FC236}">
-                <a16:creationId xmlns:a16="http://schemas.microsoft.com/office/drawing/2014/main" id="{4025F731-717F-47AF-829D-53AD9524950A}"/>
+                <a16:creationId xmlns:a16="http://schemas.microsoft.com/office/drawing/2014/main" id="{00D7D89E-36C8-4B71-964E-476EB75C3435}"/>
               </a:ext>
             </a:extLst>
           </p:cNvPr>
@@ -10773,7 +10773,7 @@
           <p:cNvPr id="15" name="">
             <a:extLst xmlns:a="http://schemas.openxmlformats.org/drawingml/2006/main">
               <a:ext uri="{FF2B5EF4-FFF2-40B4-BE49-F238E27FC236}">
-                <a16:creationId xmlns:a16="http://schemas.microsoft.com/office/drawing/2014/main" id="{6868AF58-BBD7-4444-97A9-DFB9707220DD}"/>
+                <a16:creationId xmlns:a16="http://schemas.microsoft.com/office/drawing/2014/main" id="{B2DE7132-DA31-41DC-8840-E071E0AAF1C2}"/>
               </a:ext>
             </a:extLst>
           </p:cNvPr>
@@ -10829,7 +10829,7 @@
                 <a:ea typeface="Arial"/>
                 <a:cs typeface="Arial"/>
               </a:rPr>
-              <a:t>Download statistics unavailable</a:t>
+              <a:t>Anonymous installs verified</a:t>
             </a:r>
           </a:p>
           <a:p xmlns:a="http://schemas.openxmlformats.org/drawingml/2006/main">
@@ -10852,7 +10852,7 @@
                 <a:ea typeface="Arial"/>
                 <a:cs typeface="Arial"/>
               </a:rPr>
-              <a:t>Official npm API returned HTTP 404</a:t>
+              <a:t>SDK, CLI and MCP readers</a:t>
             </a:r>
           </a:p>
         </p:txBody>
@@ -10862,7 +10862,7 @@
           <p:cNvPr id="16" name="">
             <a:extLst xmlns:a="http://schemas.openxmlformats.org/drawingml/2006/main">
               <a:ext uri="{FF2B5EF4-FFF2-40B4-BE49-F238E27FC236}">
-                <a16:creationId xmlns:a16="http://schemas.microsoft.com/office/drawing/2014/main" id="{83DD98C6-9410-47A1-B43E-73A1F9EBD264}"/>
+                <a16:creationId xmlns:a16="http://schemas.microsoft.com/office/drawing/2014/main" id="{3C6EFDA2-A360-4588-8096-D6627478646A}"/>
               </a:ext>
             </a:extLst>
           </p:cNvPr>
@@ -10918,7 +10918,7 @@
                 <a:ea typeface="Arial"/>
                 <a:cs typeface="Arial"/>
               </a:rPr>
-              <a:t>No outside user count is established.</a:t>
+              <a:t>Package integrity and read receipts are public.</a:t>
             </a:r>
           </a:p>
         </p:txBody>
@@ -10926,7 +10926,7 @@
     </p:spTree>
     <p:extLst>
       <p:ext uri="{BB962C8B-B14F-4D97-AF65-F5344CB8AC3E}">
-        <p14:creationId xmlns:p14="http://schemas.microsoft.com/office/powerpoint/2010/main" val="227464002"/>
+        <p14:creationId xmlns:p14="http://schemas.microsoft.com/office/powerpoint/2010/main" val="99962235"/>
       </p:ext>
     </p:extLst>
   </p:cSld>
@@ -10957,7 +10957,7 @@
           <p:cNvPr id="18" name="">
             <a:extLst xmlns:a="http://schemas.openxmlformats.org/drawingml/2006/main">
               <a:ext uri="{FF2B5EF4-FFF2-40B4-BE49-F238E27FC236}">
-                <a16:creationId xmlns:a16="http://schemas.microsoft.com/office/drawing/2014/main" id="{63BC7154-5B82-4053-BD63-2568AAB5D0D5}"/>
+                <a16:creationId xmlns:a16="http://schemas.microsoft.com/office/drawing/2014/main" id="{43C321BE-6B4A-4B9B-BC7E-49A15ACB1323}"/>
               </a:ext>
             </a:extLst>
           </p:cNvPr>
@@ -11023,7 +11023,7 @@
           <p:cNvPr id="2" name="">
             <a:extLst xmlns:a="http://schemas.openxmlformats.org/drawingml/2006/main">
               <a:ext uri="{FF2B5EF4-FFF2-40B4-BE49-F238E27FC236}">
-                <a16:creationId xmlns:a16="http://schemas.microsoft.com/office/drawing/2014/main" id="{148036F8-EC29-490C-80CC-B9C8AA7AEFC9}"/>
+                <a16:creationId xmlns:a16="http://schemas.microsoft.com/office/drawing/2014/main" id="{F25E3B0E-AA2A-435C-85D2-767CC1BDCE54}"/>
               </a:ext>
             </a:extLst>
           </p:cNvPr>
@@ -11089,7 +11089,7 @@
           <p:cNvPr id="3" name="">
             <a:extLst xmlns:a="http://schemas.openxmlformats.org/drawingml/2006/main">
               <a:ext uri="{FF2B5EF4-FFF2-40B4-BE49-F238E27FC236}">
-                <a16:creationId xmlns:a16="http://schemas.microsoft.com/office/drawing/2014/main" id="{DDAFCB36-0484-4F74-8BF8-D593D917DEEE}"/>
+                <a16:creationId xmlns:a16="http://schemas.microsoft.com/office/drawing/2014/main" id="{94FEB83B-3885-4678-9C5A-5BF26C99D043}"/>
               </a:ext>
             </a:extLst>
           </p:cNvPr>
@@ -11119,7 +11119,7 @@
           <p:cNvPr id="4" name="">
             <a:extLst xmlns:a="http://schemas.openxmlformats.org/drawingml/2006/main">
               <a:ext uri="{FF2B5EF4-FFF2-40B4-BE49-F238E27FC236}">
-                <a16:creationId xmlns:a16="http://schemas.microsoft.com/office/drawing/2014/main" id="{CE2B14A6-6FF5-4B58-8097-21CFAE02BECD}"/>
+                <a16:creationId xmlns:a16="http://schemas.microsoft.com/office/drawing/2014/main" id="{24FA9DBB-11BE-42EC-B384-B0A7FD733F8E}"/>
               </a:ext>
             </a:extLst>
           </p:cNvPr>
@@ -11185,7 +11185,7 @@
           <p:cNvPr id="5" name="">
             <a:extLst xmlns:a="http://schemas.openxmlformats.org/drawingml/2006/main">
               <a:ext uri="{FF2B5EF4-FFF2-40B4-BE49-F238E27FC236}">
-                <a16:creationId xmlns:a16="http://schemas.microsoft.com/office/drawing/2014/main" id="{75BC97B7-C645-413C-A977-A56295688082}"/>
+                <a16:creationId xmlns:a16="http://schemas.microsoft.com/office/drawing/2014/main" id="{1CB33658-5392-44D6-9DC2-164AA741490B}"/>
               </a:ext>
             </a:extLst>
           </p:cNvPr>
@@ -11251,7 +11251,7 @@
           <p:cNvPr id="6" name="">
             <a:extLst xmlns:a="http://schemas.openxmlformats.org/drawingml/2006/main">
               <a:ext uri="{FF2B5EF4-FFF2-40B4-BE49-F238E27FC236}">
-                <a16:creationId xmlns:a16="http://schemas.microsoft.com/office/drawing/2014/main" id="{1B953FFA-04C6-4FA7-9FF7-F92F6B7A8F43}"/>
+                <a16:creationId xmlns:a16="http://schemas.microsoft.com/office/drawing/2014/main" id="{9955FFB9-F468-4749-9F73-6E2429432A51}"/>
               </a:ext>
             </a:extLst>
           </p:cNvPr>
@@ -11317,7 +11317,7 @@
           <p:cNvPr id="7" name="">
             <a:extLst xmlns:a="http://schemas.openxmlformats.org/drawingml/2006/main">
               <a:ext uri="{FF2B5EF4-FFF2-40B4-BE49-F238E27FC236}">
-                <a16:creationId xmlns:a16="http://schemas.microsoft.com/office/drawing/2014/main" id="{DD35C85A-E59C-4B90-8EEB-C3212E8E29B5}"/>
+                <a16:creationId xmlns:a16="http://schemas.microsoft.com/office/drawing/2014/main" id="{CB99958A-DF79-41E7-9507-BAC866F8CC8E}"/>
               </a:ext>
             </a:extLst>
           </p:cNvPr>
@@ -11383,7 +11383,7 @@
           <p:cNvPr id="8" name="">
             <a:extLst xmlns:a="http://schemas.openxmlformats.org/drawingml/2006/main">
               <a:ext uri="{FF2B5EF4-FFF2-40B4-BE49-F238E27FC236}">
-                <a16:creationId xmlns:a16="http://schemas.microsoft.com/office/drawing/2014/main" id="{37EC6430-4E04-43BE-A30D-D1E9AFE1C71E}"/>
+                <a16:creationId xmlns:a16="http://schemas.microsoft.com/office/drawing/2014/main" id="{CDE6BA4E-C8B8-430E-840B-3E68A647D492}"/>
               </a:ext>
             </a:extLst>
           </p:cNvPr>
@@ -11413,7 +11413,7 @@
           <p:cNvPr id="9" name="">
             <a:extLst xmlns:a="http://schemas.openxmlformats.org/drawingml/2006/main">
               <a:ext uri="{FF2B5EF4-FFF2-40B4-BE49-F238E27FC236}">
-                <a16:creationId xmlns:a16="http://schemas.microsoft.com/office/drawing/2014/main" id="{CEC80DE2-8C9D-430B-B478-EDCCD91691C8}"/>
+                <a16:creationId xmlns:a16="http://schemas.microsoft.com/office/drawing/2014/main" id="{6BC394F7-BB26-4430-A945-7AB8C372E5F0}"/>
               </a:ext>
             </a:extLst>
           </p:cNvPr>
@@ -11502,7 +11502,7 @@
           <p:cNvPr id="10" name="">
             <a:extLst xmlns:a="http://schemas.openxmlformats.org/drawingml/2006/main">
               <a:ext uri="{FF2B5EF4-FFF2-40B4-BE49-F238E27FC236}">
-                <a16:creationId xmlns:a16="http://schemas.microsoft.com/office/drawing/2014/main" id="{11C89E40-3AB9-467A-A4D5-CDCF76DA1C4C}"/>
+                <a16:creationId xmlns:a16="http://schemas.microsoft.com/office/drawing/2014/main" id="{AEC91485-87A4-47A1-8D12-061547951220}"/>
               </a:ext>
             </a:extLst>
           </p:cNvPr>
@@ -11568,7 +11568,7 @@
           <p:cNvPr id="11" name="">
             <a:extLst xmlns:a="http://schemas.openxmlformats.org/drawingml/2006/main">
               <a:ext uri="{FF2B5EF4-FFF2-40B4-BE49-F238E27FC236}">
-                <a16:creationId xmlns:a16="http://schemas.microsoft.com/office/drawing/2014/main" id="{99FF3867-5A52-433A-BB32-004713CD5211}"/>
+                <a16:creationId xmlns:a16="http://schemas.microsoft.com/office/drawing/2014/main" id="{76277A54-9540-44FD-80DE-DCDE1696EF6D}"/>
               </a:ext>
             </a:extLst>
           </p:cNvPr>
@@ -11634,7 +11634,7 @@
           <p:cNvPr id="12" name="">
             <a:extLst xmlns:a="http://schemas.openxmlformats.org/drawingml/2006/main">
               <a:ext uri="{FF2B5EF4-FFF2-40B4-BE49-F238E27FC236}">
-                <a16:creationId xmlns:a16="http://schemas.microsoft.com/office/drawing/2014/main" id="{15F7415C-C8B3-4864-B04C-2A667123C40F}"/>
+                <a16:creationId xmlns:a16="http://schemas.microsoft.com/office/drawing/2014/main" id="{DF319949-E23B-445B-AD61-E9519EA1F69B}"/>
               </a:ext>
             </a:extLst>
           </p:cNvPr>
@@ -11700,7 +11700,7 @@
           <p:cNvPr id="13" name="">
             <a:extLst xmlns:a="http://schemas.openxmlformats.org/drawingml/2006/main">
               <a:ext uri="{FF2B5EF4-FFF2-40B4-BE49-F238E27FC236}">
-                <a16:creationId xmlns:a16="http://schemas.microsoft.com/office/drawing/2014/main" id="{99211EB2-A6AF-41F5-B772-074F461F69B4}"/>
+                <a16:creationId xmlns:a16="http://schemas.microsoft.com/office/drawing/2014/main" id="{F8B3A820-20A4-448C-A107-ED5D166AA27F}"/>
               </a:ext>
             </a:extLst>
           </p:cNvPr>
@@ -11766,7 +11766,7 @@
           <p:cNvPr id="14" name="">
             <a:extLst xmlns:a="http://schemas.openxmlformats.org/drawingml/2006/main">
               <a:ext uri="{FF2B5EF4-FFF2-40B4-BE49-F238E27FC236}">
-                <a16:creationId xmlns:a16="http://schemas.microsoft.com/office/drawing/2014/main" id="{98F3BD72-F8A8-46E0-A794-674494B1FBB9}"/>
+                <a16:creationId xmlns:a16="http://schemas.microsoft.com/office/drawing/2014/main" id="{72DB36E1-6664-4F6B-A7C2-D1DCB269918C}"/>
               </a:ext>
             </a:extLst>
           </p:cNvPr>
@@ -11822,7 +11822,7 @@
                 <a:ea typeface="Georgia"/>
                 <a:cs typeface="Georgia"/>
               </a:rPr>
-              <a:t>What I would validate next</a:t>
+              <a:t>Build with the SDK</a:t>
             </a:r>
           </a:p>
         </p:txBody>
@@ -11832,7 +11832,7 @@
           <p:cNvPr id="15" name="">
             <a:extLst xmlns:a="http://schemas.openxmlformats.org/drawingml/2006/main">
               <a:ext uri="{FF2B5EF4-FFF2-40B4-BE49-F238E27FC236}">
-                <a16:creationId xmlns:a16="http://schemas.microsoft.com/office/drawing/2014/main" id="{26E0DFC2-CE36-4860-BD4E-E9490F839E72}"/>
+                <a16:creationId xmlns:a16="http://schemas.microsoft.com/office/drawing/2014/main" id="{DA8B281C-1ED6-4298-86C2-0D037BEEFE72}"/>
               </a:ext>
             </a:extLst>
           </p:cNvPr>
@@ -11888,7 +11888,7 @@
                 <a:ea typeface="Arial"/>
                 <a:cs typeface="Arial"/>
               </a:rPr>
-              <a:t>An unaided outside integration</a:t>
+              <a:t>Publish a typed graph</a:t>
             </a:r>
           </a:p>
           <a:p xmlns:a="http://schemas.openxmlformats.org/drawingml/2006/main">
@@ -11911,7 +11911,7 @@
                 <a:ea typeface="Arial"/>
                 <a:cs typeface="Arial"/>
               </a:rPr>
-              <a:t>A second-provider strategy</a:t>
+              <a:t>Verify an accepted revision</a:t>
             </a:r>
           </a:p>
           <a:p xmlns:a="http://schemas.openxmlformats.org/drawingml/2006/main">
@@ -11934,7 +11934,7 @@
                 <a:ea typeface="Arial"/>
                 <a:cs typeface="Arial"/>
               </a:rPr>
-              <a:t>Larger graphs and real phones</a:t>
+              <a:t>Trace source-linked AI context</a:t>
             </a:r>
           </a:p>
         </p:txBody>
@@ -11944,7 +11944,7 @@
           <p:cNvPr id="16" name="">
             <a:extLst xmlns:a="http://schemas.openxmlformats.org/drawingml/2006/main">
               <a:ext uri="{FF2B5EF4-FFF2-40B4-BE49-F238E27FC236}">
-                <a16:creationId xmlns:a16="http://schemas.microsoft.com/office/drawing/2014/main" id="{CC5B82AE-035F-4E97-996A-7795C1DA886B}"/>
+                <a16:creationId xmlns:a16="http://schemas.microsoft.com/office/drawing/2014/main" id="{EA9CB8CF-7ADA-4264-8A91-C05A9557B90F}"/>
               </a:ext>
             </a:extLst>
           </p:cNvPr>
@@ -12000,7 +12000,7 @@
                 <a:ea typeface="Arial"/>
                 <a:cs typeface="Arial"/>
               </a:rPr>
-              <a:t>Current trust boundary</a:t>
+              <a:t>Reader setup</a:t>
             </a:r>
           </a:p>
         </p:txBody>
@@ -12010,7 +12010,7 @@
           <p:cNvPr id="17" name="">
             <a:extLst xmlns:a="http://schemas.openxmlformats.org/drawingml/2006/main">
               <a:ext uri="{FF2B5EF4-FFF2-40B4-BE49-F238E27FC236}">
-                <a16:creationId xmlns:a16="http://schemas.microsoft.com/office/drawing/2014/main" id="{CB8684B4-4E53-4B16-A927-97AD1141AFC6}"/>
+                <a16:creationId xmlns:a16="http://schemas.microsoft.com/office/drawing/2014/main" id="{AB7C8424-AF46-478D-BC6C-5DE9A1AB07EB}"/>
               </a:ext>
             </a:extLst>
           </p:cNvPr>
@@ -12066,7 +12066,7 @@
                 <a:ea typeface="Arial"/>
                 <a:cs typeface="Arial"/>
               </a:rPr>
-              <a:t>Fresh readers still rely on RPC</a:t>
+              <a:t>Pin accepted publishers.</a:t>
             </a:r>
           </a:p>
           <a:p xmlns:a="http://schemas.openxmlformats.org/drawingml/2006/main">
@@ -12089,7 +12089,7 @@
                 <a:ea typeface="Arial"/>
                 <a:cs typeface="Arial"/>
               </a:rPr>
-              <a:t>metadata and unseen-history</a:t>
+              <a:t>Choose an Arkiv RPC provider.</a:t>
             </a:r>
           </a:p>
           <a:p xmlns:a="http://schemas.openxmlformats.org/drawingml/2006/main">
@@ -12112,7 +12112,7 @@
                 <a:ea typeface="Arial"/>
                 <a:cs typeface="Arial"/>
               </a:rPr>
-              <a:t>completeness.</a:t>
+              <a:t>Keep verified checkpoints.</a:t>
             </a:r>
           </a:p>
         </p:txBody>
@@ -12120,7 +12120,7 @@
     </p:spTree>
     <p:extLst>
       <p:ext uri="{BB962C8B-B14F-4D97-AF65-F5344CB8AC3E}">
-        <p14:creationId xmlns:p14="http://schemas.microsoft.com/office/powerpoint/2010/main" val="915463824"/>
+        <p14:creationId xmlns:p14="http://schemas.microsoft.com/office/powerpoint/2010/main" val="216004265"/>
       </p:ext>
     </p:extLst>
   </p:cSld>

</xml_diff>